<commit_message>
cập nhật slide Pain Point & JTBD theo 2 nhóm nhu cầu, bổ sung slide đánh giá concept hiện tại
Tách Slide 5 cũ (3 nhóm nhu cầu dạng bảng) thành Slide 5-6 theo đúng 7 JTBD
đã thống nhất (Nhóm I: Tiếng Anh, Nhóm II: Toàn diện), thêm Slide 7 đối
chiếu concept hiện tại với các JTBD đó. Đồng bộ nội dung vào bản pptx
branded bằng chỉnh sửa OOXML trực tiếp — chưa mở kiểm tra trực quan trong
PowerPoint, cần xem lại trước khi trình bày 27/08.

Co-Authored-By: Claude Sonnet 5 <noreply@anthropic.com>
</commit_message>
<xml_diff>
--- a/03_product/concepts/AI-Class-New-slide-deck-FINAL-2026-08-21-branded.pptx
+++ b/03_product/concepts/AI-Class-New-slide-deck-FINAL-2026-08-21-branded.pptx
@@ -10,6 +10,8 @@
     <p:sldId id="258" r:id="rId4"/>
     <p:sldId id="268" r:id="rId19"/>
     <p:sldId id="269" r:id="rId20"/>
+    <p:sldId id="270" r:id="rId21"/>
+    <p:sldId id="271" r:id="rId22"/>
     <p:sldId id="260" r:id="rId6"/>
     <p:sldId id="261" r:id="rId7"/>
     <p:sldId id="262" r:id="rId8"/>
@@ -2585,7 +2587,7 @@
                 <a:ea typeface="Noto Sans" pitchFamily="34" charset="-122"/>
                 <a:cs typeface="Noto Sans" pitchFamily="34" charset="-120"/>
               </a:rPr>
-              <a:t>10 / 12</a:t>
+              <a:t>12 / 14</a:t>
             </a:r>
             <a:endParaRPr lang="en-US" sz="850" dirty="0"/>
           </a:p>
@@ -3975,7 +3977,7 @@
                 <a:ea typeface="Noto Sans" pitchFamily="34" charset="-122"/>
                 <a:cs typeface="Noto Sans" pitchFamily="34" charset="-120"/>
               </a:rPr>
-              <a:t>11 / 12</a:t>
+              <a:t>13 / 14</a:t>
             </a:r>
             <a:endParaRPr lang="en-US" sz="850" dirty="0"/>
           </a:p>
@@ -6658,7 +6660,7 @@
                 <a:ea typeface="Noto Sans" pitchFamily="34" charset="-122"/>
                 <a:cs typeface="Noto Sans" pitchFamily="34" charset="-120"/>
               </a:rPr>
-              <a:t>12 / 12</a:t>
+              <a:t>14 / 14</a:t>
             </a:r>
             <a:endParaRPr lang="en-US" sz="850" dirty="0"/>
           </a:p>
@@ -7904,7 +7906,7 @@
                 <a:ea typeface="Noto Sans" pitchFamily="34" charset="-122"/>
                 <a:cs typeface="Noto Sans" pitchFamily="34" charset="-120"/>
               </a:rPr>
-              <a:t>3 / 12</a:t>
+              <a:t>3 / 14</a:t>
             </a:r>
             <a:endParaRPr lang="en-US" sz="850" dirty="0"/>
           </a:p>
@@ -7920,7 +7922,7 @@
 
 <file path=ppt/slides/slide14.xml><?xml version="1.0" encoding="utf-8"?>
 <p:sld xmlns:a="http://schemas.openxmlformats.org/drawingml/2006/main" xmlns:r="http://schemas.openxmlformats.org/officeDocument/2006/relationships" xmlns:p="http://schemas.openxmlformats.org/presentationml/2006/main">
-  <p:cSld name="Slide 14">
+  <p:cSld name="Slide 8">
     <p:bg>
       <p:bgPr>
         <a:solidFill>
@@ -7944,9 +7946,11 @@
       </p:grpSpPr>
       <p:sp>
         <p:nvSpPr>
-          <p:cNvPr id="2" name="Text 0"/>
-          <p:cNvSpPr/>
-          <p:nvPr/>
+          <p:cNvPr id="2" name="Text 0">
+</p:cNvPr>
+          <p:cNvSpPr/>
+          <p:nvPr>
+</p:nvPr>
         </p:nvSpPr>
         <p:spPr>
           <a:xfrm>
@@ -7954,13 +7958,16 @@
             <a:ext cx="11183112" cy="274320"/>
           </a:xfrm>
           <a:prstGeom prst="rect">
-            <a:avLst/>
+            <a:avLst>
+</a:avLst>
           </a:prstGeom>
           <a:noFill/>
-          <a:ln/>
+          <a:ln>
+</a:ln>
         </p:spPr>
         <p:txBody>
-          <a:bodyPr wrap="square" rtlCol="0" anchor="ctr"/>
+          <a:bodyPr wrap="square" rtlCol="0" anchor="ctr">
+</a:bodyPr>
           <a:lstStyle/>
           <a:p>
             <a:pPr indent="0" marL="0">
@@ -7983,9 +7990,11 @@
       </p:sp>
       <p:sp>
         <p:nvSpPr>
-          <p:cNvPr id="3" name="Text 1"/>
-          <p:cNvSpPr/>
-          <p:nvPr/>
+          <p:cNvPr id="3" name="Text 1">
+</p:cNvPr>
+          <p:cNvSpPr/>
+          <p:nvPr>
+</p:nvPr>
         </p:nvSpPr>
         <p:spPr>
           <a:xfrm>
@@ -7993,13 +8002,16 @@
             <a:ext cx="10085832" cy="640080"/>
           </a:xfrm>
           <a:prstGeom prst="rect">
-            <a:avLst/>
+            <a:avLst>
+</a:avLst>
           </a:prstGeom>
           <a:noFill/>
-          <a:ln/>
+          <a:ln>
+</a:ln>
         </p:spPr>
         <p:txBody>
-          <a:bodyPr wrap="square" rtlCol="0" anchor="ctr"/>
+          <a:bodyPr wrap="square" rtlCol="0" anchor="ctr">
+</a:bodyPr>
           <a:lstStyle/>
           <a:p>
             <a:pPr indent="0" marL="0">
@@ -8022,9 +8034,11 @@
       </p:sp>
       <p:sp>
         <p:nvSpPr>
-          <p:cNvPr id="4" name="Shape 2"/>
-          <p:cNvSpPr/>
-          <p:nvPr/>
+          <p:cNvPr id="4" name="Shape 2">
+</p:cNvPr>
+          <p:cNvSpPr/>
+          <p:nvPr>
+</p:nvPr>
         </p:nvSpPr>
         <p:spPr>
           <a:xfrm>
@@ -8032,24 +8046,28 @@
             <a:ext cx="777240" cy="45720"/>
           </a:xfrm>
           <a:prstGeom prst="rect">
-            <a:avLst/>
+            <a:avLst>
+</a:avLst>
           </a:prstGeom>
           <a:solidFill>
             <a:srgbClr val="A5BE00"/>
           </a:solidFill>
-          <a:ln/>
+          <a:ln>
+</a:ln>
         </p:spPr>
       </p:sp>
       <p:pic>
         <p:nvPicPr>
-          <p:cNvPr id="5" name="Image 0"/>
+          <p:cNvPr id="5" name="Image 0" descr="C:\Users\landa\AppData\Local\Temp\claude\c--Users-landa--Personal--D---n-AI-Class-new\8a85e8a7-bdeb-42d6-9168-79c96b849bd1\scratchpad\pptx-gen\logo-icon-only.png">    </p:cNvPr>
           <p:cNvPicPr>
             <a:picLocks noChangeAspect="1"/>
           </p:cNvPicPr>
-          <p:nvPr/>
+          <p:nvPr>
+</p:nvPr>
         </p:nvPicPr>
         <p:blipFill>
-          <a:blip r:embed="rId1"/>
+          <a:blip r:embed="rId1">
+</a:blip>
           <a:stretch>
             <a:fillRect/>
           </a:stretch>
@@ -8064,6 +8082,1708 @@
           </a:prstGeom>
         </p:spPr>
       </p:pic>
+      <p:sp>
+        <p:nvSpPr>
+          <p:cNvPr id="6" name="Text 3">
+</p:cNvPr>
+          <p:cNvSpPr/>
+          <p:nvPr>
+</p:nvPr>
+        </p:nvSpPr>
+        <p:spPr>
+          <a:xfrm>
+            <a:off x="502920" y="1280160"/>
+            <a:ext cx="11183112" cy="384048"/>
+          </a:xfrm>
+          <a:prstGeom prst="rect">
+            <a:avLst>
+</a:avLst>
+          </a:prstGeom>
+          <a:noFill/>
+          <a:ln>
+</a:ln>
+        </p:spPr>
+        <p:txBody>
+          <a:bodyPr wrap="square" rtlCol="0" anchor="ctr">
+</a:bodyPr>
+          <a:lstStyle/>
+          <a:p>
+            <a:pPr indent="0" marL="0">
+              <a:buNone/>
+            </a:pPr>
+            <a:r>
+              <a:rPr lang="en-US" sz="1050" i="1" dirty="0">
+                <a:solidFill>
+                  <a:srgbClr val="5B6472"/>
+                </a:solidFill>
+                <a:latin typeface="Noto Sans" pitchFamily="34" charset="0"/>
+                <a:ea typeface="Noto Sans" pitchFamily="34" charset="-122"/>
+                <a:cs typeface="Noto Sans" pitchFamily="34" charset="-120"/>
+              </a:rPr>
+              <a:t>Nhóm I — Đầu tư mạnh phát triển năng lực Tiếng Anh</a:t>
+            </a:r>
+            <a:endParaRPr lang="en-US" sz="1050" dirty="0"/>
+          </a:p>
+        </p:txBody>
+      </p:sp>
+      <p:sp>
+        <p:nvSpPr>
+          <p:cNvPr id="7" name="Shape 4">
+</p:cNvPr>
+          <p:cNvSpPr/>
+          <p:nvPr>
+</p:nvPr>
+        </p:nvSpPr>
+        <p:spPr>
+          <a:xfrm>
+            <a:off x="502920" y="1664208"/>
+            <a:ext cx="73152" cy="1100000"/>
+          </a:xfrm>
+          <a:prstGeom prst="rect">
+            <a:avLst>
+</a:avLst>
+          </a:prstGeom>
+          <a:solidFill>
+            <a:srgbClr val="004671"/>
+          </a:solidFill>
+          <a:ln>
+</a:ln>
+        </p:spPr>
+      </p:sp>
+      <p:sp>
+        <p:nvSpPr>
+          <p:cNvPr id="8" name="Text 5">
+</p:cNvPr>
+          <p:cNvSpPr/>
+          <p:nvPr>
+</p:nvPr>
+        </p:nvSpPr>
+        <p:spPr>
+          <a:xfrm>
+            <a:off x="731520" y="1664208"/>
+            <a:ext cx="10954512" cy="1100000"/>
+          </a:xfrm>
+          <a:prstGeom prst="rect">
+            <a:avLst>
+</a:avLst>
+          </a:prstGeom>
+          <a:noFill/>
+          <a:ln>
+</a:ln>
+        </p:spPr>
+        <p:txBody>
+          <a:bodyPr wrap="square" rtlCol="0" anchor="t">
+            <a:normAutofit/>
+          </a:bodyPr>
+          <a:lstStyle/>
+          <a:p>
+            <a:pPr indent="0" marL="0">
+              <a:lnSpc>
+                <a:spcPct val="102000"/>
+              </a:lnSpc>
+              <a:spcAft>
+                <a:spcPts val="200"/>
+              </a:spcAft>
+              <a:buNone/>
+            </a:pPr>
+            <a:r>
+              <a:rPr lang="en-US" sz="1300" b="1" dirty="0">
+                <a:solidFill>
+                  <a:srgbClr val="004671"/>
+                </a:solidFill>
+                <a:latin typeface="Noto Sans" pitchFamily="34" charset="0"/>
+                <a:ea typeface="Noto Sans" pitchFamily="34" charset="-122"/>
+                <a:cs typeface="Noto Sans" pitchFamily="34" charset="-120"/>
+              </a:rPr>
+              <a:t>JTBD 1: Đạt thành tích học thuật rõ ràng, đo lường được về Tiếng Anh</a:t>
+            </a:r>
+            <a:endParaRPr lang="en-US" sz="1300" dirty="0"/>
+          </a:p>
+          <a:p>
+            <a:pPr indent="0" marL="0">
+              <a:lnSpc>
+                <a:spcPct val="102000"/>
+              </a:lnSpc>
+              <a:spcAft>
+                <a:spcPts val="300"/>
+              </a:spcAft>
+              <a:buNone/>
+            </a:pPr>
+            <a:r>
+              <a:rPr lang="en-US" sz="1100" b="1" dirty="0">
+                <a:solidFill>
+                  <a:srgbClr val="22333F"/>
+                </a:solidFill>
+                <a:latin typeface="Noto Sans" pitchFamily="34" charset="0"/>
+                <a:ea typeface="Noto Sans" pitchFamily="34" charset="-122"/>
+                <a:cs typeface="Noto Sans" pitchFamily="34" charset="-120"/>
+              </a:rPr>
+              <a:t>Mục tiêu: </a:t>
+            </a:r>
+            <a:r>
+              <a:rPr lang="en-US" sz="1100" dirty="0">
+                <a:solidFill>
+                  <a:srgbClr val="22333F"/>
+                </a:solidFill>
+                <a:latin typeface="Noto Sans" pitchFamily="34" charset="0"/>
+                <a:ea typeface="Noto Sans" pitchFamily="34" charset="-122"/>
+                <a:cs typeface="Noto Sans" pitchFamily="34" charset="-120"/>
+              </a:rPr>
+              <a:t>Con đạt điểm cao tiếng Anh trên trường và thi đạt các chứng chỉ theo lộ trình — bằng chứng cụ thể cho hiệu quả đầu tư.</a:t>
+            </a:r>
+            <a:endParaRPr lang="en-US" sz="1300" dirty="0"/>
+          </a:p>
+          <a:p>
+            <a:pPr indent="0" marL="0">
+              <a:lnSpc>
+                <a:spcPct val="102000"/>
+              </a:lnSpc>
+              <a:spcAft>
+                <a:spcPts val="300"/>
+              </a:spcAft>
+              <a:buNone/>
+            </a:pPr>
+            <a:r>
+              <a:rPr lang="en-US" sz="1100" b="1" dirty="0">
+                <a:solidFill>
+                  <a:srgbClr val="22333F"/>
+                </a:solidFill>
+                <a:latin typeface="Noto Sans" pitchFamily="34" charset="0"/>
+                <a:ea typeface="Noto Sans" pitchFamily="34" charset="-122"/>
+                <a:cs typeface="Noto Sans" pitchFamily="34" charset="-120"/>
+              </a:rPr>
+              <a:t>Pain point: </a:t>
+            </a:r>
+            <a:r>
+              <a:rPr lang="en-US" sz="1100" dirty="0">
+                <a:solidFill>
+                  <a:srgbClr val="22333F"/>
+                </a:solidFill>
+                <a:latin typeface="Noto Sans" pitchFamily="34" charset="0"/>
+                <a:ea typeface="Noto Sans" pitchFamily="34" charset="-122"/>
+                <a:cs typeface="Noto Sans" pitchFamily="34" charset="-120"/>
+              </a:rPr>
+              <a:t>Con học tiếng Anh chưa tốt/tiến bộ chậm — phát âm sai, giỏi ngữ pháp nhưng không tự tin khi giao tiếp.</a:t>
+            </a:r>
+            <a:endParaRPr lang="en-US" sz="1300" dirty="0"/>
+          </a:p>
+        </p:txBody>
+      </p:sp>
+      <p:sp>
+        <p:nvSpPr>
+          <p:cNvPr id="9" name="Shape 6">
+</p:cNvPr>
+          <p:cNvSpPr/>
+          <p:nvPr>
+</p:nvPr>
+        </p:nvSpPr>
+        <p:spPr>
+          <a:xfrm>
+            <a:off x="502920" y="2900789"/>
+            <a:ext cx="73152" cy="1100000"/>
+          </a:xfrm>
+          <a:prstGeom prst="rect">
+            <a:avLst>
+</a:avLst>
+          </a:prstGeom>
+          <a:solidFill>
+            <a:srgbClr val="3B81B1"/>
+          </a:solidFill>
+          <a:ln>
+</a:ln>
+        </p:spPr>
+      </p:sp>
+      <p:sp>
+        <p:nvSpPr>
+          <p:cNvPr id="10" name="Text 7">
+</p:cNvPr>
+          <p:cNvSpPr/>
+          <p:nvPr>
+</p:nvPr>
+        </p:nvSpPr>
+        <p:spPr>
+          <a:xfrm>
+            <a:off x="731520" y="2900789"/>
+            <a:ext cx="10954512" cy="1100000"/>
+          </a:xfrm>
+          <a:prstGeom prst="rect">
+            <a:avLst>
+</a:avLst>
+          </a:prstGeom>
+          <a:noFill/>
+          <a:ln>
+</a:ln>
+        </p:spPr>
+        <p:txBody>
+          <a:bodyPr wrap="square" rtlCol="0" anchor="t">
+            <a:normAutofit/>
+          </a:bodyPr>
+          <a:lstStyle/>
+          <a:p>
+            <a:pPr indent="0" marL="0">
+              <a:lnSpc>
+                <a:spcPct val="102000"/>
+              </a:lnSpc>
+              <a:spcAft>
+                <a:spcPts val="200"/>
+              </a:spcAft>
+              <a:buNone/>
+            </a:pPr>
+            <a:r>
+              <a:rPr lang="en-US" sz="1300" b="1" dirty="0">
+                <a:solidFill>
+                  <a:srgbClr val="004671"/>
+                </a:solidFill>
+                <a:latin typeface="Noto Sans" pitchFamily="34" charset="0"/>
+                <a:ea typeface="Noto Sans" pitchFamily="34" charset="-122"/>
+                <a:cs typeface="Noto Sans" pitchFamily="34" charset="-120"/>
+              </a:rPr>
+              <a:t>JTBD 2: Tự tin giao tiếp bằng tiếng Anh trong thực tế</a:t>
+            </a:r>
+            <a:endParaRPr lang="en-US" sz="1300" dirty="0"/>
+          </a:p>
+          <a:p>
+            <a:pPr indent="0" marL="0">
+              <a:lnSpc>
+                <a:spcPct val="102000"/>
+              </a:lnSpc>
+              <a:spcAft>
+                <a:spcPts val="300"/>
+              </a:spcAft>
+              <a:buNone/>
+            </a:pPr>
+            <a:r>
+              <a:rPr lang="en-US" sz="1100" b="1" dirty="0">
+                <a:solidFill>
+                  <a:srgbClr val="22333F"/>
+                </a:solidFill>
+                <a:latin typeface="Noto Sans" pitchFamily="34" charset="0"/>
+                <a:ea typeface="Noto Sans" pitchFamily="34" charset="-122"/>
+                <a:cs typeface="Noto Sans" pitchFamily="34" charset="-120"/>
+              </a:rPr>
+              <a:t>Mục tiêu: </a:t>
+            </a:r>
+            <a:r>
+              <a:rPr lang="en-US" sz="1100" dirty="0">
+                <a:solidFill>
+                  <a:srgbClr val="22333F"/>
+                </a:solidFill>
+                <a:latin typeface="Noto Sans" pitchFamily="34" charset="0"/>
+                <a:ea typeface="Noto Sans" pitchFamily="34" charset="-122"/>
+                <a:cs typeface="Noto Sans" pitchFamily="34" charset="-120"/>
+              </a:rPr>
+              <a:t>Con nghe – nói được, dạn dĩ khi dùng tiếng Anh ngoài đời — không chỉ giỏi trên giấy.</a:t>
+            </a:r>
+            <a:endParaRPr lang="en-US" sz="1300" dirty="0"/>
+          </a:p>
+          <a:p>
+            <a:pPr indent="0" marL="0">
+              <a:lnSpc>
+                <a:spcPct val="102000"/>
+              </a:lnSpc>
+              <a:spcAft>
+                <a:spcPts val="300"/>
+              </a:spcAft>
+              <a:buNone/>
+            </a:pPr>
+            <a:r>
+              <a:rPr lang="en-US" sz="1100" b="1" dirty="0">
+                <a:solidFill>
+                  <a:srgbClr val="22333F"/>
+                </a:solidFill>
+                <a:latin typeface="Noto Sans" pitchFamily="34" charset="0"/>
+                <a:ea typeface="Noto Sans" pitchFamily="34" charset="-122"/>
+                <a:cs typeface="Noto Sans" pitchFamily="34" charset="-120"/>
+              </a:rPr>
+              <a:t>Pain point: </a:t>
+            </a:r>
+            <a:r>
+              <a:rPr lang="en-US" sz="1100" dirty="0">
+                <a:solidFill>
+                  <a:srgbClr val="22333F"/>
+                </a:solidFill>
+                <a:latin typeface="Noto Sans" pitchFamily="34" charset="0"/>
+                <a:ea typeface="Noto Sans" pitchFamily="34" charset="-122"/>
+                <a:cs typeface="Noto Sans" pitchFamily="34" charset="-120"/>
+              </a:rPr>
+              <a:t>Phát âm sai, giỏi ngữ pháp nhưng chưa tự tin khi giao tiếp thực tế — cùng gốc pain point với JTBD 1, khác khía cạnh ứng dụng.</a:t>
+            </a:r>
+            <a:endParaRPr lang="en-US" sz="1300" dirty="0"/>
+          </a:p>
+        </p:txBody>
+      </p:sp>
+      <p:sp>
+        <p:nvSpPr>
+          <p:cNvPr id="11" name="Shape 8">
+</p:cNvPr>
+          <p:cNvSpPr/>
+          <p:nvPr>
+</p:nvPr>
+        </p:nvSpPr>
+        <p:spPr>
+          <a:xfrm>
+            <a:off x="502920" y="4137370"/>
+            <a:ext cx="73152" cy="1100000"/>
+          </a:xfrm>
+          <a:prstGeom prst="rect">
+            <a:avLst>
+</a:avLst>
+          </a:prstGeom>
+          <a:solidFill>
+            <a:srgbClr val="518E0D"/>
+          </a:solidFill>
+          <a:ln>
+</a:ln>
+        </p:spPr>
+      </p:sp>
+      <p:sp>
+        <p:nvSpPr>
+          <p:cNvPr id="12" name="Text 9">
+</p:cNvPr>
+          <p:cNvSpPr/>
+          <p:nvPr>
+</p:nvPr>
+        </p:nvSpPr>
+        <p:spPr>
+          <a:xfrm>
+            <a:off x="731520" y="4137370"/>
+            <a:ext cx="10954512" cy="1100000"/>
+          </a:xfrm>
+          <a:prstGeom prst="rect">
+            <a:avLst>
+</a:avLst>
+          </a:prstGeom>
+          <a:noFill/>
+          <a:ln>
+</a:ln>
+        </p:spPr>
+        <p:txBody>
+          <a:bodyPr wrap="square" rtlCol="0" anchor="t">
+            <a:normAutofit/>
+          </a:bodyPr>
+          <a:lstStyle/>
+          <a:p>
+            <a:pPr indent="0" marL="0">
+              <a:lnSpc>
+                <a:spcPct val="102000"/>
+              </a:lnSpc>
+              <a:spcAft>
+                <a:spcPts val="200"/>
+              </a:spcAft>
+              <a:buNone/>
+            </a:pPr>
+            <a:r>
+              <a:rPr lang="en-US" sz="1300" b="1" dirty="0">
+                <a:solidFill>
+                  <a:srgbClr val="004671"/>
+                </a:solidFill>
+                <a:latin typeface="Noto Sans" pitchFamily="34" charset="0"/>
+                <a:ea typeface="Noto Sans" pitchFamily="34" charset="-122"/>
+                <a:cs typeface="Noto Sans" pitchFamily="34" charset="-120"/>
+              </a:rPr>
+              <a:t>JTBD 3: Nuôi dưỡng sự yêu thích và tự giác học</a:t>
+            </a:r>
+            <a:endParaRPr lang="en-US" sz="1300" dirty="0"/>
+          </a:p>
+          <a:p>
+            <a:pPr indent="0" marL="0">
+              <a:lnSpc>
+                <a:spcPct val="102000"/>
+              </a:lnSpc>
+              <a:spcAft>
+                <a:spcPts val="300"/>
+              </a:spcAft>
+              <a:buNone/>
+            </a:pPr>
+            <a:r>
+              <a:rPr lang="en-US" sz="1100" b="1" dirty="0">
+                <a:solidFill>
+                  <a:srgbClr val="22333F"/>
+                </a:solidFill>
+                <a:latin typeface="Noto Sans" pitchFamily="34" charset="0"/>
+                <a:ea typeface="Noto Sans" pitchFamily="34" charset="-122"/>
+                <a:cs typeface="Noto Sans" pitchFamily="34" charset="-120"/>
+              </a:rPr>
+              <a:t>Mục tiêu: </a:t>
+            </a:r>
+            <a:r>
+              <a:rPr lang="en-US" sz="1100" dirty="0">
+                <a:solidFill>
+                  <a:srgbClr val="22333F"/>
+                </a:solidFill>
+                <a:latin typeface="Noto Sans" pitchFamily="34" charset="0"/>
+                <a:ea typeface="Noto Sans" pitchFamily="34" charset="-122"/>
+                <a:cs typeface="Noto Sans" pitchFamily="34" charset="-120"/>
+              </a:rPr>
+              <a:t>Con chủ động, hào hứng học tiếng Anh thay vì học đối phó — đầu tư mới bền vững lâu dài.</a:t>
+            </a:r>
+            <a:endParaRPr lang="en-US" sz="1300" dirty="0"/>
+          </a:p>
+          <a:p>
+            <a:pPr indent="0" marL="0">
+              <a:lnSpc>
+                <a:spcPct val="102000"/>
+              </a:lnSpc>
+              <a:spcAft>
+                <a:spcPts val="300"/>
+              </a:spcAft>
+              <a:buNone/>
+            </a:pPr>
+            <a:r>
+              <a:rPr lang="en-US" sz="1100" b="1" dirty="0">
+                <a:solidFill>
+                  <a:srgbClr val="22333F"/>
+                </a:solidFill>
+                <a:latin typeface="Noto Sans" pitchFamily="34" charset="0"/>
+                <a:ea typeface="Noto Sans" pitchFamily="34" charset="-122"/>
+                <a:cs typeface="Noto Sans" pitchFamily="34" charset="-120"/>
+              </a:rPr>
+              <a:t>Pain point: </a:t>
+            </a:r>
+            <a:r>
+              <a:rPr lang="en-US" sz="1100" dirty="0">
+                <a:solidFill>
+                  <a:srgbClr val="22333F"/>
+                </a:solidFill>
+                <a:latin typeface="Noto Sans" pitchFamily="34" charset="0"/>
+                <a:ea typeface="Noto Sans" pitchFamily="34" charset="-122"/>
+                <a:cs typeface="Noto Sans" pitchFamily="34" charset="-120"/>
+              </a:rPr>
+              <a:t>Phải liên tục nhắc nhở, đốc thúc vì con chưa tự giác, dễ sao nhãng.</a:t>
+            </a:r>
+            <a:endParaRPr lang="en-US" sz="1300" dirty="0"/>
+          </a:p>
+        </p:txBody>
+      </p:sp>
+      <p:sp>
+        <p:nvSpPr>
+          <p:cNvPr id="18" name="Shape 14">
+</p:cNvPr>
+          <p:cNvSpPr/>
+          <p:nvPr>
+</p:nvPr>
+        </p:nvSpPr>
+        <p:spPr>
+          <a:xfrm>
+            <a:off x="502920" y="5373951"/>
+            <a:ext cx="73152" cy="1100000"/>
+          </a:xfrm>
+          <a:prstGeom prst="rect">
+            <a:avLst>
+</a:avLst>
+          </a:prstGeom>
+          <a:solidFill>
+            <a:srgbClr val="A5BE00"/>
+          </a:solidFill>
+          <a:ln>
+</a:ln>
+        </p:spPr>
+      </p:sp>
+      <p:sp>
+        <p:nvSpPr>
+          <p:cNvPr id="19" name="Text 15">
+</p:cNvPr>
+          <p:cNvSpPr/>
+          <p:nvPr>
+</p:nvPr>
+        </p:nvSpPr>
+        <p:spPr>
+          <a:xfrm>
+            <a:off x="731520" y="5373951"/>
+            <a:ext cx="10954512" cy="1100000"/>
+          </a:xfrm>
+          <a:prstGeom prst="rect">
+            <a:avLst>
+</a:avLst>
+          </a:prstGeom>
+          <a:noFill/>
+          <a:ln>
+</a:ln>
+        </p:spPr>
+        <p:txBody>
+          <a:bodyPr wrap="square" rtlCol="0" anchor="t">
+            <a:normAutofit/>
+          </a:bodyPr>
+          <a:lstStyle/>
+          <a:p>
+            <a:pPr indent="0" marL="0">
+              <a:lnSpc>
+                <a:spcPct val="102000"/>
+              </a:lnSpc>
+              <a:spcAft>
+                <a:spcPts val="200"/>
+              </a:spcAft>
+              <a:buNone/>
+            </a:pPr>
+            <a:r>
+              <a:rPr lang="en-US" sz="1300" b="1" dirty="0">
+                <a:solidFill>
+                  <a:srgbClr val="004671"/>
+                </a:solidFill>
+                <a:latin typeface="Noto Sans" pitchFamily="34" charset="0"/>
+                <a:ea typeface="Noto Sans" pitchFamily="34" charset="-122"/>
+                <a:cs typeface="Noto Sans" pitchFamily="34" charset="-120"/>
+              </a:rPr>
+              <a:t>JTBD 4: Giải phóng thời gian và áp lực kèm con cho bố mẹ</a:t>
+            </a:r>
+            <a:endParaRPr lang="en-US" sz="1300" dirty="0"/>
+          </a:p>
+          <a:p>
+            <a:pPr indent="0" marL="0">
+              <a:lnSpc>
+                <a:spcPct val="102000"/>
+              </a:lnSpc>
+              <a:spcAft>
+                <a:spcPts val="300"/>
+              </a:spcAft>
+              <a:buNone/>
+            </a:pPr>
+            <a:r>
+              <a:rPr lang="en-US" sz="1100" b="1" dirty="0">
+                <a:solidFill>
+                  <a:srgbClr val="22333F"/>
+                </a:solidFill>
+                <a:latin typeface="Noto Sans" pitchFamily="34" charset="0"/>
+                <a:ea typeface="Noto Sans" pitchFamily="34" charset="-122"/>
+                <a:cs typeface="Noto Sans" pitchFamily="34" charset="-120"/>
+              </a:rPr>
+              <a:t>Mục tiêu: </a:t>
+            </a:r>
+            <a:r>
+              <a:rPr lang="en-US" sz="1100" dirty="0">
+                <a:solidFill>
+                  <a:srgbClr val="22333F"/>
+                </a:solidFill>
+                <a:latin typeface="Noto Sans" pitchFamily="34" charset="0"/>
+                <a:ea typeface="Noto Sans" pitchFamily="34" charset="-122"/>
+                <a:cs typeface="Noto Sans" pitchFamily="34" charset="-120"/>
+              </a:rPr>
+              <a:t>Cần giải pháp đảm nhiệm việc kèm tiếng Anh thay bố mẹ — không phải giám sát, kèm cặp mỗi ngày.</a:t>
+            </a:r>
+            <a:endParaRPr lang="en-US" sz="1300" dirty="0"/>
+          </a:p>
+          <a:p>
+            <a:pPr indent="0" marL="0">
+              <a:lnSpc>
+                <a:spcPct val="102000"/>
+              </a:lnSpc>
+              <a:spcAft>
+                <a:spcPts val="300"/>
+              </a:spcAft>
+              <a:buNone/>
+            </a:pPr>
+            <a:r>
+              <a:rPr lang="en-US" sz="1100" b="1" dirty="0">
+                <a:solidFill>
+                  <a:srgbClr val="22333F"/>
+                </a:solidFill>
+                <a:latin typeface="Noto Sans" pitchFamily="34" charset="0"/>
+                <a:ea typeface="Noto Sans" pitchFamily="34" charset="-122"/>
+                <a:cs typeface="Noto Sans" pitchFamily="34" charset="-120"/>
+              </a:rPr>
+              <a:t>Pain point: </a:t>
+            </a:r>
+            <a:r>
+              <a:rPr lang="en-US" sz="1100" dirty="0">
+                <a:solidFill>
+                  <a:srgbClr val="22333F"/>
+                </a:solidFill>
+                <a:latin typeface="Noto Sans" pitchFamily="34" charset="0"/>
+                <a:ea typeface="Noto Sans" pitchFamily="34" charset="-122"/>
+                <a:cs typeface="Noto Sans" pitchFamily="34" charset="-120"/>
+              </a:rPr>
+              <a:t>Phụ huynh bận, không có thời gian kèm con; không giỏi tiếng Anh nên không tự hỗ trợ được con.</a:t>
+            </a:r>
+            <a:endParaRPr lang="en-US" sz="1300" dirty="0"/>
+          </a:p>
+        </p:txBody>
+      </p:sp>
+      <p:pic>
+        <p:nvPicPr>
+          <p:cNvPr id="15" name="Image 1" descr="C:\Users\landa\AppData\Local\Temp\claude\c--Users-landa--Personal--D---n-AI-Class-new\8a85e8a7-bdeb-42d6-9168-79c96b849bd1\scratchpad\pptx-gen\logo-icon-only.png">    </p:cNvPr>
+          <p:cNvPicPr>
+            <a:picLocks noChangeAspect="1"/>
+          </p:cNvPicPr>
+          <p:nvPr>
+</p:nvPr>
+        </p:nvPicPr>
+        <p:blipFill>
+          <a:blip r:embed="rId2">
+</a:blip>
+          <a:stretch>
+            <a:fillRect/>
+          </a:stretch>
+        </p:blipFill>
+        <p:spPr>
+          <a:xfrm>
+            <a:off x="502920" y="6473952"/>
+            <a:ext cx="237744" cy="237744"/>
+          </a:xfrm>
+          <a:prstGeom prst="rect">
+            <a:avLst/>
+          </a:prstGeom>
+        </p:spPr>
+      </p:pic>
+      <p:sp>
+        <p:nvSpPr>
+          <p:cNvPr id="16" name="Text 12">
+</p:cNvPr>
+          <p:cNvSpPr/>
+          <p:nvPr>
+</p:nvPr>
+        </p:nvSpPr>
+        <p:spPr>
+          <a:xfrm>
+            <a:off x="795528" y="6473952"/>
+            <a:ext cx="3657600" cy="256032"/>
+          </a:xfrm>
+          <a:prstGeom prst="rect">
+            <a:avLst>
+</a:avLst>
+          </a:prstGeom>
+          <a:noFill/>
+          <a:ln>
+</a:ln>
+        </p:spPr>
+        <p:txBody>
+          <a:bodyPr wrap="square" rtlCol="0" anchor="ctr">
+</a:bodyPr>
+          <a:lstStyle/>
+          <a:p>
+            <a:pPr indent="0" marL="0">
+              <a:buNone/>
+            </a:pPr>
+            <a:r>
+              <a:rPr lang="en-US" sz="800" spc="100" kern="0" dirty="0">
+                <a:solidFill>
+                  <a:srgbClr val="5B6472"/>
+                </a:solidFill>
+                <a:latin typeface="Noto Sans" pitchFamily="34" charset="0"/>
+                <a:ea typeface="Noto Sans" pitchFamily="34" charset="-122"/>
+                <a:cs typeface="Noto Sans" pitchFamily="34" charset="-120"/>
+              </a:rPr>
+              <a:t>EDUPIA  AI CLASS NEW</a:t>
+            </a:r>
+            <a:endParaRPr lang="en-US" sz="800" dirty="0"/>
+          </a:p>
+        </p:txBody>
+      </p:sp>
+      <p:sp>
+        <p:nvSpPr>
+          <p:cNvPr id="17" name="Text 13">
+</p:cNvPr>
+          <p:cNvSpPr/>
+          <p:nvPr>
+</p:nvPr>
+        </p:nvSpPr>
+        <p:spPr>
+          <a:xfrm>
+            <a:off x="10789920" y="6473952"/>
+            <a:ext cx="914400" cy="256032"/>
+          </a:xfrm>
+          <a:prstGeom prst="rect">
+            <a:avLst>
+</a:avLst>
+          </a:prstGeom>
+          <a:noFill/>
+          <a:ln>
+</a:ln>
+        </p:spPr>
+        <p:txBody>
+          <a:bodyPr wrap="square" rtlCol="0" anchor="ctr">
+</a:bodyPr>
+          <a:lstStyle/>
+          <a:p>
+            <a:pPr algn="r" indent="0" marL="0">
+              <a:buNone/>
+            </a:pPr>
+            <a:r>
+              <a:rPr lang="en-US" sz="850" dirty="0">
+                <a:solidFill>
+                  <a:srgbClr val="5B6472"/>
+                </a:solidFill>
+                <a:latin typeface="Noto Sans" pitchFamily="34" charset="0"/>
+                <a:ea typeface="Noto Sans" pitchFamily="34" charset="-122"/>
+                <a:cs typeface="Noto Sans" pitchFamily="34" charset="-120"/>
+              </a:rPr>
+              <a:t>4 / 14</a:t>
+            </a:r>
+            <a:endParaRPr lang="en-US" sz="850" dirty="0"/>
+          </a:p>
+        </p:txBody>
+      </p:sp>
+    </p:spTree>
+  </p:cSld>
+  <p:clrMapOvr>
+    <a:masterClrMapping/>
+  </p:clrMapOvr>
+</p:sld>
+</file>
+
+<file path=ppt/slides/slide15.xml><?xml version="1.0" encoding="utf-8"?>
+<p:sld xmlns:a="http://schemas.openxmlformats.org/drawingml/2006/main" xmlns:r="http://schemas.openxmlformats.org/officeDocument/2006/relationships" xmlns:p="http://schemas.openxmlformats.org/presentationml/2006/main">
+  <p:cSld name="Slide 8">
+    <p:bg>
+      <p:bgPr>
+        <a:solidFill>
+          <a:srgbClr val="FFFFFF"/>
+        </a:solidFill>
+      </p:bgPr>
+    </p:bg>
+    <p:spTree>
+      <p:nvGrpSpPr>
+        <p:cNvPr id="1" name=""/>
+        <p:cNvGrpSpPr/>
+        <p:nvPr/>
+      </p:nvGrpSpPr>
+      <p:grpSpPr>
+        <a:xfrm>
+          <a:off x="0" y="0"/>
+          <a:ext cx="0" cy="0"/>
+          <a:chOff x="0" y="0"/>
+          <a:chExt cx="0" cy="0"/>
+        </a:xfrm>
+      </p:grpSpPr>
+      <p:sp>
+        <p:nvSpPr>
+          <p:cNvPr id="2" name="Text 0">
+</p:cNvPr>
+          <p:cNvSpPr/>
+          <p:nvPr>
+</p:nvPr>
+        </p:nvSpPr>
+        <p:spPr>
+          <a:xfrm>
+            <a:off x="502920" y="292608"/>
+            <a:ext cx="11183112" cy="274320"/>
+          </a:xfrm>
+          <a:prstGeom prst="rect">
+            <a:avLst>
+</a:avLst>
+          </a:prstGeom>
+          <a:noFill/>
+          <a:ln>
+</a:ln>
+        </p:spPr>
+        <p:txBody>
+          <a:bodyPr wrap="square" rtlCol="0" anchor="ctr">
+</a:bodyPr>
+          <a:lstStyle/>
+          <a:p>
+            <a:pPr indent="0" marL="0">
+              <a:buNone/>
+            </a:pPr>
+            <a:r>
+              <a:rPr lang="en-US" sz="1100" b="1" spc="120" kern="0" dirty="0">
+                <a:solidFill>
+                  <a:srgbClr val="3B81B1"/>
+                </a:solidFill>
+                <a:latin typeface="Noto Sans" pitchFamily="34" charset="0"/>
+                <a:ea typeface="Noto Sans" pitchFamily="34" charset="-122"/>
+                <a:cs typeface="Noto Sans" pitchFamily="34" charset="-120"/>
+              </a:rPr>
+              <a:t>PHẦN 2 — CHÂN DUNG KHÁCH HÀNG MỤC TIÊU</a:t>
+            </a:r>
+            <a:endParaRPr lang="en-US" sz="1100" dirty="0"/>
+          </a:p>
+        </p:txBody>
+      </p:sp>
+      <p:sp>
+        <p:nvSpPr>
+          <p:cNvPr id="3" name="Text 1">
+</p:cNvPr>
+          <p:cNvSpPr/>
+          <p:nvPr>
+</p:nvPr>
+        </p:nvSpPr>
+        <p:spPr>
+          <a:xfrm>
+            <a:off x="502920" y="548640"/>
+            <a:ext cx="10085832" cy="640080"/>
+          </a:xfrm>
+          <a:prstGeom prst="rect">
+            <a:avLst>
+</a:avLst>
+          </a:prstGeom>
+          <a:noFill/>
+          <a:ln>
+</a:ln>
+        </p:spPr>
+        <p:txBody>
+          <a:bodyPr wrap="square" rtlCol="0" anchor="ctr">
+</a:bodyPr>
+          <a:lstStyle/>
+          <a:p>
+            <a:pPr indent="0" marL="0">
+              <a:buNone/>
+            </a:pPr>
+            <a:r>
+              <a:rPr lang="en-US" sz="2600" b="1" dirty="0">
+                <a:solidFill>
+                  <a:srgbClr val="004671"/>
+                </a:solidFill>
+                <a:latin typeface="Noto Sans" pitchFamily="34" charset="0"/>
+                <a:ea typeface="Noto Sans" pitchFamily="34" charset="-122"/>
+                <a:cs typeface="Noto Sans" pitchFamily="34" charset="-120"/>
+              </a:rPr>
+              <a:t>Pain Point &amp; JTBD</a:t>
+            </a:r>
+            <a:endParaRPr lang="en-US" sz="2600" dirty="0"/>
+          </a:p>
+        </p:txBody>
+      </p:sp>
+      <p:sp>
+        <p:nvSpPr>
+          <p:cNvPr id="4" name="Shape 2">
+</p:cNvPr>
+          <p:cNvSpPr/>
+          <p:nvPr>
+</p:nvPr>
+        </p:nvSpPr>
+        <p:spPr>
+          <a:xfrm>
+            <a:off x="502920" y="1170432"/>
+            <a:ext cx="777240" cy="45720"/>
+          </a:xfrm>
+          <a:prstGeom prst="rect">
+            <a:avLst>
+</a:avLst>
+          </a:prstGeom>
+          <a:solidFill>
+            <a:srgbClr val="A5BE00"/>
+          </a:solidFill>
+          <a:ln>
+</a:ln>
+        </p:spPr>
+      </p:sp>
+      <p:pic>
+        <p:nvPicPr>
+          <p:cNvPr id="5" name="Image 0" descr="C:\Users\landa\AppData\Local\Temp\claude\c--Users-landa--Personal--D---n-AI-Class-new\8a85e8a7-bdeb-42d6-9168-79c96b849bd1\scratchpad\pptx-gen\logo-icon-only.png">    </p:cNvPr>
+          <p:cNvPicPr>
+            <a:picLocks noChangeAspect="1"/>
+          </p:cNvPicPr>
+          <p:nvPr>
+</p:nvPr>
+        </p:nvPicPr>
+        <p:blipFill>
+          <a:blip r:embed="rId1">
+</a:blip>
+          <a:stretch>
+            <a:fillRect/>
+          </a:stretch>
+        </p:blipFill>
+        <p:spPr>
+          <a:xfrm>
+            <a:off x="11292840" y="365760"/>
+            <a:ext cx="502920" cy="502920"/>
+          </a:xfrm>
+          <a:prstGeom prst="rect">
+            <a:avLst/>
+          </a:prstGeom>
+        </p:spPr>
+      </p:pic>
+      <p:sp>
+        <p:nvSpPr>
+          <p:cNvPr id="6" name="Text 3">
+</p:cNvPr>
+          <p:cNvSpPr/>
+          <p:nvPr>
+</p:nvPr>
+        </p:nvSpPr>
+        <p:spPr>
+          <a:xfrm>
+            <a:off x="502920" y="1280160"/>
+            <a:ext cx="11183112" cy="384048"/>
+          </a:xfrm>
+          <a:prstGeom prst="rect">
+            <a:avLst>
+</a:avLst>
+          </a:prstGeom>
+          <a:noFill/>
+          <a:ln>
+</a:ln>
+        </p:spPr>
+        <p:txBody>
+          <a:bodyPr wrap="square" rtlCol="0" anchor="ctr">
+</a:bodyPr>
+          <a:lstStyle/>
+          <a:p>
+            <a:pPr indent="0" marL="0">
+              <a:buNone/>
+            </a:pPr>
+            <a:r>
+              <a:rPr lang="en-US" sz="1050" i="1" dirty="0">
+                <a:solidFill>
+                  <a:srgbClr val="5B6472"/>
+                </a:solidFill>
+                <a:latin typeface="Noto Sans" pitchFamily="34" charset="0"/>
+                <a:ea typeface="Noto Sans" pitchFamily="34" charset="-122"/>
+                <a:cs typeface="Noto Sans" pitchFamily="34" charset="-120"/>
+              </a:rPr>
+              <a:t>Nhóm II — Phát triển toàn diện, giỏi đều các môn</a:t>
+            </a:r>
+            <a:endParaRPr lang="en-US" sz="1050" dirty="0"/>
+          </a:p>
+        </p:txBody>
+      </p:sp>
+      <p:sp>
+        <p:nvSpPr>
+          <p:cNvPr id="7" name="Shape 4">
+</p:cNvPr>
+          <p:cNvSpPr/>
+          <p:nvPr>
+</p:nvPr>
+        </p:nvSpPr>
+        <p:spPr>
+          <a:xfrm>
+            <a:off x="502920" y="1664208"/>
+            <a:ext cx="73152" cy="1289304"/>
+          </a:xfrm>
+          <a:prstGeom prst="rect">
+            <a:avLst>
+</a:avLst>
+          </a:prstGeom>
+          <a:solidFill>
+            <a:srgbClr val="004671"/>
+          </a:solidFill>
+          <a:ln>
+</a:ln>
+        </p:spPr>
+      </p:sp>
+      <p:sp>
+        <p:nvSpPr>
+          <p:cNvPr id="8" name="Text 5">
+</p:cNvPr>
+          <p:cNvSpPr/>
+          <p:nvPr>
+</p:nvPr>
+        </p:nvSpPr>
+        <p:spPr>
+          <a:xfrm>
+            <a:off x="731520" y="1664208"/>
+            <a:ext cx="10954512" cy="1289304"/>
+          </a:xfrm>
+          <a:prstGeom prst="rect">
+            <a:avLst>
+</a:avLst>
+          </a:prstGeom>
+          <a:noFill/>
+          <a:ln>
+</a:ln>
+        </p:spPr>
+        <p:txBody>
+          <a:bodyPr wrap="square" rtlCol="0" anchor="t">
+            <a:normAutofit/>
+          </a:bodyPr>
+          <a:lstStyle/>
+          <a:p>
+            <a:pPr indent="0" marL="0">
+              <a:lnSpc>
+                <a:spcPct val="102000"/>
+              </a:lnSpc>
+              <a:spcAft>
+                <a:spcPts val="200"/>
+              </a:spcAft>
+              <a:buNone/>
+            </a:pPr>
+            <a:r>
+              <a:rPr lang="en-US" sz="1300" b="1" dirty="0">
+                <a:solidFill>
+                  <a:srgbClr val="004671"/>
+                </a:solidFill>
+                <a:latin typeface="Noto Sans" pitchFamily="34" charset="0"/>
+                <a:ea typeface="Noto Sans" pitchFamily="34" charset="-122"/>
+                <a:cs typeface="Noto Sans" pitchFamily="34" charset="-120"/>
+              </a:rPr>
+              <a:t>JTBD 1: Đạt điểm cao đồng đều ở tất cả các môn</a:t>
+            </a:r>
+            <a:endParaRPr lang="en-US" sz="1300" dirty="0"/>
+          </a:p>
+          <a:p>
+            <a:pPr indent="0" marL="0">
+              <a:lnSpc>
+                <a:spcPct val="102000"/>
+              </a:lnSpc>
+              <a:spcAft>
+                <a:spcPts val="300"/>
+              </a:spcAft>
+              <a:buNone/>
+            </a:pPr>
+            <a:r>
+              <a:rPr lang="en-US" sz="1100" b="1" dirty="0">
+                <a:solidFill>
+                  <a:srgbClr val="22333F"/>
+                </a:solidFill>
+                <a:latin typeface="Noto Sans" pitchFamily="34" charset="0"/>
+                <a:ea typeface="Noto Sans" pitchFamily="34" charset="-122"/>
+                <a:cs typeface="Noto Sans" pitchFamily="34" charset="-120"/>
+              </a:rPr>
+              <a:t>Mục tiêu: </a:t>
+            </a:r>
+            <a:r>
+              <a:rPr lang="en-US" sz="1100" dirty="0">
+                <a:solidFill>
+                  <a:srgbClr val="22333F"/>
+                </a:solidFill>
+                <a:latin typeface="Noto Sans" pitchFamily="34" charset="0"/>
+                <a:ea typeface="Noto Sans" pitchFamily="34" charset="-122"/>
+                <a:cs typeface="Noto Sans" pitchFamily="34" charset="-120"/>
+              </a:rPr>
+              <a:t>Con không bị lệch môn hay hổng kiến thức ở bất kỳ môn chính khóa nào — đảm bảo nền tảng học thuật toàn diện.</a:t>
+            </a:r>
+            <a:endParaRPr lang="en-US" sz="1300" dirty="0"/>
+          </a:p>
+          <a:p>
+            <a:pPr indent="0" marL="0">
+              <a:lnSpc>
+                <a:spcPct val="102000"/>
+              </a:lnSpc>
+              <a:spcAft>
+                <a:spcPts val="300"/>
+              </a:spcAft>
+              <a:buNone/>
+            </a:pPr>
+            <a:r>
+              <a:rPr lang="en-US" sz="1100" b="1" dirty="0">
+                <a:solidFill>
+                  <a:srgbClr val="22333F"/>
+                </a:solidFill>
+                <a:latin typeface="Noto Sans" pitchFamily="34" charset="0"/>
+                <a:ea typeface="Noto Sans" pitchFamily="34" charset="-122"/>
+                <a:cs typeface="Noto Sans" pitchFamily="34" charset="-120"/>
+              </a:rPr>
+              <a:t>Pain point: </a:t>
+            </a:r>
+            <a:r>
+              <a:rPr lang="en-US" sz="1100" dirty="0">
+                <a:solidFill>
+                  <a:srgbClr val="22333F"/>
+                </a:solidFill>
+                <a:latin typeface="Noto Sans" pitchFamily="34" charset="0"/>
+                <a:ea typeface="Noto Sans" pitchFamily="34" charset="-122"/>
+                <a:cs typeface="Noto Sans" pitchFamily="34" charset="-120"/>
+              </a:rPr>
+              <a:t>◆ Con học lệch, thiếu cân bằng giữa các môn — giả định, chưa xác nhận.</a:t>
+            </a:r>
+            <a:endParaRPr lang="en-US" sz="1300" dirty="0"/>
+          </a:p>
+        </p:txBody>
+      </p:sp>
+      <p:sp>
+        <p:nvSpPr>
+          <p:cNvPr id="9" name="Shape 6">
+</p:cNvPr>
+          <p:cNvSpPr/>
+          <p:nvPr>
+</p:nvPr>
+        </p:nvSpPr>
+        <p:spPr>
+          <a:xfrm>
+            <a:off x="502920" y="3136392"/>
+            <a:ext cx="73152" cy="1289304"/>
+          </a:xfrm>
+          <a:prstGeom prst="rect">
+            <a:avLst>
+</a:avLst>
+          </a:prstGeom>
+          <a:solidFill>
+            <a:srgbClr val="3B81B1"/>
+          </a:solidFill>
+          <a:ln>
+</a:ln>
+        </p:spPr>
+      </p:sp>
+      <p:sp>
+        <p:nvSpPr>
+          <p:cNvPr id="10" name="Text 7">
+</p:cNvPr>
+          <p:cNvSpPr/>
+          <p:nvPr>
+</p:nvPr>
+        </p:nvSpPr>
+        <p:spPr>
+          <a:xfrm>
+            <a:off x="731520" y="3136392"/>
+            <a:ext cx="10954512" cy="1289304"/>
+          </a:xfrm>
+          <a:prstGeom prst="rect">
+            <a:avLst>
+</a:avLst>
+          </a:prstGeom>
+          <a:noFill/>
+          <a:ln>
+</a:ln>
+        </p:spPr>
+        <p:txBody>
+          <a:bodyPr wrap="square" rtlCol="0" anchor="t">
+            <a:normAutofit/>
+          </a:bodyPr>
+          <a:lstStyle/>
+          <a:p>
+            <a:pPr indent="0" marL="0">
+              <a:lnSpc>
+                <a:spcPct val="102000"/>
+              </a:lnSpc>
+              <a:spcAft>
+                <a:spcPts val="200"/>
+              </a:spcAft>
+              <a:buNone/>
+            </a:pPr>
+            <a:r>
+              <a:rPr lang="en-US" sz="1300" b="1" dirty="0">
+                <a:solidFill>
+                  <a:srgbClr val="004671"/>
+                </a:solidFill>
+                <a:latin typeface="Noto Sans" pitchFamily="34" charset="0"/>
+                <a:ea typeface="Noto Sans" pitchFamily="34" charset="-122"/>
+                <a:cs typeface="Noto Sans" pitchFamily="34" charset="-120"/>
+              </a:rPr>
+              <a:t>JTBD 2: Vượt qua các kỳ thi mang tính bước ngoặt (chuyển cấp, Đại học)</a:t>
+            </a:r>
+            <a:endParaRPr lang="en-US" sz="1300" dirty="0"/>
+          </a:p>
+          <a:p>
+            <a:pPr indent="0" marL="0">
+              <a:lnSpc>
+                <a:spcPct val="102000"/>
+              </a:lnSpc>
+              <a:spcAft>
+                <a:spcPts val="300"/>
+              </a:spcAft>
+              <a:buNone/>
+            </a:pPr>
+            <a:r>
+              <a:rPr lang="en-US" sz="1100" b="1" dirty="0">
+                <a:solidFill>
+                  <a:srgbClr val="22333F"/>
+                </a:solidFill>
+                <a:latin typeface="Noto Sans" pitchFamily="34" charset="0"/>
+                <a:ea typeface="Noto Sans" pitchFamily="34" charset="-122"/>
+                <a:cs typeface="Noto Sans" pitchFamily="34" charset="-120"/>
+              </a:rPr>
+              <a:t>Mục tiêu: </a:t>
+            </a:r>
+            <a:r>
+              <a:rPr lang="en-US" sz="1100" dirty="0">
+                <a:solidFill>
+                  <a:srgbClr val="22333F"/>
+                </a:solidFill>
+                <a:latin typeface="Noto Sans" pitchFamily="34" charset="0"/>
+                <a:ea typeface="Noto Sans" pitchFamily="34" charset="-122"/>
+                <a:cs typeface="Noto Sans" pitchFamily="34" charset="-120"/>
+              </a:rPr>
+              <a:t>Con có đủ năng lực tổng hợp để vượt qua các kỳ thi quan trọng (thi vào 10, thi tốt nghiệp/Đại học).</a:t>
+            </a:r>
+            <a:endParaRPr lang="en-US" sz="1300" dirty="0"/>
+          </a:p>
+          <a:p>
+            <a:pPr indent="0" marL="0">
+              <a:lnSpc>
+                <a:spcPct val="102000"/>
+              </a:lnSpc>
+              <a:spcAft>
+                <a:spcPts val="300"/>
+              </a:spcAft>
+              <a:buNone/>
+            </a:pPr>
+            <a:r>
+              <a:rPr lang="en-US" sz="1100" b="1" dirty="0">
+                <a:solidFill>
+                  <a:srgbClr val="22333F"/>
+                </a:solidFill>
+                <a:latin typeface="Noto Sans" pitchFamily="34" charset="0"/>
+                <a:ea typeface="Noto Sans" pitchFamily="34" charset="-122"/>
+                <a:cs typeface="Noto Sans" pitchFamily="34" charset="-120"/>
+              </a:rPr>
+              <a:t>Pain point: </a:t>
+            </a:r>
+            <a:r>
+              <a:rPr lang="en-US" sz="1100" dirty="0">
+                <a:solidFill>
+                  <a:srgbClr val="22333F"/>
+                </a:solidFill>
+                <a:latin typeface="Noto Sans" pitchFamily="34" charset="0"/>
+                <a:ea typeface="Noto Sans" pitchFamily="34" charset="-122"/>
+                <a:cs typeface="Noto Sans" pitchFamily="34" charset="-120"/>
+              </a:rPr>
+              <a:t>◆ Lo con không đủ điểm/năng lực để đỗ trường mong muốn — giả định, cần validate ở khảo sát T9.</a:t>
+            </a:r>
+            <a:endParaRPr lang="en-US" sz="1300" dirty="0"/>
+          </a:p>
+        </p:txBody>
+      </p:sp>
+      <p:sp>
+        <p:nvSpPr>
+          <p:cNvPr id="11" name="Shape 8">
+</p:cNvPr>
+          <p:cNvSpPr/>
+          <p:nvPr>
+</p:nvPr>
+        </p:nvSpPr>
+        <p:spPr>
+          <a:xfrm>
+            <a:off x="502920" y="4608576"/>
+            <a:ext cx="73152" cy="1289304"/>
+          </a:xfrm>
+          <a:prstGeom prst="rect">
+            <a:avLst>
+</a:avLst>
+          </a:prstGeom>
+          <a:solidFill>
+            <a:srgbClr val="518E0D"/>
+          </a:solidFill>
+          <a:ln>
+</a:ln>
+        </p:spPr>
+      </p:sp>
+      <p:sp>
+        <p:nvSpPr>
+          <p:cNvPr id="12" name="Text 9">
+</p:cNvPr>
+          <p:cNvSpPr/>
+          <p:nvPr>
+</p:nvPr>
+        </p:nvSpPr>
+        <p:spPr>
+          <a:xfrm>
+            <a:off x="731520" y="4608576"/>
+            <a:ext cx="10954512" cy="1289304"/>
+          </a:xfrm>
+          <a:prstGeom prst="rect">
+            <a:avLst>
+</a:avLst>
+          </a:prstGeom>
+          <a:noFill/>
+          <a:ln>
+</a:ln>
+        </p:spPr>
+        <p:txBody>
+          <a:bodyPr wrap="square" rtlCol="0" anchor="t">
+            <a:normAutofit/>
+          </a:bodyPr>
+          <a:lstStyle/>
+          <a:p>
+            <a:pPr indent="0" marL="0">
+              <a:lnSpc>
+                <a:spcPct val="102000"/>
+              </a:lnSpc>
+              <a:spcAft>
+                <a:spcPts val="200"/>
+              </a:spcAft>
+              <a:buNone/>
+            </a:pPr>
+            <a:r>
+              <a:rPr lang="en-US" sz="1300" b="1" dirty="0">
+                <a:solidFill>
+                  <a:srgbClr val="004671"/>
+                </a:solidFill>
+                <a:latin typeface="Noto Sans" pitchFamily="34" charset="0"/>
+                <a:ea typeface="Noto Sans" pitchFamily="34" charset="-122"/>
+                <a:cs typeface="Noto Sans" pitchFamily="34" charset="-120"/>
+              </a:rPr>
+              <a:t>JTBD 3: Giải phóng thời gian và áp lực kèm con cho bố mẹ</a:t>
+            </a:r>
+            <a:endParaRPr lang="en-US" sz="1300" dirty="0"/>
+          </a:p>
+          <a:p>
+            <a:pPr indent="0" marL="0">
+              <a:lnSpc>
+                <a:spcPct val="102000"/>
+              </a:lnSpc>
+              <a:spcAft>
+                <a:spcPts val="300"/>
+              </a:spcAft>
+              <a:buNone/>
+            </a:pPr>
+            <a:r>
+              <a:rPr lang="en-US" sz="1100" b="1" dirty="0">
+                <a:solidFill>
+                  <a:srgbClr val="22333F"/>
+                </a:solidFill>
+                <a:latin typeface="Noto Sans" pitchFamily="34" charset="0"/>
+                <a:ea typeface="Noto Sans" pitchFamily="34" charset="-122"/>
+                <a:cs typeface="Noto Sans" pitchFamily="34" charset="-120"/>
+              </a:rPr>
+              <a:t>Mục tiêu: </a:t>
+            </a:r>
+            <a:r>
+              <a:rPr lang="en-US" sz="1100" dirty="0">
+                <a:solidFill>
+                  <a:srgbClr val="22333F"/>
+                </a:solidFill>
+                <a:latin typeface="Noto Sans" pitchFamily="34" charset="0"/>
+                <a:ea typeface="Noto Sans" pitchFamily="34" charset="-122"/>
+                <a:cs typeface="Noto Sans" pitchFamily="34" charset="-120"/>
+              </a:rPr>
+              <a:t>Cần giải pháp "đóng gói" nhiều môn — không phải tự tìm, quản lý, sắp xếp ở nhiều nơi khác nhau.</a:t>
+            </a:r>
+            <a:endParaRPr lang="en-US" sz="1300" dirty="0"/>
+          </a:p>
+          <a:p>
+            <a:pPr indent="0" marL="0">
+              <a:lnSpc>
+                <a:spcPct val="102000"/>
+              </a:lnSpc>
+              <a:spcAft>
+                <a:spcPts val="300"/>
+              </a:spcAft>
+              <a:buNone/>
+            </a:pPr>
+            <a:r>
+              <a:rPr lang="en-US" sz="1100" b="1" dirty="0">
+                <a:solidFill>
+                  <a:srgbClr val="22333F"/>
+                </a:solidFill>
+                <a:latin typeface="Noto Sans" pitchFamily="34" charset="0"/>
+                <a:ea typeface="Noto Sans" pitchFamily="34" charset="-122"/>
+                <a:cs typeface="Noto Sans" pitchFamily="34" charset="-120"/>
+              </a:rPr>
+              <a:t>Pain point: </a:t>
+            </a:r>
+            <a:r>
+              <a:rPr lang="en-US" sz="1100" dirty="0">
+                <a:solidFill>
+                  <a:srgbClr val="22333F"/>
+                </a:solidFill>
+                <a:latin typeface="Noto Sans" pitchFamily="34" charset="0"/>
+                <a:ea typeface="Noto Sans" pitchFamily="34" charset="-122"/>
+                <a:cs typeface="Noto Sans" pitchFamily="34" charset="-120"/>
+              </a:rPr>
+              <a:t>◆ Khó quản lý việc học đa môn/đa trung tâm; chi phí và thời gian đưa đón cộng dồn.</a:t>
+            </a:r>
+            <a:endParaRPr lang="en-US" sz="1300" dirty="0"/>
+          </a:p>
+        </p:txBody>
+      </p:sp>
+      <p:pic>
+        <p:nvPicPr>
+          <p:cNvPr id="15" name="Image 1" descr="C:\Users\landa\AppData\Local\Temp\claude\c--Users-landa--Personal--D---n-AI-Class-new\8a85e8a7-bdeb-42d6-9168-79c96b849bd1\scratchpad\pptx-gen\logo-icon-only.png">    </p:cNvPr>
+          <p:cNvPicPr>
+            <a:picLocks noChangeAspect="1"/>
+          </p:cNvPicPr>
+          <p:nvPr>
+</p:nvPr>
+        </p:nvPicPr>
+        <p:blipFill>
+          <a:blip r:embed="rId2">
+</a:blip>
+          <a:stretch>
+            <a:fillRect/>
+          </a:stretch>
+        </p:blipFill>
+        <p:spPr>
+          <a:xfrm>
+            <a:off x="502920" y="6473952"/>
+            <a:ext cx="237744" cy="237744"/>
+          </a:xfrm>
+          <a:prstGeom prst="rect">
+            <a:avLst/>
+          </a:prstGeom>
+        </p:spPr>
+      </p:pic>
+      <p:sp>
+        <p:nvSpPr>
+          <p:cNvPr id="16" name="Text 12">
+</p:cNvPr>
+          <p:cNvSpPr/>
+          <p:nvPr>
+</p:nvPr>
+        </p:nvSpPr>
+        <p:spPr>
+          <a:xfrm>
+            <a:off x="795528" y="6473952"/>
+            <a:ext cx="3657600" cy="256032"/>
+          </a:xfrm>
+          <a:prstGeom prst="rect">
+            <a:avLst>
+</a:avLst>
+          </a:prstGeom>
+          <a:noFill/>
+          <a:ln>
+</a:ln>
+        </p:spPr>
+        <p:txBody>
+          <a:bodyPr wrap="square" rtlCol="0" anchor="ctr">
+</a:bodyPr>
+          <a:lstStyle/>
+          <a:p>
+            <a:pPr indent="0" marL="0">
+              <a:buNone/>
+            </a:pPr>
+            <a:r>
+              <a:rPr lang="en-US" sz="800" spc="100" kern="0" dirty="0">
+                <a:solidFill>
+                  <a:srgbClr val="5B6472"/>
+                </a:solidFill>
+                <a:latin typeface="Noto Sans" pitchFamily="34" charset="0"/>
+                <a:ea typeface="Noto Sans" pitchFamily="34" charset="-122"/>
+                <a:cs typeface="Noto Sans" pitchFamily="34" charset="-120"/>
+              </a:rPr>
+              <a:t>EDUPIA  AI CLASS NEW</a:t>
+            </a:r>
+            <a:endParaRPr lang="en-US" sz="800" dirty="0"/>
+          </a:p>
+        </p:txBody>
+      </p:sp>
+      <p:sp>
+        <p:nvSpPr>
+          <p:cNvPr id="17" name="Text 13">
+</p:cNvPr>
+          <p:cNvSpPr/>
+          <p:nvPr>
+</p:nvPr>
+        </p:nvSpPr>
+        <p:spPr>
+          <a:xfrm>
+            <a:off x="10789920" y="6473952"/>
+            <a:ext cx="914400" cy="256032"/>
+          </a:xfrm>
+          <a:prstGeom prst="rect">
+            <a:avLst>
+</a:avLst>
+          </a:prstGeom>
+          <a:noFill/>
+          <a:ln>
+</a:ln>
+        </p:spPr>
+        <p:txBody>
+          <a:bodyPr wrap="square" rtlCol="0" anchor="ctr">
+</a:bodyPr>
+          <a:lstStyle/>
+          <a:p>
+            <a:pPr algn="r" indent="0" marL="0">
+              <a:buNone/>
+            </a:pPr>
+            <a:r>
+              <a:rPr lang="en-US" sz="850" dirty="0">
+                <a:solidFill>
+                  <a:srgbClr val="5B6472"/>
+                </a:solidFill>
+                <a:latin typeface="Noto Sans" pitchFamily="34" charset="0"/>
+                <a:ea typeface="Noto Sans" pitchFamily="34" charset="-122"/>
+                <a:cs typeface="Noto Sans" pitchFamily="34" charset="-120"/>
+              </a:rPr>
+              <a:t>5 / 14</a:t>
+            </a:r>
+            <a:endParaRPr lang="en-US" sz="850" dirty="0"/>
+          </a:p>
+        </p:txBody>
+      </p:sp>
+    </p:spTree>
+  </p:cSld>
+  <p:clrMapOvr>
+    <a:masterClrMapping/>
+  </p:clrMapOvr>
+</p:sld>
+</file>
+
+<file path=ppt/slides/slide16.xml><?xml version="1.0" encoding="utf-8"?>
+<p:sld xmlns:a="http://schemas.openxmlformats.org/drawingml/2006/main" xmlns:r="http://schemas.openxmlformats.org/officeDocument/2006/relationships" xmlns:p="http://schemas.openxmlformats.org/presentationml/2006/main">
+  <p:cSld name="Slide 16">
+    <p:bg>
+      <p:bgPr>
+        <a:solidFill>
+          <a:srgbClr val="FFFFFF"/>
+        </a:solidFill>
+      </p:bgPr>
+    </p:bg>
+    <p:spTree>
+      <p:nvGrpSpPr>
+        <p:cNvPr id="1" name=""/>
+        <p:cNvGrpSpPr/>
+        <p:nvPr/>
+      </p:nvGrpSpPr>
+      <p:grpSpPr>
+        <a:xfrm>
+          <a:off x="0" y="0"/>
+          <a:ext cx="0" cy="0"/>
+          <a:chOff x="0" y="0"/>
+          <a:chExt cx="0" cy="0"/>
+        </a:xfrm>
+      </p:grpSpPr>
+      <p:sp>
+        <p:nvSpPr>
+          <p:cNvPr id="2" name="Text 0">
+</p:cNvPr>
+          <p:cNvSpPr/>
+          <p:nvPr>
+</p:nvPr>
+        </p:nvSpPr>
+        <p:spPr>
+          <a:xfrm>
+            <a:off x="502920" y="292608"/>
+            <a:ext cx="11183112" cy="274320"/>
+          </a:xfrm>
+          <a:prstGeom prst="rect">
+            <a:avLst>
+</a:avLst>
+          </a:prstGeom>
+          <a:noFill/>
+          <a:ln>
+</a:ln>
+        </p:spPr>
+        <p:txBody>
+          <a:bodyPr wrap="square" rtlCol="0" anchor="ctr">
+</a:bodyPr>
+          <a:lstStyle/>
+          <a:p>
+            <a:pPr indent="0" marL="0">
+              <a:buNone/>
+            </a:pPr>
+            <a:r>
+              <a:rPr lang="en-US" sz="1100" b="1" spc="120" kern="0" dirty="0">
+                <a:solidFill>
+                  <a:srgbClr val="3B81B1"/>
+                </a:solidFill>
+                <a:latin typeface="Noto Sans" pitchFamily="34" charset="0"/>
+                <a:ea typeface="Noto Sans" pitchFamily="34" charset="-122"/>
+                <a:cs typeface="Noto Sans" pitchFamily="34" charset="-120"/>
+              </a:rPr>
+              <a:t>PHẦN 2 — CHÂN DUNG KHÁCH HÀNG MỤC TIÊU</a:t>
+            </a:r>
+            <a:endParaRPr lang="en-US" sz="1100" dirty="0"/>
+          </a:p>
+        </p:txBody>
+      </p:sp>
+      <p:sp>
+        <p:nvSpPr>
+          <p:cNvPr id="3" name="Text 1">
+</p:cNvPr>
+          <p:cNvSpPr/>
+          <p:nvPr>
+</p:nvPr>
+        </p:nvSpPr>
+        <p:spPr>
+          <a:xfrm>
+            <a:off x="502920" y="548640"/>
+            <a:ext cx="10085832" cy="640080"/>
+          </a:xfrm>
+          <a:prstGeom prst="rect">
+            <a:avLst>
+</a:avLst>
+          </a:prstGeom>
+          <a:noFill/>
+          <a:ln>
+</a:ln>
+        </p:spPr>
+        <p:txBody>
+          <a:bodyPr wrap="square" rtlCol="0" anchor="ctr">
+</a:bodyPr>
+          <a:lstStyle/>
+          <a:p>
+            <a:pPr indent="0" marL="0">
+              <a:buNone/>
+            </a:pPr>
+            <a:r>
+              <a:rPr lang="en-US" sz="2600" b="1" dirty="0">
+                <a:solidFill>
+                  <a:srgbClr val="004671"/>
+                </a:solidFill>
+                <a:latin typeface="Noto Sans" pitchFamily="34" charset="0"/>
+                <a:ea typeface="Noto Sans" pitchFamily="34" charset="-122"/>
+                <a:cs typeface="Noto Sans" pitchFamily="34" charset="-120"/>
+              </a:rPr>
+              <a:t>Phân tích, Đánh giá Concept hiện tại</a:t>
+            </a:r>
+            <a:endParaRPr lang="en-US" sz="2600" dirty="0"/>
+          </a:p>
+        </p:txBody>
+      </p:sp>
+      <p:sp>
+        <p:nvSpPr>
+          <p:cNvPr id="4" name="Shape 2">
+</p:cNvPr>
+          <p:cNvSpPr/>
+          <p:nvPr>
+</p:nvPr>
+        </p:nvSpPr>
+        <p:spPr>
+          <a:xfrm>
+            <a:off x="502920" y="1170432"/>
+            <a:ext cx="777240" cy="45720"/>
+          </a:xfrm>
+          <a:prstGeom prst="rect">
+            <a:avLst>
+</a:avLst>
+          </a:prstGeom>
+          <a:solidFill>
+            <a:srgbClr val="A5BE00"/>
+          </a:solidFill>
+          <a:ln>
+</a:ln>
+        </p:spPr>
+      </p:sp>
+      <p:pic>
+        <p:nvPicPr>
+          <p:cNvPr id="5" name="Image 0">
+</p:cNvPr>
+          <p:cNvPicPr>
+            <a:picLocks noChangeAspect="1"/>
+          </p:cNvPicPr>
+          <p:nvPr>
+</p:nvPr>
+        </p:nvPicPr>
+        <p:blipFill>
+          <a:blip r:embed="rId1">
+</a:blip>
+          <a:stretch>
+            <a:fillRect/>
+          </a:stretch>
+        </p:blipFill>
+        <p:spPr>
+          <a:xfrm>
+            <a:off x="11292840" y="365760"/>
+            <a:ext cx="502920" cy="502920"/>
+          </a:xfrm>
+          <a:prstGeom prst="rect">
+            <a:avLst/>
+          </a:prstGeom>
+        </p:spPr>
+      </p:pic>
+      <p:sp>
+        <p:nvSpPr>
+          <p:cNvPr id="6" name="Text 3">
+</p:cNvPr>
+          <p:cNvSpPr/>
+          <p:nvPr>
+</p:nvPr>
+        </p:nvSpPr>
+        <p:spPr>
+          <a:xfrm>
+            <a:off x="502920" y="1280160"/>
+            <a:ext cx="11183112" cy="384048"/>
+          </a:xfrm>
+          <a:prstGeom prst="rect">
+            <a:avLst>
+</a:avLst>
+          </a:prstGeom>
+          <a:noFill/>
+          <a:ln>
+</a:ln>
+        </p:spPr>
+        <p:txBody>
+          <a:bodyPr wrap="square" rtlCol="0" anchor="ctr">
+</a:bodyPr>
+          <a:lstStyle/>
+          <a:p>
+            <a:pPr indent="0" marL="0">
+              <a:buNone/>
+            </a:pPr>
+            <a:r>
+              <a:rPr lang="en-US" sz="1050" i="1" dirty="0">
+                <a:solidFill>
+                  <a:srgbClr val="5B6472"/>
+                </a:solidFill>
+                <a:latin typeface="Noto Sans" pitchFamily="34" charset="0"/>
+                <a:ea typeface="Noto Sans" pitchFamily="34" charset="-122"/>
+                <a:cs typeface="Noto Sans" pitchFamily="34" charset="-120"/>
+              </a:rPr>
+              <a:t>Concept hiện tại đang giải quyết được gì? Và còn thiếu gì?</a:t>
+            </a:r>
+            <a:endParaRPr lang="en-US" sz="1050" dirty="0"/>
+          </a:p>
+        </p:txBody>
+      </p:sp>
       <p:graphicFrame>
         <p:nvGraphicFramePr>
           <p:cNvPr id="12" name="Table 0"/>
@@ -8073,19 +9793,19 @@
           <p:nvPr/>
         </p:nvGraphicFramePr>
         <p:xfrm>
-          <a:off x="502920" y="1371600"/>
-          <a:ext cx="11183112" cy="5029200"/>
+          <a:off x="502920" y="1730000"/>
+          <a:ext cx="11183112" cy="3143250"/>
         </p:xfrm>
         <a:graphic>
           <a:graphicData uri="http://schemas.openxmlformats.org/drawingml/2006/table">
             <a:tbl>
-              <a:tblPr firstRow="1" bandRow="0"/>
+              <a:tblPr/>
               <a:tblGrid>
-                <a:gridCol w="5200000"/>
-                <a:gridCol w="3583112"/>
+                <a:gridCol w="3200000"/>
+                <a:gridCol w="5583112"/>
                 <a:gridCol w="2400000"/>
               </a:tblGrid>
-              <a:tr h="350000">
+              <a:tr h="628650">
                 <a:tc>
                   <a:txBody>
                     <a:bodyPr/>
@@ -8095,7 +9815,7 @@
                         <a:buNone/>
                       </a:pPr>
                       <a:r>
-                        <a:rPr lang="en-US" sz="1200" b="1" dirty="0">
+                        <a:rPr lang="en-US" sz="1150" b="1" dirty="0">
                           <a:solidFill>
                             <a:srgbClr val="FFFFFF"/>
                           </a:solidFill>
@@ -8103,9 +9823,9 @@
                           <a:ea typeface="Noto Sans" pitchFamily="34" charset="-122"/>
                           <a:cs typeface="Noto Sans" pitchFamily="34" charset="-120"/>
                         </a:rPr>
-                        <a:t>Job (góc nhìn phụ huynh)</a:t>
+                        <a:t>Cấu phần hiện tại</a:t>
                       </a:r>
-                      <a:endParaRPr lang="en-US" sz="1200" dirty="0">
+                      <a:endParaRPr lang="en-US" sz="1150" dirty="0">
                         <a:latin typeface="Noto Sans" charset="0"/>
                         <a:ea typeface="Noto Sans" charset="0"/>
                         <a:cs typeface="Noto Sans" charset="0"/>
@@ -8163,7 +9883,7 @@
                         <a:buNone/>
                       </a:pPr>
                       <a:r>
-                        <a:rPr lang="en-US" sz="1200" b="1" dirty="0">
+                        <a:rPr lang="en-US" sz="1150" b="1" dirty="0">
                           <a:solidFill>
                             <a:srgbClr val="FFFFFF"/>
                           </a:solidFill>
@@ -8171,9 +9891,9 @@
                           <a:ea typeface="Noto Sans" pitchFamily="34" charset="-122"/>
                           <a:cs typeface="Noto Sans" pitchFamily="34" charset="-120"/>
                         </a:rPr>
-                        <a:t>Pain point liên quan</a:t>
+                        <a:t>JTBD được giải quyết (Slide 5)</a:t>
                       </a:r>
-                      <a:endParaRPr lang="en-US" sz="1200" dirty="0">
+                      <a:endParaRPr lang="en-US" sz="1150" dirty="0">
                         <a:latin typeface="Noto Sans" charset="0"/>
                         <a:ea typeface="Noto Sans" charset="0"/>
                         <a:cs typeface="Noto Sans" charset="0"/>
@@ -8231,7 +9951,7 @@
                         <a:buNone/>
                       </a:pPr>
                       <a:r>
-                        <a:rPr lang="en-US" sz="1200" b="1" dirty="0">
+                        <a:rPr lang="en-US" sz="1150" b="1" dirty="0">
                           <a:solidFill>
                             <a:srgbClr val="FFFFFF"/>
                           </a:solidFill>
@@ -8239,9 +9959,9 @@
                           <a:ea typeface="Noto Sans" pitchFamily="34" charset="-122"/>
                           <a:cs typeface="Noto Sans" pitchFamily="34" charset="-120"/>
                         </a:rPr>
-                        <a:t>Nhu cầu</a:t>
+                        <a:t>Đánh giá</a:t>
                       </a:r>
-                      <a:endParaRPr lang="en-US" sz="1200" dirty="0">
+                      <a:endParaRPr lang="en-US" sz="1150" dirty="0">
                         <a:latin typeface="Noto Sans" charset="0"/>
                         <a:ea typeface="Noto Sans" charset="0"/>
                         <a:cs typeface="Noto Sans" charset="0"/>
@@ -8291,7 +10011,7 @@
                   </a:tcPr>
                 </a:tc>
               </a:tr>
-              <a:tr h="584650">
+              <a:tr h="628650">
                 <a:tc>
                   <a:txBody>
                     <a:bodyPr/>
@@ -8301,28 +10021,17 @@
                         <a:buNone/>
                       </a:pPr>
                       <a:r>
-                        <a:rPr lang="en-US" sz="1200" b="1" dirty="0">
+                        <a:rPr lang="en-US" sz="1100" b="1" dirty="0">
                           <a:solidFill>
-                            <a:srgbClr val="3B81B1"/>
+                            <a:srgbClr val="004671"/>
                           </a:solidFill>
                           <a:latin typeface="Noto Sans" pitchFamily="34" charset="0"/>
                           <a:ea typeface="Noto Sans" pitchFamily="34" charset="-122"/>
                           <a:cs typeface="Noto Sans" pitchFamily="34" charset="-120"/>
                         </a:rPr>
-                        <a:t>[Functional] </a:t>
+                        <a:t>Big Class + AI Practice — GV bám sát SGK (2 buổi/tuần)</a:t>
                       </a:r>
-                      <a:r>
-                        <a:rPr lang="en-US" sz="1200" dirty="0">
-                          <a:solidFill>
-                            <a:srgbClr val="22333F"/>
-                          </a:solidFill>
-                          <a:latin typeface="Noto Sans" pitchFamily="34" charset="0"/>
-                          <a:ea typeface="Noto Sans" pitchFamily="34" charset="-122"/>
-                          <a:cs typeface="Noto Sans" pitchFamily="34" charset="-120"/>
-                        </a:rPr>
-                        <a:t>Muốn con học giỏi môn tiếng Anh</a:t>
-                      </a:r>
-                      <a:endParaRPr lang="en-US" sz="1200" dirty="0">
+                      <a:endParaRPr lang="en-US" sz="1100" dirty="0">
                         <a:latin typeface="Noto Sans" charset="0"/>
                         <a:ea typeface="Noto Sans" charset="0"/>
                         <a:cs typeface="Noto Sans" charset="0"/>
@@ -8380,156 +10089,7 @@
                         <a:buNone/>
                       </a:pPr>
                       <a:r>
-                        <a:rPr lang="en-US" sz="1200" dirty="0">
-                          <a:solidFill>
-                            <a:srgbClr val="5B6472"/>
-                          </a:solidFill>
-                          <a:latin typeface="Noto Sans" pitchFamily="34" charset="0"/>
-                          <a:ea typeface="Noto Sans" pitchFamily="34" charset="-122"/>
-                          <a:cs typeface="Noto Sans" pitchFamily="34" charset="-120"/>
-                        </a:rPr>
-                        <a:t>Con học TA chưa tốt/tiến bộ chậm — phát âm sai, không tự tin khi giao tiếp</a:t>
-                      </a:r>
-                      <a:endParaRPr lang="en-US" sz="1200" dirty="0">
-                        <a:latin typeface="Noto Sans" charset="0"/>
-                        <a:ea typeface="Noto Sans" charset="0"/>
-                        <a:cs typeface="Noto Sans" charset="0"/>
-                      </a:endParaRPr>
-                    </a:p>
-                  </a:txBody>
-                  <a:tcPr marL="101600" marR="101600" marT="63500" marB="63500" anchor="t">
-                    <a:lnL w="9525" cap="flat" cmpd="sng" algn="ctr">
-                      <a:solidFill>
-                        <a:srgbClr val="DCE7EA"/>
-                      </a:solidFill>
-                      <a:prstDash val="solid"/>
-                      <a:round/>
-                      <a:headEnd type="none" w="med" len="med"/>
-                      <a:tailEnd type="none" w="med" len="med"/>
-                    </a:lnL>
-                    <a:lnR w="9525" cap="flat" cmpd="sng" algn="ctr">
-                      <a:solidFill>
-                        <a:srgbClr val="DCE7EA"/>
-                      </a:solidFill>
-                      <a:prstDash val="solid"/>
-                      <a:round/>
-                      <a:headEnd type="none" w="med" len="med"/>
-                      <a:tailEnd type="none" w="med" len="med"/>
-                    </a:lnR>
-                    <a:lnT w="9525" cap="flat" cmpd="sng" algn="ctr">
-                      <a:solidFill>
-                        <a:srgbClr val="DCE7EA"/>
-                      </a:solidFill>
-                      <a:prstDash val="solid"/>
-                      <a:round/>
-                      <a:headEnd type="none" w="med" len="med"/>
-                      <a:tailEnd type="none" w="med" len="med"/>
-                    </a:lnT>
-                    <a:lnB w="9525" cap="flat" cmpd="sng" algn="ctr">
-                      <a:solidFill>
-                        <a:srgbClr val="DCE7EA"/>
-                      </a:solidFill>
-                      <a:prstDash val="solid"/>
-                      <a:round/>
-                      <a:headEnd type="none" w="med" len="med"/>
-                      <a:tailEnd type="none" w="med" len="med"/>
-                    </a:lnB>
-                    <a:solidFill>
-                      <a:srgbClr val="FFFFFF"/>
-                    </a:solidFill>
-                  </a:tcPr>
-                </a:tc>
-                <a:tc rowSpan="2">
-                  <a:txBody>
-                    <a:bodyPr/>
-                    <a:lstStyle/>
-                    <a:p>
-                      <a:pPr indent="0" marL="0">
-                        <a:buNone/>
-                      </a:pPr>
-                      <a:r>
-                        <a:rPr lang="en-US" sz="1200" b="1" dirty="0">
-                          <a:solidFill>
-                            <a:srgbClr val="004671"/>
-                          </a:solidFill>
-                          <a:latin typeface="Noto Sans" pitchFamily="34" charset="0"/>
-                          <a:ea typeface="Noto Sans" pitchFamily="34" charset="-122"/>
-                          <a:cs typeface="Noto Sans" pitchFamily="34" charset="-120"/>
-                        </a:rPr>
-                        <a:t>Muốn con học giỏi tiếng Anh</a:t>
-                      </a:r>
-                      <a:endParaRPr lang="en-US" sz="1200" dirty="0">
-                        <a:latin typeface="Noto Sans" charset="0"/>
-                        <a:ea typeface="Noto Sans" charset="0"/>
-                        <a:cs typeface="Noto Sans" charset="0"/>
-                      </a:endParaRPr>
-                    </a:p>
-                  </a:txBody>
-                  <a:tcPr marL="101600" marR="101600" marT="63500" marB="63500" anchor="t">
-                    <a:lnL w="9525" cap="flat" cmpd="sng" algn="ctr">
-                      <a:solidFill>
-                        <a:srgbClr val="DCE7EA"/>
-                      </a:solidFill>
-                      <a:prstDash val="solid"/>
-                      <a:round/>
-                      <a:headEnd type="none" w="med" len="med"/>
-                      <a:tailEnd type="none" w="med" len="med"/>
-                    </a:lnL>
-                    <a:lnR w="9525" cap="flat" cmpd="sng" algn="ctr">
-                      <a:solidFill>
-                        <a:srgbClr val="DCE7EA"/>
-                      </a:solidFill>
-                      <a:prstDash val="solid"/>
-                      <a:round/>
-                      <a:headEnd type="none" w="med" len="med"/>
-                      <a:tailEnd type="none" w="med" len="med"/>
-                    </a:lnR>
-                    <a:lnT w="9525" cap="flat" cmpd="sng" algn="ctr">
-                      <a:solidFill>
-                        <a:srgbClr val="DCE7EA"/>
-                      </a:solidFill>
-                      <a:prstDash val="solid"/>
-                      <a:round/>
-                      <a:headEnd type="none" w="med" len="med"/>
-                      <a:tailEnd type="none" w="med" len="med"/>
-                    </a:lnT>
-                    <a:lnB w="9525" cap="flat" cmpd="sng" algn="ctr">
-                      <a:solidFill>
-                        <a:srgbClr val="DCE7EA"/>
-                      </a:solidFill>
-                      <a:prstDash val="solid"/>
-                      <a:round/>
-                      <a:headEnd type="none" w="med" len="med"/>
-                      <a:tailEnd type="none" w="med" len="med"/>
-                    </a:lnB>
-                    <a:solidFill>
-                      <a:srgbClr val="FFFFFF"/>
-                    </a:solidFill>
-                  </a:tcPr>
-                </a:tc>
-              </a:tr>
-              <a:tr h="584650">
-                <a:tc>
-                  <a:txBody>
-                    <a:bodyPr/>
-                    <a:lstStyle/>
-                    <a:p>
-                      <a:pPr indent="0" marL="0">
-                        <a:buNone/>
-                      </a:pPr>
-                      <a:r>
-                        <a:rPr lang="en-US" sz="1200" b="1" dirty="0">
-                          <a:solidFill>
-                            <a:srgbClr val="A5BE00"/>
-                          </a:solidFill>
-                          <a:latin typeface="Noto Sans" pitchFamily="34" charset="0"/>
-                          <a:ea typeface="Noto Sans" pitchFamily="34" charset="-122"/>
-                          <a:cs typeface="Noto Sans" pitchFamily="34" charset="-120"/>
-                        </a:rPr>
-                        <a:t>[Emotional] </a:t>
-                      </a:r>
-                      <a:r>
-                        <a:rPr lang="en-US" sz="1200" dirty="0">
+                        <a:rPr lang="en-US" sz="1100" dirty="0">
                           <a:solidFill>
                             <a:srgbClr val="22333F"/>
                           </a:solidFill>
@@ -8537,215 +10097,9 @@
                           <a:ea typeface="Noto Sans" pitchFamily="34" charset="-122"/>
                           <a:cs typeface="Noto Sans" pitchFamily="34" charset="-120"/>
                         </a:rPr>
-                        <a:t>Yên tâm con tiến bộ thực chất mà không cần tự kèm</a:t>
+                        <a:t>JTBD 1: Đạt thành tích học thuật rõ ràng về Tiếng Anh</a:t>
                       </a:r>
-                      <a:endParaRPr lang="en-US" sz="1200" dirty="0">
-                        <a:latin typeface="Noto Sans" charset="0"/>
-                        <a:ea typeface="Noto Sans" charset="0"/>
-                        <a:cs typeface="Noto Sans" charset="0"/>
-                      </a:endParaRPr>
-                    </a:p>
-                  </a:txBody>
-                  <a:tcPr marL="101600" marR="101600" marT="63500" marB="63500" anchor="t">
-                    <a:lnL w="9525" cap="flat" cmpd="sng" algn="ctr">
-                      <a:solidFill>
-                        <a:srgbClr val="DCE7EA"/>
-                      </a:solidFill>
-                      <a:prstDash val="solid"/>
-                      <a:round/>
-                      <a:headEnd type="none" w="med" len="med"/>
-                      <a:tailEnd type="none" w="med" len="med"/>
-                    </a:lnL>
-                    <a:lnR w="9525" cap="flat" cmpd="sng" algn="ctr">
-                      <a:solidFill>
-                        <a:srgbClr val="DCE7EA"/>
-                      </a:solidFill>
-                      <a:prstDash val="solid"/>
-                      <a:round/>
-                      <a:headEnd type="none" w="med" len="med"/>
-                      <a:tailEnd type="none" w="med" len="med"/>
-                    </a:lnR>
-                    <a:lnT w="9525" cap="flat" cmpd="sng" algn="ctr">
-                      <a:solidFill>
-                        <a:srgbClr val="DCE7EA"/>
-                      </a:solidFill>
-                      <a:prstDash val="solid"/>
-                      <a:round/>
-                      <a:headEnd type="none" w="med" len="med"/>
-                      <a:tailEnd type="none" w="med" len="med"/>
-                    </a:lnT>
-                    <a:lnB w="9525" cap="flat" cmpd="sng" algn="ctr">
-                      <a:solidFill>
-                        <a:srgbClr val="DCE7EA"/>
-                      </a:solidFill>
-                      <a:prstDash val="solid"/>
-                      <a:round/>
-                      <a:headEnd type="none" w="med" len="med"/>
-                      <a:tailEnd type="none" w="med" len="med"/>
-                    </a:lnB>
-                    <a:solidFill>
-                      <a:srgbClr val="F2FAFB"/>
-                    </a:solidFill>
-                  </a:tcPr>
-                </a:tc>
-                <a:tc>
-                  <a:txBody>
-                    <a:bodyPr/>
-                    <a:lstStyle/>
-                    <a:p>
-                      <a:pPr indent="0" marL="0">
-                        <a:buNone/>
-                      </a:pPr>
-                      <a:r>
-                        <a:rPr lang="en-US" sz="1200" dirty="0">
-                          <a:solidFill>
-                            <a:srgbClr val="5B6472"/>
-                          </a:solidFill>
-                          <a:latin typeface="Noto Sans" pitchFamily="34" charset="0"/>
-                          <a:ea typeface="Noto Sans" pitchFamily="34" charset="-122"/>
-                          <a:cs typeface="Noto Sans" pitchFamily="34" charset="-120"/>
-                        </a:rPr>
-                        <a:t>Con học TA chưa tốt; phụ huynh bận, phải nhắc nhở/đốc thúc con</a:t>
-                      </a:r>
-                      <a:endParaRPr lang="en-US" sz="1200" dirty="0">
-                        <a:latin typeface="Noto Sans" charset="0"/>
-                        <a:ea typeface="Noto Sans" charset="0"/>
-                        <a:cs typeface="Noto Sans" charset="0"/>
-                      </a:endParaRPr>
-                    </a:p>
-                  </a:txBody>
-                  <a:tcPr marL="101600" marR="101600" marT="63500" marB="63500" anchor="t">
-                    <a:lnL w="9525" cap="flat" cmpd="sng" algn="ctr">
-                      <a:solidFill>
-                        <a:srgbClr val="DCE7EA"/>
-                      </a:solidFill>
-                      <a:prstDash val="solid"/>
-                      <a:round/>
-                      <a:headEnd type="none" w="med" len="med"/>
-                      <a:tailEnd type="none" w="med" len="med"/>
-                    </a:lnL>
-                    <a:lnR w="9525" cap="flat" cmpd="sng" algn="ctr">
-                      <a:solidFill>
-                        <a:srgbClr val="DCE7EA"/>
-                      </a:solidFill>
-                      <a:prstDash val="solid"/>
-                      <a:round/>
-                      <a:headEnd type="none" w="med" len="med"/>
-                      <a:tailEnd type="none" w="med" len="med"/>
-                    </a:lnR>
-                    <a:lnT w="9525" cap="flat" cmpd="sng" algn="ctr">
-                      <a:solidFill>
-                        <a:srgbClr val="DCE7EA"/>
-                      </a:solidFill>
-                      <a:prstDash val="solid"/>
-                      <a:round/>
-                      <a:headEnd type="none" w="med" len="med"/>
-                      <a:tailEnd type="none" w="med" len="med"/>
-                    </a:lnT>
-                    <a:lnB w="9525" cap="flat" cmpd="sng" algn="ctr">
-                      <a:solidFill>
-                        <a:srgbClr val="DCE7EA"/>
-                      </a:solidFill>
-                      <a:prstDash val="solid"/>
-                      <a:round/>
-                      <a:headEnd type="none" w="med" len="med"/>
-                      <a:tailEnd type="none" w="med" len="med"/>
-                    </a:lnB>
-                    <a:solidFill>
-                      <a:srgbClr val="F2FAFB"/>
-                    </a:solidFill>
-                  </a:tcPr>
-                </a:tc>
-                <a:tc vMerge="1">
-                  <a:txBody>
-                    <a:bodyPr/>
-                    <a:lstStyle/>
-                    <a:p>
-                      <a:pPr indent="0" marL="0">
-                        <a:buNone/>
-                      </a:pPr>
-                      <a:endParaRPr lang="en-US" sz="1200" dirty="0">
-                        <a:latin typeface="Noto Sans" charset="0"/>
-                        <a:ea typeface="Noto Sans" charset="0"/>
-                        <a:cs typeface="Noto Sans" charset="0"/>
-                      </a:endParaRPr>
-                    </a:p>
-                  </a:txBody>
-                  <a:tcPr marL="101600" marR="101600" marT="63500" marB="63500" anchor="t">
-                    <a:lnL w="9525" cap="flat" cmpd="sng" algn="ctr">
-                      <a:solidFill>
-                        <a:srgbClr val="DCE7EA"/>
-                      </a:solidFill>
-                      <a:prstDash val="solid"/>
-                      <a:round/>
-                      <a:headEnd type="none" w="med" len="med"/>
-                      <a:tailEnd type="none" w="med" len="med"/>
-                    </a:lnL>
-                    <a:lnR w="9525" cap="flat" cmpd="sng" algn="ctr">
-                      <a:solidFill>
-                        <a:srgbClr val="DCE7EA"/>
-                      </a:solidFill>
-                      <a:prstDash val="solid"/>
-                      <a:round/>
-                      <a:headEnd type="none" w="med" len="med"/>
-                      <a:tailEnd type="none" w="med" len="med"/>
-                    </a:lnR>
-                    <a:lnT w="9525" cap="flat" cmpd="sng" algn="ctr">
-                      <a:solidFill>
-                        <a:srgbClr val="DCE7EA"/>
-                      </a:solidFill>
-                      <a:prstDash val="solid"/>
-                      <a:round/>
-                      <a:headEnd type="none" w="med" len="med"/>
-                      <a:tailEnd type="none" w="med" len="med"/>
-                    </a:lnT>
-                    <a:lnB w="9525" cap="flat" cmpd="sng" algn="ctr">
-                      <a:solidFill>
-                        <a:srgbClr val="DCE7EA"/>
-                      </a:solidFill>
-                      <a:prstDash val="solid"/>
-                      <a:round/>
-                      <a:headEnd type="none" w="med" len="med"/>
-                      <a:tailEnd type="none" w="med" len="med"/>
-                    </a:lnB>
-                    <a:solidFill>
-                      <a:srgbClr val="FFFFFF"/>
-                    </a:solidFill>
-                  </a:tcPr>
-                </a:tc>
-              </a:tr>
-              <a:tr h="584650">
-                <a:tc>
-                  <a:txBody>
-                    <a:bodyPr/>
-                    <a:lstStyle/>
-                    <a:p>
-                      <a:pPr indent="0" marL="0">
-                        <a:buNone/>
-                      </a:pPr>
-                      <a:r>
-                        <a:rPr lang="en-US" sz="1200" b="1" dirty="0">
-                          <a:solidFill>
-                            <a:srgbClr val="3B81B1"/>
-                          </a:solidFill>
-                          <a:latin typeface="Noto Sans" pitchFamily="34" charset="0"/>
-                          <a:ea typeface="Noto Sans" pitchFamily="34" charset="-122"/>
-                          <a:cs typeface="Noto Sans" pitchFamily="34" charset="-120"/>
-                        </a:rPr>
-                        <a:t>[Functional] </a:t>
-                      </a:r>
-                      <a:r>
-                        <a:rPr lang="en-US" sz="1200" dirty="0">
-                          <a:solidFill>
-                            <a:srgbClr val="22333F"/>
-                          </a:solidFill>
-                          <a:latin typeface="Noto Sans" pitchFamily="34" charset="0"/>
-                          <a:ea typeface="Noto Sans" pitchFamily="34" charset="-122"/>
-                          <a:cs typeface="Noto Sans" pitchFamily="34" charset="-120"/>
-                        </a:rPr>
-                        <a:t>Muốn con phát triển toàn diện, không học lệch</a:t>
-                      </a:r>
-                      <a:endParaRPr lang="en-US" sz="1200" dirty="0">
+                      <a:endParaRPr lang="en-US" sz="1100" dirty="0">
                         <a:latin typeface="Noto Sans" charset="0"/>
                         <a:ea typeface="Noto Sans" charset="0"/>
                         <a:cs typeface="Noto Sans" charset="0"/>
@@ -8803,17 +10157,17 @@
                         <a:buNone/>
                       </a:pPr>
                       <a:r>
-                        <a:rPr lang="en-US" sz="1200" dirty="0">
+                        <a:rPr lang="en-US" sz="1100" b="1" dirty="0">
                           <a:solidFill>
-                            <a:srgbClr val="5B6472"/>
+                            <a:srgbClr val="518E0D"/>
                           </a:solidFill>
                           <a:latin typeface="Noto Sans" pitchFamily="34" charset="0"/>
                           <a:ea typeface="Noto Sans" pitchFamily="34" charset="-122"/>
                           <a:cs typeface="Noto Sans" pitchFamily="34" charset="-120"/>
                         </a:rPr>
-                        <a:t>◆ Con học lệch, thiếu cân bằng giữa các môn (giả định đa môn, chưa xác nhận)</a:t>
+                        <a:t>Đã giải quyết</a:t>
                       </a:r>
-                      <a:endParaRPr lang="en-US" sz="1200" dirty="0">
+                      <a:endParaRPr lang="en-US" sz="1100" dirty="0">
                         <a:latin typeface="Noto Sans" charset="0"/>
                         <a:ea typeface="Noto Sans" charset="0"/>
                         <a:cs typeface="Noto Sans" charset="0"/>
@@ -8862,76 +10216,8 @@
                     </a:solidFill>
                   </a:tcPr>
                 </a:tc>
-                <a:tc rowSpan="3">
-                  <a:txBody>
-                    <a:bodyPr/>
-                    <a:lstStyle/>
-                    <a:p>
-                      <a:pPr indent="0" marL="0">
-                        <a:buNone/>
-                      </a:pPr>
-                      <a:r>
-                        <a:rPr lang="en-US" sz="1200" b="1" dirty="0">
-                          <a:solidFill>
-                            <a:srgbClr val="004671"/>
-                          </a:solidFill>
-                          <a:latin typeface="Noto Sans" pitchFamily="34" charset="0"/>
-                          <a:ea typeface="Noto Sans" pitchFamily="34" charset="-122"/>
-                          <a:cs typeface="Noto Sans" pitchFamily="34" charset="-120"/>
-                        </a:rPr>
-                        <a:t>Muốn con học giỏi toàn diện</a:t>
-                      </a:r>
-                      <a:endParaRPr lang="en-US" sz="1200" dirty="0">
-                        <a:latin typeface="Noto Sans" charset="0"/>
-                        <a:ea typeface="Noto Sans" charset="0"/>
-                        <a:cs typeface="Noto Sans" charset="0"/>
-                      </a:endParaRPr>
-                    </a:p>
-                  </a:txBody>
-                  <a:tcPr marL="101600" marR="101600" marT="63500" marB="63500" anchor="t">
-                    <a:lnL w="9525" cap="flat" cmpd="sng" algn="ctr">
-                      <a:solidFill>
-                        <a:srgbClr val="DCE7EA"/>
-                      </a:solidFill>
-                      <a:prstDash val="solid"/>
-                      <a:round/>
-                      <a:headEnd type="none" w="med" len="med"/>
-                      <a:tailEnd type="none" w="med" len="med"/>
-                    </a:lnL>
-                    <a:lnR w="9525" cap="flat" cmpd="sng" algn="ctr">
-                      <a:solidFill>
-                        <a:srgbClr val="DCE7EA"/>
-                      </a:solidFill>
-                      <a:prstDash val="solid"/>
-                      <a:round/>
-                      <a:headEnd type="none" w="med" len="med"/>
-                      <a:tailEnd type="none" w="med" len="med"/>
-                    </a:lnR>
-                    <a:lnT w="9525" cap="flat" cmpd="sng" algn="ctr">
-                      <a:solidFill>
-                        <a:srgbClr val="DCE7EA"/>
-                      </a:solidFill>
-                      <a:prstDash val="solid"/>
-                      <a:round/>
-                      <a:headEnd type="none" w="med" len="med"/>
-                      <a:tailEnd type="none" w="med" len="med"/>
-                    </a:lnT>
-                    <a:lnB w="9525" cap="flat" cmpd="sng" algn="ctr">
-                      <a:solidFill>
-                        <a:srgbClr val="DCE7EA"/>
-                      </a:solidFill>
-                      <a:prstDash val="solid"/>
-                      <a:round/>
-                      <a:headEnd type="none" w="med" len="med"/>
-                      <a:tailEnd type="none" w="med" len="med"/>
-                    </a:lnB>
-                    <a:solidFill>
-                      <a:srgbClr val="F2FAFB"/>
-                    </a:solidFill>
-                  </a:tcPr>
-                </a:tc>
               </a:tr>
-              <a:tr h="584650">
+              <a:tr h="628650">
                 <a:tc>
                   <a:txBody>
                     <a:bodyPr/>
@@ -8941,234 +10227,17 @@
                         <a:buNone/>
                       </a:pPr>
                       <a:r>
-                        <a:rPr lang="en-US" sz="1200" b="1" dirty="0">
+                        <a:rPr lang="en-US" sz="1100" b="1" dirty="0">
                           <a:solidFill>
-                            <a:srgbClr val="3B81B1"/>
+                            <a:srgbClr val="004671"/>
                           </a:solidFill>
                           <a:latin typeface="Noto Sans" pitchFamily="34" charset="0"/>
                           <a:ea typeface="Noto Sans" pitchFamily="34" charset="-122"/>
                           <a:cs typeface="Noto Sans" pitchFamily="34" charset="-120"/>
                         </a:rPr>
-                        <a:t>[Functional] </a:t>
+                        <a:t>AI Speak — 1h luyện nói</a:t>
                       </a:r>
-                      <a:r>
-                        <a:rPr lang="en-US" sz="1200" dirty="0">
-                          <a:solidFill>
-                            <a:srgbClr val="22333F"/>
-                          </a:solidFill>
-                          <a:latin typeface="Noto Sans" pitchFamily="34" charset="0"/>
-                          <a:ea typeface="Noto Sans" pitchFamily="34" charset="-122"/>
-                          <a:cs typeface="Noto Sans" pitchFamily="34" charset="-120"/>
-                        </a:rPr>
-                        <a:t>Quản lý toàn bộ việc học của con ở một nơi, không phải tự tổng hợp</a:t>
-                      </a:r>
-                      <a:endParaRPr lang="en-US" sz="1200" dirty="0">
-                        <a:latin typeface="Noto Sans" charset="0"/>
-                        <a:ea typeface="Noto Sans" charset="0"/>
-                        <a:cs typeface="Noto Sans" charset="0"/>
-                      </a:endParaRPr>
-                    </a:p>
-                  </a:txBody>
-                  <a:tcPr marL="101600" marR="101600" marT="63500" marB="63500" anchor="t">
-                    <a:lnL w="9525" cap="flat" cmpd="sng" algn="ctr">
-                      <a:solidFill>
-                        <a:srgbClr val="DCE7EA"/>
-                      </a:solidFill>
-                      <a:prstDash val="solid"/>
-                      <a:round/>
-                      <a:headEnd type="none" w="med" len="med"/>
-                      <a:tailEnd type="none" w="med" len="med"/>
-                    </a:lnL>
-                    <a:lnR w="9525" cap="flat" cmpd="sng" algn="ctr">
-                      <a:solidFill>
-                        <a:srgbClr val="DCE7EA"/>
-                      </a:solidFill>
-                      <a:prstDash val="solid"/>
-                      <a:round/>
-                      <a:headEnd type="none" w="med" len="med"/>
-                      <a:tailEnd type="none" w="med" len="med"/>
-                    </a:lnR>
-                    <a:lnT w="9525" cap="flat" cmpd="sng" algn="ctr">
-                      <a:solidFill>
-                        <a:srgbClr val="DCE7EA"/>
-                      </a:solidFill>
-                      <a:prstDash val="solid"/>
-                      <a:round/>
-                      <a:headEnd type="none" w="med" len="med"/>
-                      <a:tailEnd type="none" w="med" len="med"/>
-                    </a:lnT>
-                    <a:lnB w="9525" cap="flat" cmpd="sng" algn="ctr">
-                      <a:solidFill>
-                        <a:srgbClr val="DCE7EA"/>
-                      </a:solidFill>
-                      <a:prstDash val="solid"/>
-                      <a:round/>
-                      <a:headEnd type="none" w="med" len="med"/>
-                      <a:tailEnd type="none" w="med" len="med"/>
-                    </a:lnB>
-                    <a:solidFill>
-                      <a:srgbClr val="F2FAFB"/>
-                    </a:solidFill>
-                  </a:tcPr>
-                </a:tc>
-                <a:tc>
-                  <a:txBody>
-                    <a:bodyPr/>
-                    <a:lstStyle/>
-                    <a:p>
-                      <a:pPr indent="0" marL="0">
-                        <a:buNone/>
-                      </a:pPr>
-                      <a:r>
-                        <a:rPr lang="en-US" sz="1200" dirty="0">
-                          <a:solidFill>
-                            <a:srgbClr val="5B6472"/>
-                          </a:solidFill>
-                          <a:latin typeface="Noto Sans" pitchFamily="34" charset="0"/>
-                          <a:ea typeface="Noto Sans" pitchFamily="34" charset="-122"/>
-                          <a:cs typeface="Noto Sans" pitchFamily="34" charset="-120"/>
-                        </a:rPr>
-                        <a:t>Khó quản lý khi con học nhiều môn/nhiều trung tâm</a:t>
-                      </a:r>
-                      <a:endParaRPr lang="en-US" sz="1200" dirty="0">
-                        <a:latin typeface="Noto Sans" charset="0"/>
-                        <a:ea typeface="Noto Sans" charset="0"/>
-                        <a:cs typeface="Noto Sans" charset="0"/>
-                      </a:endParaRPr>
-                    </a:p>
-                  </a:txBody>
-                  <a:tcPr marL="101600" marR="101600" marT="63500" marB="63500" anchor="t">
-                    <a:lnL w="9525" cap="flat" cmpd="sng" algn="ctr">
-                      <a:solidFill>
-                        <a:srgbClr val="DCE7EA"/>
-                      </a:solidFill>
-                      <a:prstDash val="solid"/>
-                      <a:round/>
-                      <a:headEnd type="none" w="med" len="med"/>
-                      <a:tailEnd type="none" w="med" len="med"/>
-                    </a:lnL>
-                    <a:lnR w="9525" cap="flat" cmpd="sng" algn="ctr">
-                      <a:solidFill>
-                        <a:srgbClr val="DCE7EA"/>
-                      </a:solidFill>
-                      <a:prstDash val="solid"/>
-                      <a:round/>
-                      <a:headEnd type="none" w="med" len="med"/>
-                      <a:tailEnd type="none" w="med" len="med"/>
-                    </a:lnR>
-                    <a:lnT w="9525" cap="flat" cmpd="sng" algn="ctr">
-                      <a:solidFill>
-                        <a:srgbClr val="DCE7EA"/>
-                      </a:solidFill>
-                      <a:prstDash val="solid"/>
-                      <a:round/>
-                      <a:headEnd type="none" w="med" len="med"/>
-                      <a:tailEnd type="none" w="med" len="med"/>
-                    </a:lnT>
-                    <a:lnB w="9525" cap="flat" cmpd="sng" algn="ctr">
-                      <a:solidFill>
-                        <a:srgbClr val="DCE7EA"/>
-                      </a:solidFill>
-                      <a:prstDash val="solid"/>
-                      <a:round/>
-                      <a:headEnd type="none" w="med" len="med"/>
-                      <a:tailEnd type="none" w="med" len="med"/>
-                    </a:lnB>
-                    <a:solidFill>
-                      <a:srgbClr val="F2FAFB"/>
-                    </a:solidFill>
-                  </a:tcPr>
-                </a:tc>
-                <a:tc vMerge="1">
-                  <a:txBody>
-                    <a:bodyPr/>
-                    <a:lstStyle/>
-                    <a:p>
-                      <a:pPr indent="0" marL="0">
-                        <a:buNone/>
-                      </a:pPr>
-                      <a:endParaRPr lang="en-US" sz="1200" dirty="0">
-                        <a:latin typeface="Noto Sans" charset="0"/>
-                        <a:ea typeface="Noto Sans" charset="0"/>
-                        <a:cs typeface="Noto Sans" charset="0"/>
-                      </a:endParaRPr>
-                    </a:p>
-                  </a:txBody>
-                  <a:tcPr marL="101600" marR="101600" marT="63500" marB="63500" anchor="t">
-                    <a:lnL w="9525" cap="flat" cmpd="sng" algn="ctr">
-                      <a:solidFill>
-                        <a:srgbClr val="DCE7EA"/>
-                      </a:solidFill>
-                      <a:prstDash val="solid"/>
-                      <a:round/>
-                      <a:headEnd type="none" w="med" len="med"/>
-                      <a:tailEnd type="none" w="med" len="med"/>
-                    </a:lnL>
-                    <a:lnR w="9525" cap="flat" cmpd="sng" algn="ctr">
-                      <a:solidFill>
-                        <a:srgbClr val="DCE7EA"/>
-                      </a:solidFill>
-                      <a:prstDash val="solid"/>
-                      <a:round/>
-                      <a:headEnd type="none" w="med" len="med"/>
-                      <a:tailEnd type="none" w="med" len="med"/>
-                    </a:lnR>
-                    <a:lnT w="9525" cap="flat" cmpd="sng" algn="ctr">
-                      <a:solidFill>
-                        <a:srgbClr val="DCE7EA"/>
-                      </a:solidFill>
-                      <a:prstDash val="solid"/>
-                      <a:round/>
-                      <a:headEnd type="none" w="med" len="med"/>
-                      <a:tailEnd type="none" w="med" len="med"/>
-                    </a:lnT>
-                    <a:lnB w="9525" cap="flat" cmpd="sng" algn="ctr">
-                      <a:solidFill>
-                        <a:srgbClr val="DCE7EA"/>
-                      </a:solidFill>
-                      <a:prstDash val="solid"/>
-                      <a:round/>
-                      <a:headEnd type="none" w="med" len="med"/>
-                      <a:tailEnd type="none" w="med" len="med"/>
-                    </a:lnB>
-                    <a:solidFill>
-                      <a:srgbClr val="F2FAFB"/>
-                    </a:solidFill>
-                  </a:tcPr>
-                </a:tc>
-              </a:tr>
-              <a:tr h="584650">
-                <a:tc>
-                  <a:txBody>
-                    <a:bodyPr/>
-                    <a:lstStyle/>
-                    <a:p>
-                      <a:pPr indent="0" marL="0">
-                        <a:buNone/>
-                      </a:pPr>
-                      <a:r>
-                        <a:rPr lang="en-US" sz="1200" b="1" dirty="0">
-                          <a:solidFill>
-                            <a:srgbClr val="3B81B1"/>
-                          </a:solidFill>
-                          <a:latin typeface="Noto Sans" pitchFamily="34" charset="0"/>
-                          <a:ea typeface="Noto Sans" pitchFamily="34" charset="-122"/>
-                          <a:cs typeface="Noto Sans" pitchFamily="34" charset="-120"/>
-                        </a:rPr>
-                        <a:t>[Functional] </a:t>
-                      </a:r>
-                      <a:r>
-                        <a:rPr lang="en-US" sz="1200" dirty="0">
-                          <a:solidFill>
-                            <a:srgbClr val="22333F"/>
-                          </a:solidFill>
-                          <a:latin typeface="Noto Sans" pitchFamily="34" charset="0"/>
-                          <a:ea typeface="Noto Sans" pitchFamily="34" charset="-122"/>
-                          <a:cs typeface="Noto Sans" pitchFamily="34" charset="-120"/>
-                        </a:rPr>
-                        <a:t>Duy trì việc học hiệu quả trong khả năng chi trả lâu dài</a:t>
-                      </a:r>
-                      <a:endParaRPr lang="en-US" sz="1200" dirty="0">
+                      <a:endParaRPr lang="en-US" sz="1100" dirty="0">
                         <a:latin typeface="Noto Sans" charset="0"/>
                         <a:ea typeface="Noto Sans" charset="0"/>
                         <a:cs typeface="Noto Sans" charset="0"/>
@@ -9226,145 +10295,7 @@
                         <a:buNone/>
                       </a:pPr>
                       <a:r>
-                        <a:rPr lang="en-US" sz="1200" dirty="0">
-                          <a:solidFill>
-                            <a:srgbClr val="5B6472"/>
-                          </a:solidFill>
-                          <a:latin typeface="Noto Sans" pitchFamily="34" charset="0"/>
-                          <a:ea typeface="Noto Sans" pitchFamily="34" charset="-122"/>
-                          <a:cs typeface="Noto Sans" pitchFamily="34" charset="-120"/>
-                        </a:rPr>
-                        <a:t>Chi phí cộng dồn nhiều lớp/trung tâm; tốn thời gian đưa đón</a:t>
-                      </a:r>
-                      <a:endParaRPr lang="en-US" sz="1200" dirty="0">
-                        <a:latin typeface="Noto Sans" charset="0"/>
-                        <a:ea typeface="Noto Sans" charset="0"/>
-                        <a:cs typeface="Noto Sans" charset="0"/>
-                      </a:endParaRPr>
-                    </a:p>
-                  </a:txBody>
-                  <a:tcPr marL="101600" marR="101600" marT="63500" marB="63500" anchor="t">
-                    <a:lnL w="9525" cap="flat" cmpd="sng" algn="ctr">
-                      <a:solidFill>
-                        <a:srgbClr val="DCE7EA"/>
-                      </a:solidFill>
-                      <a:prstDash val="solid"/>
-                      <a:round/>
-                      <a:headEnd type="none" w="med" len="med"/>
-                      <a:tailEnd type="none" w="med" len="med"/>
-                    </a:lnL>
-                    <a:lnR w="9525" cap="flat" cmpd="sng" algn="ctr">
-                      <a:solidFill>
-                        <a:srgbClr val="DCE7EA"/>
-                      </a:solidFill>
-                      <a:prstDash val="solid"/>
-                      <a:round/>
-                      <a:headEnd type="none" w="med" len="med"/>
-                      <a:tailEnd type="none" w="med" len="med"/>
-                    </a:lnR>
-                    <a:lnT w="9525" cap="flat" cmpd="sng" algn="ctr">
-                      <a:solidFill>
-                        <a:srgbClr val="DCE7EA"/>
-                      </a:solidFill>
-                      <a:prstDash val="solid"/>
-                      <a:round/>
-                      <a:headEnd type="none" w="med" len="med"/>
-                      <a:tailEnd type="none" w="med" len="med"/>
-                    </a:lnT>
-                    <a:lnB w="9525" cap="flat" cmpd="sng" algn="ctr">
-                      <a:solidFill>
-                        <a:srgbClr val="DCE7EA"/>
-                      </a:solidFill>
-                      <a:prstDash val="solid"/>
-                      <a:round/>
-                      <a:headEnd type="none" w="med" len="med"/>
-                      <a:tailEnd type="none" w="med" len="med"/>
-                    </a:lnB>
-                    <a:solidFill>
-                      <a:srgbClr val="FFFFFF"/>
-                    </a:solidFill>
-                  </a:tcPr>
-                </a:tc>
-                <a:tc vMerge="1">
-                  <a:txBody>
-                    <a:bodyPr/>
-                    <a:lstStyle/>
-                    <a:p>
-                      <a:pPr indent="0" marL="0">
-                        <a:buNone/>
-                      </a:pPr>
-                      <a:endParaRPr lang="en-US" sz="1200" dirty="0">
-                        <a:latin typeface="Noto Sans" charset="0"/>
-                        <a:ea typeface="Noto Sans" charset="0"/>
-                        <a:cs typeface="Noto Sans" charset="0"/>
-                      </a:endParaRPr>
-                    </a:p>
-                  </a:txBody>
-                  <a:tcPr marL="101600" marR="101600" marT="63500" marB="63500" anchor="t">
-                    <a:lnL w="9525" cap="flat" cmpd="sng" algn="ctr">
-                      <a:solidFill>
-                        <a:srgbClr val="DCE7EA"/>
-                      </a:solidFill>
-                      <a:prstDash val="solid"/>
-                      <a:round/>
-                      <a:headEnd type="none" w="med" len="med"/>
-                      <a:tailEnd type="none" w="med" len="med"/>
-                    </a:lnL>
-                    <a:lnR w="9525" cap="flat" cmpd="sng" algn="ctr">
-                      <a:solidFill>
-                        <a:srgbClr val="DCE7EA"/>
-                      </a:solidFill>
-                      <a:prstDash val="solid"/>
-                      <a:round/>
-                      <a:headEnd type="none" w="med" len="med"/>
-                      <a:tailEnd type="none" w="med" len="med"/>
-                    </a:lnR>
-                    <a:lnT w="9525" cap="flat" cmpd="sng" algn="ctr">
-                      <a:solidFill>
-                        <a:srgbClr val="DCE7EA"/>
-                      </a:solidFill>
-                      <a:prstDash val="solid"/>
-                      <a:round/>
-                      <a:headEnd type="none" w="med" len="med"/>
-                      <a:tailEnd type="none" w="med" len="med"/>
-                    </a:lnT>
-                    <a:lnB w="9525" cap="flat" cmpd="sng" algn="ctr">
-                      <a:solidFill>
-                        <a:srgbClr val="DCE7EA"/>
-                      </a:solidFill>
-                      <a:prstDash val="solid"/>
-                      <a:round/>
-                      <a:headEnd type="none" w="med" len="med"/>
-                      <a:tailEnd type="none" w="med" len="med"/>
-                    </a:lnB>
-                    <a:solidFill>
-                      <a:srgbClr val="F2FAFB"/>
-                    </a:solidFill>
-                  </a:tcPr>
-                </a:tc>
-              </a:tr>
-              <a:tr h="584650">
-                <a:tc>
-                  <a:txBody>
-                    <a:bodyPr/>
-                    <a:lstStyle/>
-                    <a:p>
-                      <a:pPr indent="0" marL="0">
-                        <a:buNone/>
-                      </a:pPr>
-                      <a:r>
-                        <a:rPr lang="en-US" sz="1200" b="1" dirty="0">
-                          <a:solidFill>
-                            <a:srgbClr val="3B81B1"/>
-                          </a:solidFill>
-                          <a:latin typeface="Noto Sans" pitchFamily="34" charset="0"/>
-                          <a:ea typeface="Noto Sans" pitchFamily="34" charset="-122"/>
-                          <a:cs typeface="Noto Sans" pitchFamily="34" charset="-120"/>
-                        </a:rPr>
-                        <a:t>[Functional] </a:t>
-                      </a:r>
-                      <a:r>
-                        <a:rPr lang="en-US" sz="1200" dirty="0">
+                        <a:rPr lang="en-US" sz="1100" dirty="0">
                           <a:solidFill>
                             <a:srgbClr val="22333F"/>
                           </a:solidFill>
@@ -9372,226 +10303,9 @@
                           <a:ea typeface="Noto Sans" pitchFamily="34" charset="-122"/>
                           <a:cs typeface="Noto Sans" pitchFamily="34" charset="-120"/>
                         </a:rPr>
-                        <a:t>Có người giám sát, đốc thúc con học thay bố mẹ, con được học cá nhân hóa</a:t>
+                        <a:t>JTBD 2: Tự tin giao tiếp bằng tiếng Anh trong thực tế</a:t>
                       </a:r>
-                      <a:endParaRPr lang="en-US" sz="1200" dirty="0">
-                        <a:latin typeface="Noto Sans" charset="0"/>
-                        <a:ea typeface="Noto Sans" charset="0"/>
-                        <a:cs typeface="Noto Sans" charset="0"/>
-                      </a:endParaRPr>
-                    </a:p>
-                  </a:txBody>
-                  <a:tcPr marL="101600" marR="101600" marT="63500" marB="63500" anchor="t">
-                    <a:lnL w="9525" cap="flat" cmpd="sng" algn="ctr">
-                      <a:solidFill>
-                        <a:srgbClr val="DCE7EA"/>
-                      </a:solidFill>
-                      <a:prstDash val="solid"/>
-                      <a:round/>
-                      <a:headEnd type="none" w="med" len="med"/>
-                      <a:tailEnd type="none" w="med" len="med"/>
-                    </a:lnL>
-                    <a:lnR w="9525" cap="flat" cmpd="sng" algn="ctr">
-                      <a:solidFill>
-                        <a:srgbClr val="DCE7EA"/>
-                      </a:solidFill>
-                      <a:prstDash val="solid"/>
-                      <a:round/>
-                      <a:headEnd type="none" w="med" len="med"/>
-                      <a:tailEnd type="none" w="med" len="med"/>
-                    </a:lnR>
-                    <a:lnT w="9525" cap="flat" cmpd="sng" algn="ctr">
-                      <a:solidFill>
-                        <a:srgbClr val="DCE7EA"/>
-                      </a:solidFill>
-                      <a:prstDash val="solid"/>
-                      <a:round/>
-                      <a:headEnd type="none" w="med" len="med"/>
-                      <a:tailEnd type="none" w="med" len="med"/>
-                    </a:lnT>
-                    <a:lnB w="9525" cap="flat" cmpd="sng" algn="ctr">
-                      <a:solidFill>
-                        <a:srgbClr val="DCE7EA"/>
-                      </a:solidFill>
-                      <a:prstDash val="solid"/>
-                      <a:round/>
-                      <a:headEnd type="none" w="med" len="med"/>
-                      <a:tailEnd type="none" w="med" len="med"/>
-                    </a:lnB>
-                    <a:solidFill>
-                      <a:srgbClr val="F2FAFB"/>
-                    </a:solidFill>
-                  </a:tcPr>
-                </a:tc>
-                <a:tc>
-                  <a:txBody>
-                    <a:bodyPr/>
-                    <a:lstStyle/>
-                    <a:p>
-                      <a:pPr indent="0" marL="0">
-                        <a:buNone/>
-                      </a:pPr>
-                      <a:r>
-                        <a:rPr lang="en-US" sz="1200" dirty="0">
-                          <a:solidFill>
-                            <a:srgbClr val="5B6472"/>
-                          </a:solidFill>
-                          <a:latin typeface="Noto Sans" pitchFamily="34" charset="0"/>
-                          <a:ea typeface="Noto Sans" pitchFamily="34" charset="-122"/>
-                          <a:cs typeface="Noto Sans" pitchFamily="34" charset="-120"/>
-                        </a:rPr>
-                        <a:t>Phụ huynh phải liên tục nhắc nhở, đốc thúc vì con chưa tự giác</a:t>
-                      </a:r>
-                      <a:endParaRPr lang="en-US" sz="1200" dirty="0">
-                        <a:latin typeface="Noto Sans" charset="0"/>
-                        <a:ea typeface="Noto Sans" charset="0"/>
-                        <a:cs typeface="Noto Sans" charset="0"/>
-                      </a:endParaRPr>
-                    </a:p>
-                  </a:txBody>
-                  <a:tcPr marL="101600" marR="101600" marT="63500" marB="63500" anchor="t">
-                    <a:lnL w="9525" cap="flat" cmpd="sng" algn="ctr">
-                      <a:solidFill>
-                        <a:srgbClr val="DCE7EA"/>
-                      </a:solidFill>
-                      <a:prstDash val="solid"/>
-                      <a:round/>
-                      <a:headEnd type="none" w="med" len="med"/>
-                      <a:tailEnd type="none" w="med" len="med"/>
-                    </a:lnL>
-                    <a:lnR w="9525" cap="flat" cmpd="sng" algn="ctr">
-                      <a:solidFill>
-                        <a:srgbClr val="DCE7EA"/>
-                      </a:solidFill>
-                      <a:prstDash val="solid"/>
-                      <a:round/>
-                      <a:headEnd type="none" w="med" len="med"/>
-                      <a:tailEnd type="none" w="med" len="med"/>
-                    </a:lnR>
-                    <a:lnT w="9525" cap="flat" cmpd="sng" algn="ctr">
-                      <a:solidFill>
-                        <a:srgbClr val="DCE7EA"/>
-                      </a:solidFill>
-                      <a:prstDash val="solid"/>
-                      <a:round/>
-                      <a:headEnd type="none" w="med" len="med"/>
-                      <a:tailEnd type="none" w="med" len="med"/>
-                    </a:lnT>
-                    <a:lnB w="9525" cap="flat" cmpd="sng" algn="ctr">
-                      <a:solidFill>
-                        <a:srgbClr val="DCE7EA"/>
-                      </a:solidFill>
-                      <a:prstDash val="solid"/>
-                      <a:round/>
-                      <a:headEnd type="none" w="med" len="med"/>
-                      <a:tailEnd type="none" w="med" len="med"/>
-                    </a:lnB>
-                    <a:solidFill>
-                      <a:srgbClr val="F2FAFB"/>
-                    </a:solidFill>
-                  </a:tcPr>
-                </a:tc>
-                <a:tc rowSpan="3">
-                  <a:txBody>
-                    <a:bodyPr/>
-                    <a:lstStyle/>
-                    <a:p>
-                      <a:pPr indent="0" marL="0">
-                        <a:buNone/>
-                      </a:pPr>
-                      <a:r>
-                        <a:rPr lang="en-US" sz="1200" b="1" dirty="0">
-                          <a:solidFill>
-                            <a:srgbClr val="004671"/>
-                          </a:solidFill>
-                          <a:latin typeface="Noto Sans" pitchFamily="34" charset="0"/>
-                          <a:ea typeface="Noto Sans" pitchFamily="34" charset="-122"/>
-                          <a:cs typeface="Noto Sans" pitchFamily="34" charset="-120"/>
-                        </a:rPr>
-                        <a:t>Muốn con được đồng hành, đốc thúc học tập</a:t>
-                      </a:r>
-                      <a:endParaRPr lang="en-US" sz="1200" dirty="0">
-                        <a:latin typeface="Noto Sans" charset="0"/>
-                        <a:ea typeface="Noto Sans" charset="0"/>
-                        <a:cs typeface="Noto Sans" charset="0"/>
-                      </a:endParaRPr>
-                    </a:p>
-                  </a:txBody>
-                  <a:tcPr marL="101600" marR="101600" marT="63500" marB="63500" anchor="t">
-                    <a:lnL w="9525" cap="flat" cmpd="sng" algn="ctr">
-                      <a:solidFill>
-                        <a:srgbClr val="DCE7EA"/>
-                      </a:solidFill>
-                      <a:prstDash val="solid"/>
-                      <a:round/>
-                      <a:headEnd type="none" w="med" len="med"/>
-                      <a:tailEnd type="none" w="med" len="med"/>
-                    </a:lnL>
-                    <a:lnR w="9525" cap="flat" cmpd="sng" algn="ctr">
-                      <a:solidFill>
-                        <a:srgbClr val="DCE7EA"/>
-                      </a:solidFill>
-                      <a:prstDash val="solid"/>
-                      <a:round/>
-                      <a:headEnd type="none" w="med" len="med"/>
-                      <a:tailEnd type="none" w="med" len="med"/>
-                    </a:lnR>
-                    <a:lnT w="9525" cap="flat" cmpd="sng" algn="ctr">
-                      <a:solidFill>
-                        <a:srgbClr val="DCE7EA"/>
-                      </a:solidFill>
-                      <a:prstDash val="solid"/>
-                      <a:round/>
-                      <a:headEnd type="none" w="med" len="med"/>
-                      <a:tailEnd type="none" w="med" len="med"/>
-                    </a:lnT>
-                    <a:lnB w="9525" cap="flat" cmpd="sng" algn="ctr">
-                      <a:solidFill>
-                        <a:srgbClr val="DCE7EA"/>
-                      </a:solidFill>
-                      <a:prstDash val="solid"/>
-                      <a:round/>
-                      <a:headEnd type="none" w="med" len="med"/>
-                      <a:tailEnd type="none" w="med" len="med"/>
-                    </a:lnB>
-                    <a:solidFill>
-                      <a:srgbClr val="FFFFFF"/>
-                    </a:solidFill>
-                  </a:tcPr>
-                </a:tc>
-              </a:tr>
-              <a:tr h="584650">
-                <a:tc>
-                  <a:txBody>
-                    <a:bodyPr/>
-                    <a:lstStyle/>
-                    <a:p>
-                      <a:pPr indent="0" marL="0">
-                        <a:buNone/>
-                      </a:pPr>
-                      <a:r>
-                        <a:rPr lang="en-US" sz="1200" b="1" dirty="0">
-                          <a:solidFill>
-                            <a:srgbClr val="A5BE00"/>
-                          </a:solidFill>
-                          <a:latin typeface="Noto Sans" pitchFamily="34" charset="0"/>
-                          <a:ea typeface="Noto Sans" pitchFamily="34" charset="-122"/>
-                          <a:cs typeface="Noto Sans" pitchFamily="34" charset="-120"/>
-                        </a:rPr>
-                        <a:t>[Emotional] </a:t>
-                      </a:r>
-                      <a:r>
-                        <a:rPr lang="en-US" sz="1200" dirty="0">
-                          <a:solidFill>
-                            <a:srgbClr val="22333F"/>
-                          </a:solidFill>
-                          <a:latin typeface="Noto Sans" pitchFamily="34" charset="0"/>
-                          <a:ea typeface="Noto Sans" pitchFamily="34" charset="-122"/>
-                          <a:cs typeface="Noto Sans" pitchFamily="34" charset="-120"/>
-                        </a:rPr>
-                        <a:t>Tin mình đã chọn đúng, đầu tư đủ, không thua kém gia đình khác</a:t>
-                      </a:r>
-                      <a:endParaRPr lang="en-US" sz="1200" dirty="0">
+                      <a:endParaRPr lang="en-US" sz="1100" dirty="0">
                         <a:latin typeface="Noto Sans" charset="0"/>
                         <a:ea typeface="Noto Sans" charset="0"/>
                         <a:cs typeface="Noto Sans" charset="0"/>
@@ -9649,17 +10363,17 @@
                         <a:buNone/>
                       </a:pPr>
                       <a:r>
-                        <a:rPr lang="en-US" sz="1200" dirty="0">
+                        <a:rPr lang="en-US" sz="1100" b="1" dirty="0">
                           <a:solidFill>
-                            <a:srgbClr val="5B6472"/>
+                            <a:srgbClr val="518E0D"/>
                           </a:solidFill>
                           <a:latin typeface="Noto Sans" pitchFamily="34" charset="0"/>
                           <a:ea typeface="Noto Sans" pitchFamily="34" charset="-122"/>
                           <a:cs typeface="Noto Sans" pitchFamily="34" charset="-120"/>
                         </a:rPr>
-                        <a:t>Học online "không ai quản" nên không yên tâm; sợ mất tiền mà không hiệu quả</a:t>
+                        <a:t>Đã giải quyết</a:t>
                       </a:r>
-                      <a:endParaRPr lang="en-US" sz="1200" dirty="0">
+                      <a:endParaRPr lang="en-US" sz="1100" dirty="0">
                         <a:latin typeface="Noto Sans" charset="0"/>
                         <a:ea typeface="Noto Sans" charset="0"/>
                         <a:cs typeface="Noto Sans" charset="0"/>
@@ -9708,65 +10422,8 @@
                     </a:solidFill>
                   </a:tcPr>
                 </a:tc>
-                <a:tc vMerge="1">
-                  <a:txBody>
-                    <a:bodyPr/>
-                    <a:lstStyle/>
-                    <a:p>
-                      <a:pPr indent="0" marL="0">
-                        <a:buNone/>
-                      </a:pPr>
-                      <a:endParaRPr lang="en-US" sz="1200" dirty="0">
-                        <a:latin typeface="Noto Sans" charset="0"/>
-                        <a:ea typeface="Noto Sans" charset="0"/>
-                        <a:cs typeface="Noto Sans" charset="0"/>
-                      </a:endParaRPr>
-                    </a:p>
-                  </a:txBody>
-                  <a:tcPr marL="101600" marR="101600" marT="63500" marB="63500" anchor="t">
-                    <a:lnL w="9525" cap="flat" cmpd="sng" algn="ctr">
-                      <a:solidFill>
-                        <a:srgbClr val="DCE7EA"/>
-                      </a:solidFill>
-                      <a:prstDash val="solid"/>
-                      <a:round/>
-                      <a:headEnd type="none" w="med" len="med"/>
-                      <a:tailEnd type="none" w="med" len="med"/>
-                    </a:lnL>
-                    <a:lnR w="9525" cap="flat" cmpd="sng" algn="ctr">
-                      <a:solidFill>
-                        <a:srgbClr val="DCE7EA"/>
-                      </a:solidFill>
-                      <a:prstDash val="solid"/>
-                      <a:round/>
-                      <a:headEnd type="none" w="med" len="med"/>
-                      <a:tailEnd type="none" w="med" len="med"/>
-                    </a:lnR>
-                    <a:lnT w="9525" cap="flat" cmpd="sng" algn="ctr">
-                      <a:solidFill>
-                        <a:srgbClr val="DCE7EA"/>
-                      </a:solidFill>
-                      <a:prstDash val="solid"/>
-                      <a:round/>
-                      <a:headEnd type="none" w="med" len="med"/>
-                      <a:tailEnd type="none" w="med" len="med"/>
-                    </a:lnT>
-                    <a:lnB w="9525" cap="flat" cmpd="sng" algn="ctr">
-                      <a:solidFill>
-                        <a:srgbClr val="DCE7EA"/>
-                      </a:solidFill>
-                      <a:prstDash val="solid"/>
-                      <a:round/>
-                      <a:headEnd type="none" w="med" len="med"/>
-                      <a:tailEnd type="none" w="med" len="med"/>
-                    </a:lnB>
-                    <a:solidFill>
-                      <a:srgbClr val="FFFFFF"/>
-                    </a:solidFill>
-                  </a:tcPr>
-                </a:tc>
               </a:tr>
-              <a:tr h="584650">
+              <a:tr h="628650">
                 <a:tc>
                   <a:txBody>
                     <a:bodyPr/>
@@ -9776,7 +10433,7 @@
                         <a:buNone/>
                       </a:pPr>
                       <a:r>
-                        <a:rPr lang="en-US" sz="1200" b="1" dirty="0">
+                        <a:rPr lang="en-US" sz="1100" b="1" dirty="0">
                           <a:solidFill>
                             <a:srgbClr val="004671"/>
                           </a:solidFill>
@@ -9784,20 +10441,9 @@
                           <a:ea typeface="Noto Sans" pitchFamily="34" charset="-122"/>
                           <a:cs typeface="Noto Sans" pitchFamily="34" charset="-120"/>
                         </a:rPr>
-                        <a:t>[Social] </a:t>
+                        <a:t>Edupia Club — Quốc tế</a:t>
                       </a:r>
-                      <a:r>
-                        <a:rPr lang="en-US" sz="1200" dirty="0">
-                          <a:solidFill>
-                            <a:srgbClr val="22333F"/>
-                          </a:solidFill>
-                          <a:latin typeface="Noto Sans" pitchFamily="34" charset="0"/>
-                          <a:ea typeface="Noto Sans" pitchFamily="34" charset="-122"/>
-                          <a:cs typeface="Noto Sans" pitchFamily="34" charset="-120"/>
-                        </a:rPr>
-                        <a:t>Hãnh diện, tự hào với người thân, bạn bè khi con đạt thành tích cao, muốn chia sẻ</a:t>
-                      </a:r>
-                      <a:endParaRPr lang="en-US" sz="1200" dirty="0">
+                      <a:endParaRPr lang="en-US" sz="1100" dirty="0">
                         <a:latin typeface="Noto Sans" charset="0"/>
                         <a:ea typeface="Noto Sans" charset="0"/>
                         <a:cs typeface="Noto Sans" charset="0"/>
@@ -9842,7 +10488,7 @@
                       <a:tailEnd type="none" w="med" len="med"/>
                     </a:lnB>
                     <a:solidFill>
-                      <a:srgbClr val="F2FAFB"/>
+                      <a:srgbClr val="FFFFFF"/>
                     </a:solidFill>
                   </a:tcPr>
                 </a:tc>
@@ -9855,17 +10501,17 @@
                         <a:buNone/>
                       </a:pPr>
                       <a:r>
-                        <a:rPr lang="en-US" sz="1200" dirty="0">
+                        <a:rPr lang="en-US" sz="1100" dirty="0">
                           <a:solidFill>
-                            <a:srgbClr val="5B6472"/>
+                            <a:srgbClr val="22333F"/>
                           </a:solidFill>
                           <a:latin typeface="Noto Sans" pitchFamily="34" charset="0"/>
                           <a:ea typeface="Noto Sans" pitchFamily="34" charset="-122"/>
                           <a:cs typeface="Noto Sans" pitchFamily="34" charset="-120"/>
                         </a:rPr>
-                        <a:t>Lo con thua thiệt, thua kém "con nhà người ta"</a:t>
+                        <a:t>JTBD 3: Nuôi dưỡng sự yêu thích và tự giác học</a:t>
                       </a:r>
-                      <a:endParaRPr lang="en-US" sz="1200" dirty="0">
+                      <a:endParaRPr lang="en-US" sz="1100" dirty="0">
                         <a:latin typeface="Noto Sans" charset="0"/>
                         <a:ea typeface="Noto Sans" charset="0"/>
                         <a:cs typeface="Noto Sans" charset="0"/>
@@ -9910,11 +10556,11 @@
                       <a:tailEnd type="none" w="med" len="med"/>
                     </a:lnB>
                     <a:solidFill>
-                      <a:srgbClr val="F2FAFB"/>
+                      <a:srgbClr val="FFFFFF"/>
                     </a:solidFill>
                   </a:tcPr>
                 </a:tc>
-                <a:tc vMerge="1">
+                <a:tc>
                   <a:txBody>
                     <a:bodyPr/>
                     <a:lstStyle/>
@@ -9922,7 +10568,224 @@
                       <a:pPr indent="0" marL="0">
                         <a:buNone/>
                       </a:pPr>
-                      <a:endParaRPr lang="en-US" sz="1200" dirty="0">
+                      <a:r>
+                        <a:rPr lang="en-US" sz="1100" b="1" dirty="0">
+                          <a:solidFill>
+                            <a:srgbClr val="518E0D"/>
+                          </a:solidFill>
+                          <a:latin typeface="Noto Sans" pitchFamily="34" charset="0"/>
+                          <a:ea typeface="Noto Sans" pitchFamily="34" charset="-122"/>
+                          <a:cs typeface="Noto Sans" pitchFamily="34" charset="-120"/>
+                        </a:rPr>
+                        <a:t>Đã giải quyết</a:t>
+                      </a:r>
+                      <a:endParaRPr lang="en-US" sz="1100" dirty="0">
+                        <a:latin typeface="Noto Sans" charset="0"/>
+                        <a:ea typeface="Noto Sans" charset="0"/>
+                        <a:cs typeface="Noto Sans" charset="0"/>
+                      </a:endParaRPr>
+                    </a:p>
+                  </a:txBody>
+                  <a:tcPr marL="101600" marR="101600" marT="63500" marB="63500" anchor="t">
+                    <a:lnL w="9525" cap="flat" cmpd="sng" algn="ctr">
+                      <a:solidFill>
+                        <a:srgbClr val="DCE7EA"/>
+                      </a:solidFill>
+                      <a:prstDash val="solid"/>
+                      <a:round/>
+                      <a:headEnd type="none" w="med" len="med"/>
+                      <a:tailEnd type="none" w="med" len="med"/>
+                    </a:lnL>
+                    <a:lnR w="9525" cap="flat" cmpd="sng" algn="ctr">
+                      <a:solidFill>
+                        <a:srgbClr val="DCE7EA"/>
+                      </a:solidFill>
+                      <a:prstDash val="solid"/>
+                      <a:round/>
+                      <a:headEnd type="none" w="med" len="med"/>
+                      <a:tailEnd type="none" w="med" len="med"/>
+                    </a:lnR>
+                    <a:lnT w="9525" cap="flat" cmpd="sng" algn="ctr">
+                      <a:solidFill>
+                        <a:srgbClr val="DCE7EA"/>
+                      </a:solidFill>
+                      <a:prstDash val="solid"/>
+                      <a:round/>
+                      <a:headEnd type="none" w="med" len="med"/>
+                      <a:tailEnd type="none" w="med" len="med"/>
+                    </a:lnT>
+                    <a:lnB w="9525" cap="flat" cmpd="sng" algn="ctr">
+                      <a:solidFill>
+                        <a:srgbClr val="DCE7EA"/>
+                      </a:solidFill>
+                      <a:prstDash val="solid"/>
+                      <a:round/>
+                      <a:headEnd type="none" w="med" len="med"/>
+                      <a:tailEnd type="none" w="med" len="med"/>
+                    </a:lnB>
+                    <a:solidFill>
+                      <a:srgbClr val="FFFFFF"/>
+                    </a:solidFill>
+                  </a:tcPr>
+                </a:tc>
+              </a:tr>
+              <a:tr h="628650">
+                <a:tc>
+                  <a:txBody>
+                    <a:bodyPr/>
+                    <a:lstStyle/>
+                    <a:p>
+                      <a:pPr indent="0" marL="0">
+                        <a:buNone/>
+                      </a:pPr>
+                      <a:r>
+                        <a:rPr lang="en-US" sz="1100" b="1" dirty="0">
+                          <a:solidFill>
+                            <a:srgbClr val="004671"/>
+                          </a:solidFill>
+                          <a:latin typeface="Noto Sans" pitchFamily="34" charset="0"/>
+                          <a:ea typeface="Noto Sans" pitchFamily="34" charset="-122"/>
+                          <a:cs typeface="Noto Sans" pitchFamily="34" charset="-120"/>
+                        </a:rPr>
+                        <a:t>GVCN kèm con</a:t>
+                      </a:r>
+                      <a:endParaRPr lang="en-US" sz="1100" dirty="0">
+                        <a:latin typeface="Noto Sans" charset="0"/>
+                        <a:ea typeface="Noto Sans" charset="0"/>
+                        <a:cs typeface="Noto Sans" charset="0"/>
+                      </a:endParaRPr>
+                    </a:p>
+                  </a:txBody>
+                  <a:tcPr marL="101600" marR="101600" marT="63500" marB="63500" anchor="t">
+                    <a:lnL w="9525" cap="flat" cmpd="sng" algn="ctr">
+                      <a:solidFill>
+                        <a:srgbClr val="DCE7EA"/>
+                      </a:solidFill>
+                      <a:prstDash val="solid"/>
+                      <a:round/>
+                      <a:headEnd type="none" w="med" len="med"/>
+                      <a:tailEnd type="none" w="med" len="med"/>
+                    </a:lnL>
+                    <a:lnR w="9525" cap="flat" cmpd="sng" algn="ctr">
+                      <a:solidFill>
+                        <a:srgbClr val="DCE7EA"/>
+                      </a:solidFill>
+                      <a:prstDash val="solid"/>
+                      <a:round/>
+                      <a:headEnd type="none" w="med" len="med"/>
+                      <a:tailEnd type="none" w="med" len="med"/>
+                    </a:lnR>
+                    <a:lnT w="9525" cap="flat" cmpd="sng" algn="ctr">
+                      <a:solidFill>
+                        <a:srgbClr val="DCE7EA"/>
+                      </a:solidFill>
+                      <a:prstDash val="solid"/>
+                      <a:round/>
+                      <a:headEnd type="none" w="med" len="med"/>
+                      <a:tailEnd type="none" w="med" len="med"/>
+                    </a:lnT>
+                    <a:lnB w="9525" cap="flat" cmpd="sng" algn="ctr">
+                      <a:solidFill>
+                        <a:srgbClr val="DCE7EA"/>
+                      </a:solidFill>
+                      <a:prstDash val="solid"/>
+                      <a:round/>
+                      <a:headEnd type="none" w="med" len="med"/>
+                      <a:tailEnd type="none" w="med" len="med"/>
+                    </a:lnB>
+                    <a:solidFill>
+                      <a:srgbClr val="FFFFFF"/>
+                    </a:solidFill>
+                  </a:tcPr>
+                </a:tc>
+                <a:tc>
+                  <a:txBody>
+                    <a:bodyPr/>
+                    <a:lstStyle/>
+                    <a:p>
+                      <a:pPr indent="0" marL="0">
+                        <a:buNone/>
+                      </a:pPr>
+                      <a:r>
+                        <a:rPr lang="en-US" sz="1100" dirty="0">
+                          <a:solidFill>
+                            <a:srgbClr val="22333F"/>
+                          </a:solidFill>
+                          <a:latin typeface="Noto Sans" pitchFamily="34" charset="0"/>
+                          <a:ea typeface="Noto Sans" pitchFamily="34" charset="-122"/>
+                          <a:cs typeface="Noto Sans" pitchFamily="34" charset="-120"/>
+                        </a:rPr>
+                        <a:t>JTBD 4: Giải phóng thời gian và áp lực kèm con cho bố mẹ</a:t>
+                      </a:r>
+                      <a:endParaRPr lang="en-US" sz="1100" dirty="0">
+                        <a:latin typeface="Noto Sans" charset="0"/>
+                        <a:ea typeface="Noto Sans" charset="0"/>
+                        <a:cs typeface="Noto Sans" charset="0"/>
+                      </a:endParaRPr>
+                    </a:p>
+                  </a:txBody>
+                  <a:tcPr marL="101600" marR="101600" marT="63500" marB="63500" anchor="t">
+                    <a:lnL w="9525" cap="flat" cmpd="sng" algn="ctr">
+                      <a:solidFill>
+                        <a:srgbClr val="DCE7EA"/>
+                      </a:solidFill>
+                      <a:prstDash val="solid"/>
+                      <a:round/>
+                      <a:headEnd type="none" w="med" len="med"/>
+                      <a:tailEnd type="none" w="med" len="med"/>
+                    </a:lnL>
+                    <a:lnR w="9525" cap="flat" cmpd="sng" algn="ctr">
+                      <a:solidFill>
+                        <a:srgbClr val="DCE7EA"/>
+                      </a:solidFill>
+                      <a:prstDash val="solid"/>
+                      <a:round/>
+                      <a:headEnd type="none" w="med" len="med"/>
+                      <a:tailEnd type="none" w="med" len="med"/>
+                    </a:lnR>
+                    <a:lnT w="9525" cap="flat" cmpd="sng" algn="ctr">
+                      <a:solidFill>
+                        <a:srgbClr val="DCE7EA"/>
+                      </a:solidFill>
+                      <a:prstDash val="solid"/>
+                      <a:round/>
+                      <a:headEnd type="none" w="med" len="med"/>
+                      <a:tailEnd type="none" w="med" len="med"/>
+                    </a:lnT>
+                    <a:lnB w="9525" cap="flat" cmpd="sng" algn="ctr">
+                      <a:solidFill>
+                        <a:srgbClr val="DCE7EA"/>
+                      </a:solidFill>
+                      <a:prstDash val="solid"/>
+                      <a:round/>
+                      <a:headEnd type="none" w="med" len="med"/>
+                      <a:tailEnd type="none" w="med" len="med"/>
+                    </a:lnB>
+                    <a:solidFill>
+                      <a:srgbClr val="FFFFFF"/>
+                    </a:solidFill>
+                  </a:tcPr>
+                </a:tc>
+                <a:tc>
+                  <a:txBody>
+                    <a:bodyPr/>
+                    <a:lstStyle/>
+                    <a:p>
+                      <a:pPr indent="0" marL="0">
+                        <a:buNone/>
+                      </a:pPr>
+                      <a:r>
+                        <a:rPr lang="en-US" sz="1100" b="1" dirty="0">
+                          <a:solidFill>
+                            <a:srgbClr val="22333F"/>
+                          </a:solidFill>
+                          <a:latin typeface="Noto Sans" pitchFamily="34" charset="0"/>
+                          <a:ea typeface="Noto Sans" pitchFamily="34" charset="-122"/>
+                          <a:cs typeface="Noto Sans" pitchFamily="34" charset="-120"/>
+                        </a:rPr>
+                        <a:t>⚠ Chưa rõ ràng</a:t>
+                      </a:r>
+                      <a:endParaRPr lang="en-US" sz="1100" dirty="0">
                         <a:latin typeface="Noto Sans" charset="0"/>
                         <a:ea typeface="Noto Sans" charset="0"/>
                         <a:cs typeface="Noto Sans" charset="0"/>
@@ -9976,16 +10839,139 @@
           </a:graphicData>
         </a:graphic>
       </p:graphicFrame>
+      <p:sp>
+        <p:nvSpPr>
+          <p:cNvPr id="13" name="Text 10">
+</p:cNvPr>
+          <p:cNvSpPr/>
+          <p:nvPr>
+</p:nvPr>
+        </p:nvSpPr>
+        <p:spPr>
+          <a:xfrm>
+            <a:off x="502920" y="5000000"/>
+            <a:ext cx="11183112" cy="550000"/>
+          </a:xfrm>
+          <a:prstGeom prst="rect">
+            <a:avLst>
+</a:avLst>
+          </a:prstGeom>
+          <a:noFill/>
+          <a:ln>
+</a:ln>
+        </p:spPr>
+        <p:txBody>
+          <a:bodyPr wrap="square" rtlCol="0" anchor="t">
+            <a:normAutofit/>
+          </a:bodyPr>
+          <a:lstStyle/>
+          <a:p>
+            <a:pPr indent="0" marL="0">
+              <a:lnSpc>
+                <a:spcPct val="105000"/>
+              </a:lnSpc>
+              <a:buNone/>
+            </a:pPr>
+            <a:r>
+              <a:rPr lang="en-US" sz="1100" b="1" dirty="0">
+                <a:solidFill>
+                  <a:srgbClr val="004671"/>
+                </a:solidFill>
+                <a:latin typeface="Noto Sans" pitchFamily="34" charset="0"/>
+                <a:ea typeface="Noto Sans" pitchFamily="34" charset="-122"/>
+                <a:cs typeface="Noto Sans" pitchFamily="34" charset="-120"/>
+              </a:rPr>
+              <a:t>Nhóm II — Phát triển toàn diện, giỏi đều các môn: </a:t>
+            </a:r>
+            <a:r>
+              <a:rPr lang="en-US" sz="1100" dirty="0">
+                <a:solidFill>
+                  <a:srgbClr val="22333F"/>
+                </a:solidFill>
+                <a:latin typeface="Noto Sans" pitchFamily="34" charset="0"/>
+                <a:ea typeface="Noto Sans" pitchFamily="34" charset="-122"/>
+                <a:cs typeface="Noto Sans" pitchFamily="34" charset="-120"/>
+              </a:rPr>
+              <a:t>⚠ Concept hiện tại chưa đáp ứng được nhu cầu này — cả 3 JTBD ở Slide 6 đều chưa có cấu phần sản phẩm nào giải quyết.</a:t>
+            </a:r>
+            <a:endParaRPr lang="en-US" sz="1100" dirty="0"/>
+          </a:p>
+        </p:txBody>
+      </p:sp>
+      <p:sp>
+        <p:nvSpPr>
+          <p:cNvPr id="14" name="Text 11">
+</p:cNvPr>
+          <p:cNvSpPr/>
+          <p:nvPr>
+</p:nvPr>
+        </p:nvSpPr>
+        <p:spPr>
+          <a:xfrm>
+            <a:off x="502920" y="5620000"/>
+            <a:ext cx="11183112" cy="750000"/>
+          </a:xfrm>
+          <a:prstGeom prst="rect">
+            <a:avLst>
+</a:avLst>
+          </a:prstGeom>
+          <a:solidFill>
+            <a:srgbClr val="F2FAFB"/>
+          </a:solidFill>
+          <a:ln>
+</a:ln>
+        </p:spPr>
+        <p:txBody>
+          <a:bodyPr wrap="square" rtlCol="0" anchor="t">
+            <a:normAutofit/>
+          </a:bodyPr>
+          <a:lstStyle/>
+          <a:p>
+            <a:pPr indent="0" marL="101600">
+              <a:lnSpc>
+                <a:spcPct val="105000"/>
+              </a:lnSpc>
+              <a:buNone/>
+            </a:pPr>
+            <a:r>
+              <a:rPr lang="en-US" sz="1100" b="1" dirty="0">
+                <a:solidFill>
+                  <a:srgbClr val="004671"/>
+                </a:solidFill>
+                <a:latin typeface="Noto Sans" pitchFamily="34" charset="0"/>
+                <a:ea typeface="Noto Sans" pitchFamily="34" charset="-122"/>
+                <a:cs typeface="Noto Sans" pitchFamily="34" charset="-120"/>
+              </a:rPr>
+              <a:t>Đánh giá tổng thể: </a:t>
+            </a:r>
+            <a:r>
+              <a:rPr lang="en-US" sz="1100" dirty="0">
+                <a:solidFill>
+                  <a:srgbClr val="22333F"/>
+                </a:solidFill>
+                <a:latin typeface="Noto Sans" pitchFamily="34" charset="0"/>
+                <a:ea typeface="Noto Sans" pitchFamily="34" charset="-122"/>
+                <a:cs typeface="Noto Sans" pitchFamily="34" charset="-120"/>
+              </a:rPr>
+              <a:t>Concept hiện tại giải quyết tốt 3/4 JTBD ở Nhóm I, còn khoảng trống rõ ở JTBD 4 và hoàn toàn chưa chạm tới Nhóm II — đây là 2 khoảng trống mà 3 định hướng concept ở Phần 3 cần trả lời.</a:t>
+            </a:r>
+            <a:endParaRPr lang="en-US" sz="1100" dirty="0"/>
+          </a:p>
+        </p:txBody>
+      </p:sp>
       <p:pic>
         <p:nvPicPr>
-          <p:cNvPr id="7" name="Image 1"/>
+          <p:cNvPr id="7" name="Image 1">
+</p:cNvPr>
           <p:cNvPicPr>
             <a:picLocks noChangeAspect="1"/>
           </p:cNvPicPr>
-          <p:nvPr/>
+          <p:nvPr>
+</p:nvPr>
         </p:nvPicPr>
         <p:blipFill>
-          <a:blip r:embed="rId2"/>
+          <a:blip r:embed="rId2">
+</a:blip>
           <a:stretch>
             <a:fillRect/>
           </a:stretch>
@@ -10002,9 +10988,11 @@
       </p:pic>
       <p:sp>
         <p:nvSpPr>
-          <p:cNvPr id="8" name="Text 3"/>
-          <p:cNvSpPr/>
-          <p:nvPr/>
+          <p:cNvPr id="8" name="Text 3">
+</p:cNvPr>
+          <p:cNvSpPr/>
+          <p:nvPr>
+</p:nvPr>
         </p:nvSpPr>
         <p:spPr>
           <a:xfrm>
@@ -10012,13 +11000,16 @@
             <a:ext cx="3657600" cy="256032"/>
           </a:xfrm>
           <a:prstGeom prst="rect">
-            <a:avLst/>
+            <a:avLst>
+</a:avLst>
           </a:prstGeom>
           <a:noFill/>
-          <a:ln/>
+          <a:ln>
+</a:ln>
         </p:spPr>
         <p:txBody>
-          <a:bodyPr wrap="square" rtlCol="0" anchor="ctr"/>
+          <a:bodyPr wrap="square" rtlCol="0" anchor="ctr">
+</a:bodyPr>
           <a:lstStyle/>
           <a:p>
             <a:pPr indent="0" marL="0">
@@ -10041,9 +11032,11 @@
       </p:sp>
       <p:sp>
         <p:nvSpPr>
-          <p:cNvPr id="9" name="Text 4"/>
-          <p:cNvSpPr/>
-          <p:nvPr/>
+          <p:cNvPr id="9" name="Text 4">
+</p:cNvPr>
+          <p:cNvSpPr/>
+          <p:nvPr>
+</p:nvPr>
         </p:nvSpPr>
         <p:spPr>
           <a:xfrm>
@@ -10051,13 +11044,16 @@
             <a:ext cx="914400" cy="256032"/>
           </a:xfrm>
           <a:prstGeom prst="rect">
-            <a:avLst/>
+            <a:avLst>
+</a:avLst>
           </a:prstGeom>
           <a:noFill/>
-          <a:ln/>
+          <a:ln>
+</a:ln>
         </p:spPr>
         <p:txBody>
-          <a:bodyPr wrap="square" rtlCol="0" anchor="ctr"/>
+          <a:bodyPr wrap="square" rtlCol="0" anchor="ctr">
+</a:bodyPr>
           <a:lstStyle/>
           <a:p>
             <a:pPr algn="r" indent="0" marL="0">
@@ -10072,7 +11068,7 @@
                 <a:ea typeface="Noto Sans" pitchFamily="34" charset="-122"/>
                 <a:cs typeface="Noto Sans" pitchFamily="34" charset="-120"/>
               </a:rPr>
-              <a:t>4 / 12</a:t>
+              <a:t>6 / 14</a:t>
             </a:r>
             <a:endParaRPr lang="en-US" sz="850" dirty="0"/>
           </a:p>
@@ -10789,7 +11785,7 @@
                 <a:ea typeface="Noto Sans" pitchFamily="34" charset="-122"/>
                 <a:cs typeface="Noto Sans" pitchFamily="34" charset="-120"/>
               </a:rPr>
-              <a:t>1 / 12</a:t>
+              <a:t>1 / 14</a:t>
             </a:r>
             <a:endParaRPr lang="en-US" sz="850" dirty="0"/>
           </a:p>
@@ -11414,7 +12410,7 @@
                 <a:ea typeface="Noto Sans" pitchFamily="34" charset="-122"/>
                 <a:cs typeface="Noto Sans" pitchFamily="34" charset="-120"/>
               </a:rPr>
-              <a:t>2 / 12</a:t>
+              <a:t>2 / 14</a:t>
             </a:r>
             <a:endParaRPr lang="en-US" sz="850" dirty="0"/>
           </a:p>
@@ -12517,7 +13513,7 @@
                 <a:ea typeface="Noto Sans" pitchFamily="34" charset="-122"/>
                 <a:cs typeface="Noto Sans" pitchFamily="34" charset="-120"/>
               </a:rPr>
-              <a:t>5 / 12</a:t>
+              <a:t>7 / 14</a:t>
             </a:r>
             <a:endParaRPr lang="en-US" sz="850" dirty="0"/>
           </a:p>
@@ -13923,7 +14919,7 @@
                 <a:ea typeface="Noto Sans" pitchFamily="34" charset="-122"/>
                 <a:cs typeface="Noto Sans" pitchFamily="34" charset="-120"/>
               </a:rPr>
-              <a:t>6 / 12</a:t>
+              <a:t>8 / 14</a:t>
             </a:r>
             <a:endParaRPr lang="en-US" sz="850" dirty="0"/>
           </a:p>
@@ -14989,7 +15985,7 @@
                 <a:ea typeface="Noto Sans" pitchFamily="34" charset="-122"/>
                 <a:cs typeface="Noto Sans" pitchFamily="34" charset="-120"/>
               </a:rPr>
-              <a:t>7 / 12</a:t>
+              <a:t>9 / 14</a:t>
             </a:r>
             <a:endParaRPr lang="en-US" sz="850" dirty="0"/>
           </a:p>
@@ -15730,7 +16726,7 @@
                 <a:ea typeface="Noto Sans" pitchFamily="34" charset="-122"/>
                 <a:cs typeface="Noto Sans" pitchFamily="34" charset="-120"/>
               </a:rPr>
-              <a:t>8 / 12</a:t>
+              <a:t>10 / 14</a:t>
             </a:r>
             <a:endParaRPr lang="en-US" sz="850" dirty="0"/>
           </a:p>
@@ -16333,7 +17329,7 @@
                 <a:ea typeface="Noto Sans" pitchFamily="34" charset="-122"/>
                 <a:cs typeface="Noto Sans" pitchFamily="34" charset="-120"/>
               </a:rPr>
-              <a:t>9 / 12</a:t>
+              <a:t>11 / 14</a:t>
             </a:r>
             <a:endParaRPr lang="en-US" sz="850" dirty="0"/>
           </a:p>

</xml_diff>

<commit_message>
bổ sung nội dung phân tích phản biện concept
</commit_message>
<xml_diff>
--- a/03_product/concepts/AI-Class-New-slide-deck-FINAL-2026-08-21-branded.pptx
+++ b/03_product/concepts/AI-Class-New-slide-deck-FINAL-2026-08-21-branded.pptx
@@ -20,6 +20,7 @@
     <p:sldId id="265" r:id="rId11"/>
     <p:sldId id="266" r:id="rId12"/>
     <p:sldId id="267" r:id="rId13"/>
+    <p:sldId id="272" r:id="rId23"/>
   </p:sldIdLst>
   <p:notesMasterIdLst>
     <p:notesMasterId r:id="rId14"/>
@@ -11082,6 +11083,1681 @@
 </p:sld>
 </file>
 
+<file path=ppt/slides/slide17.xml><?xml version="1.0" encoding="utf-8"?>
+<p:sld xmlns:a="http://schemas.openxmlformats.org/drawingml/2006/main" xmlns:r="http://schemas.openxmlformats.org/officeDocument/2006/relationships" xmlns:p="http://schemas.openxmlformats.org/presentationml/2006/main">
+  <p:cSld name="Slide 17">
+    <p:bg>
+      <p:bgPr>
+        <a:solidFill>
+          <a:srgbClr val="FFFFFF"/>
+        </a:solidFill>
+      </p:bgPr>
+    </p:bg>
+    <p:spTree>
+      <p:nvGrpSpPr>
+        <p:cNvPr id="1" name=""/>
+        <p:cNvGrpSpPr/>
+        <p:nvPr/>
+      </p:nvGrpSpPr>
+      <p:grpSpPr>
+        <a:xfrm>
+          <a:off x="0" y="0"/>
+          <a:ext cx="0" cy="0"/>
+          <a:chOff x="0" y="0"/>
+          <a:chExt cx="0" cy="0"/>
+        </a:xfrm>
+      </p:grpSpPr>
+      <p:sp>
+        <p:nvSpPr>
+          <p:cNvPr id="2" name="Text 0"/>
+          <p:cNvSpPr/>
+          <p:nvPr/>
+        </p:nvSpPr>
+        <p:spPr>
+          <a:xfrm>
+            <a:off x="502920" y="292608"/>
+            <a:ext cx="11183112" cy="274320"/>
+          </a:xfrm>
+          <a:prstGeom prst="rect">
+            <a:avLst/>
+          </a:prstGeom>
+          <a:noFill/>
+          <a:ln/>
+        </p:spPr>
+        <p:txBody>
+          <a:bodyPr wrap="square" rtlCol="0" anchor="ctr"/>
+          <a:lstStyle/>
+          <a:p>
+            <a:pPr indent="0" marL="0">
+              <a:lnSpc>
+                <a:spcPct val="102000"/>
+              </a:lnSpc>
+              <a:spcAft>
+                <a:spcPts val="0"/>
+              </a:spcAft>
+              <a:buNone/>
+            </a:pPr>
+            <a:r>
+              <a:rPr lang="en-US" sz="1100" b="1" dirty="0">
+                <a:solidFill>
+                  <a:srgbClr val="3B81B1"/>
+                </a:solidFill>
+                <a:latin typeface="Noto Sans" pitchFamily="34" charset="0"/>
+                <a:ea typeface="Noto Sans" pitchFamily="34" charset="-122"/>
+                <a:cs typeface="Noto Sans" pitchFamily="34" charset="-120"/>
+              </a:rPr>
+              <a:t>PHỤ LỤC — HƯỚNG PHÂN TÍCH JTBD THAY THẾ</a:t>
+            </a:r>
+            <a:endParaRPr lang="en-US" sz="1100" dirty="0"/>
+          </a:p>
+        </p:txBody>
+      </p:sp>
+      <p:sp>
+        <p:nvSpPr>
+          <p:cNvPr id="3" name="Text 1"/>
+          <p:cNvSpPr/>
+          <p:nvPr/>
+        </p:nvSpPr>
+        <p:spPr>
+          <a:xfrm>
+            <a:off x="502920" y="548640"/>
+            <a:ext cx="11183112" cy="520000"/>
+          </a:xfrm>
+          <a:prstGeom prst="rect">
+            <a:avLst/>
+          </a:prstGeom>
+          <a:noFill/>
+          <a:ln/>
+        </p:spPr>
+        <p:txBody>
+          <a:bodyPr wrap="square" rtlCol="0" anchor="ctr"/>
+          <a:lstStyle/>
+          <a:p>
+            <a:pPr indent="0" marL="0">
+              <a:lnSpc>
+                <a:spcPct val="102000"/>
+              </a:lnSpc>
+              <a:spcAft>
+                <a:spcPts val="0"/>
+              </a:spcAft>
+              <a:buNone/>
+            </a:pPr>
+            <a:r>
+              <a:rPr lang="en-US" sz="2600" b="1" dirty="0">
+                <a:solidFill>
+                  <a:srgbClr val="004671"/>
+                </a:solidFill>
+                <a:latin typeface="Noto Sans" pitchFamily="34" charset="0"/>
+                <a:ea typeface="Noto Sans" pitchFamily="34" charset="-122"/>
+                <a:cs typeface="Noto Sans" pitchFamily="34" charset="-120"/>
+              </a:rPr>
+              <a:t>Phân tích sâu JTBD — góc nhìn đầy đủ 3 tầng</a:t>
+            </a:r>
+            <a:endParaRPr lang="en-US" sz="2600" dirty="0"/>
+          </a:p>
+        </p:txBody>
+      </p:sp>
+      <p:sp>
+        <p:nvSpPr>
+          <p:cNvPr id="4" name="Shape 2"/>
+          <p:cNvSpPr/>
+          <p:nvPr/>
+        </p:nvSpPr>
+        <p:spPr>
+          <a:xfrm>
+            <a:off x="502920" y="1170432"/>
+            <a:ext cx="777240" cy="45720"/>
+          </a:xfrm>
+          <a:prstGeom prst="rect">
+            <a:avLst/>
+          </a:prstGeom>
+          <a:solidFill>
+            <a:srgbClr val="A5BE00"/>
+          </a:solidFill>
+          <a:ln/>
+        </p:spPr>
+      </p:sp>
+      <p:pic>
+        <p:nvPicPr>
+          <p:cNvPr id="5" name="Image 0"/>
+          <p:cNvPicPr>
+            <a:picLocks noChangeAspect="1"/>
+          </p:cNvPicPr>
+          <p:nvPr/>
+        </p:nvPicPr>
+        <p:blipFill>
+          <a:blip r:embed="rId1"/>
+          <a:stretch>
+            <a:fillRect/>
+          </a:stretch>
+        </p:blipFill>
+        <p:spPr>
+          <a:xfrm>
+            <a:off x="11292840" y="365760"/>
+            <a:ext cx="502920" cy="502920"/>
+          </a:xfrm>
+          <a:prstGeom prst="rect">
+            <a:avLst/>
+          </a:prstGeom>
+        </p:spPr>
+      </p:pic>
+      <p:sp>
+        <p:nvSpPr>
+          <p:cNvPr id="6" name="Text 3"/>
+          <p:cNvSpPr/>
+          <p:nvPr/>
+        </p:nvSpPr>
+        <p:spPr>
+          <a:xfrm>
+            <a:off x="502920" y="1230000"/>
+            <a:ext cx="10600000" cy="560000"/>
+          </a:xfrm>
+          <a:prstGeom prst="rect">
+            <a:avLst/>
+          </a:prstGeom>
+          <a:noFill/>
+          <a:ln/>
+        </p:spPr>
+        <p:txBody>
+          <a:bodyPr wrap="square" rtlCol="0" anchor="t">
+            <a:normAutofit/>
+          </a:bodyPr>
+          <a:lstStyle/>
+          <a:p>
+            <a:pPr indent="0" marL="0">
+              <a:lnSpc>
+                <a:spcPct val="105000"/>
+              </a:lnSpc>
+              <a:spcAft>
+                <a:spcPts val="0"/>
+              </a:spcAft>
+              <a:buNone/>
+            </a:pPr>
+            <a:r>
+              <a:rPr lang="en-US" sz="1000" i="1" dirty="0">
+                <a:solidFill>
+                  <a:srgbClr val="5B6472"/>
+                </a:solidFill>
+                <a:latin typeface="Noto Sans" pitchFamily="34" charset="0"/>
+                <a:ea typeface="Noto Sans" pitchFamily="34" charset="-122"/>
+                <a:cs typeface="Noto Sans" pitchFamily="34" charset="-120"/>
+              </a:rPr>
+              <a:t>Giữ đủ 3 tầng Chức năng / Cảm xúc / Xã hội cho mỗi JTBD (Slide 5–6 đã lược bớt cho gọn). Đề xuất khung để thảo luận: (1) Nhóm II là giai đoạn chuyển cấp nối tiếp Nhóm I, không phải phân khúc song song; (2) bổ sung 2 JTBD ẩn.</a:t>
+            </a:r>
+            <a:endParaRPr lang="en-US" sz="1000" dirty="0"/>
+          </a:p>
+        </p:txBody>
+      </p:sp>
+      <p:sp>
+        <p:nvSpPr>
+          <p:cNvPr id="7" name="Text 4"/>
+          <p:cNvSpPr/>
+          <p:nvPr/>
+        </p:nvSpPr>
+        <p:spPr>
+          <a:xfrm>
+            <a:off x="502920" y="1810000"/>
+            <a:ext cx="5466556" cy="300000"/>
+          </a:xfrm>
+          <a:prstGeom prst="rect">
+            <a:avLst/>
+          </a:prstGeom>
+          <a:noFill/>
+          <a:ln/>
+        </p:spPr>
+        <p:txBody>
+          <a:bodyPr wrap="square" rtlCol="0" anchor="ctr"/>
+          <a:lstStyle/>
+          <a:p>
+            <a:pPr indent="0" marL="0">
+              <a:lnSpc>
+                <a:spcPct val="102000"/>
+              </a:lnSpc>
+              <a:spcAft>
+                <a:spcPts val="0"/>
+              </a:spcAft>
+              <a:buNone/>
+            </a:pPr>
+            <a:r>
+              <a:rPr lang="en-US" sz="1000" b="1" dirty="0">
+                <a:solidFill>
+                  <a:srgbClr val="004671"/>
+                </a:solidFill>
+                <a:latin typeface="Noto Sans" pitchFamily="34" charset="0"/>
+                <a:ea typeface="Noto Sans" pitchFamily="34" charset="-122"/>
+                <a:cs typeface="Noto Sans" pitchFamily="34" charset="-120"/>
+              </a:rPr>
+              <a:t>NHÓM I — ĐẦU TƯ MẠNH PHÁT TRIỂN NĂNG LỰC TIẾNG ANH</a:t>
+            </a:r>
+            <a:endParaRPr lang="en-US" sz="1000" dirty="0"/>
+          </a:p>
+        </p:txBody>
+      </p:sp>
+      <p:sp>
+        <p:nvSpPr>
+          <p:cNvPr id="8" name="Text 5"/>
+          <p:cNvSpPr/>
+          <p:nvPr/>
+        </p:nvSpPr>
+        <p:spPr>
+          <a:xfrm>
+            <a:off x="6219476" y="1760000"/>
+            <a:ext cx="5466556" cy="400000"/>
+          </a:xfrm>
+          <a:prstGeom prst="rect">
+            <a:avLst/>
+          </a:prstGeom>
+          <a:noFill/>
+          <a:ln/>
+        </p:spPr>
+        <p:txBody>
+          <a:bodyPr wrap="square" rtlCol="0" anchor="t">
+            <a:normAutofit/>
+          </a:bodyPr>
+          <a:lstStyle/>
+          <a:p>
+            <a:pPr indent="0" marL="0">
+              <a:lnSpc>
+                <a:spcPct val="102000"/>
+              </a:lnSpc>
+              <a:spcAft>
+                <a:spcPts val="100"/>
+              </a:spcAft>
+              <a:buNone/>
+            </a:pPr>
+            <a:r>
+              <a:rPr lang="en-US" sz="1000" b="1" dirty="0">
+                <a:solidFill>
+                  <a:srgbClr val="004671"/>
+                </a:solidFill>
+                <a:latin typeface="Noto Sans" pitchFamily="34" charset="0"/>
+                <a:ea typeface="Noto Sans" pitchFamily="34" charset="-122"/>
+                <a:cs typeface="Noto Sans" pitchFamily="34" charset="-120"/>
+              </a:rPr>
+              <a:t>NHÓM II — GIAI ĐOẠN CHUYỂN CẤP, NỐI TIẾP NHÓM I</a:t>
+            </a:r>
+            <a:endParaRPr lang="en-US" sz="1000" dirty="0"/>
+          </a:p>
+          <a:p>
+            <a:pPr indent="0" marL="0">
+              <a:lnSpc>
+                <a:spcPct val="102000"/>
+              </a:lnSpc>
+              <a:spcAft>
+                <a:spcPts val="0"/>
+              </a:spcAft>
+              <a:buNone/>
+            </a:pPr>
+            <a:r>
+              <a:rPr lang="en-US" sz="800" i="1" dirty="0">
+                <a:solidFill>
+                  <a:srgbClr val="5B6472"/>
+                </a:solidFill>
+                <a:latin typeface="Noto Sans" pitchFamily="34" charset="0"/>
+                <a:ea typeface="Noto Sans" pitchFamily="34" charset="-122"/>
+                <a:cs typeface="Noto Sans" pitchFamily="34" charset="-120"/>
+              </a:rPr>
+              <a:t>Dữ liệu VN (Dang Hai-Anh; VnExpress): hành trình theo cấp học, không phải phân khúc khách hàng khác.</a:t>
+            </a:r>
+            <a:endParaRPr lang="en-US" sz="800" dirty="0"/>
+          </a:p>
+        </p:txBody>
+      </p:sp>
+      <p:sp>
+        <p:nvSpPr>
+          <p:cNvPr id="9" name="Bar 9"/>
+          <p:cNvSpPr/>
+          <p:nvPr/>
+        </p:nvSpPr>
+        <p:spPr>
+          <a:xfrm>
+            <a:off x="502920" y="2210000"/>
+            <a:ext cx="73152" cy="1000000"/>
+          </a:xfrm>
+          <a:prstGeom prst="rect">
+            <a:avLst/>
+          </a:prstGeom>
+          <a:solidFill>
+            <a:srgbClr val="004671"/>
+          </a:solidFill>
+          <a:ln/>
+        </p:spPr>
+      </p:sp>
+      <p:sp>
+        <p:nvSpPr>
+          <p:cNvPr id="10" name="Text 10"/>
+          <p:cNvSpPr/>
+          <p:nvPr/>
+        </p:nvSpPr>
+        <p:spPr>
+          <a:xfrm>
+            <a:off x="685800" y="2210000"/>
+            <a:ext cx="5283676" cy="1000000"/>
+          </a:xfrm>
+          <a:prstGeom prst="rect">
+            <a:avLst/>
+          </a:prstGeom>
+          <a:noFill/>
+          <a:ln/>
+        </p:spPr>
+        <p:txBody>
+          <a:bodyPr wrap="square" rtlCol="0" anchor="t">
+            <a:normAutofit/>
+          </a:bodyPr>
+          <a:lstStyle/>
+          <a:p>
+            <a:pPr indent="0" marL="0">
+              <a:lnSpc>
+                <a:spcPct val="102000"/>
+              </a:lnSpc>
+              <a:spcAft>
+                <a:spcPts val="200"/>
+              </a:spcAft>
+              <a:buNone/>
+            </a:pPr>
+            <a:r>
+              <a:rPr lang="en-US" sz="1150" b="1" dirty="0">
+                <a:solidFill>
+                  <a:srgbClr val="004671"/>
+                </a:solidFill>
+                <a:latin typeface="Noto Sans" pitchFamily="34" charset="0"/>
+                <a:ea typeface="Noto Sans" pitchFamily="34" charset="-122"/>
+                <a:cs typeface="Noto Sans" pitchFamily="34" charset="-120"/>
+              </a:rPr>
+              <a:t>JTBD 1 — Thành tích đo lường được</a:t>
+            </a:r>
+            <a:endParaRPr lang="en-US" sz="1150" dirty="0"/>
+          </a:p>
+          <a:p>
+            <a:pPr indent="0" marL="0">
+              <a:lnSpc>
+                <a:spcPct val="102000"/>
+              </a:lnSpc>
+              <a:spcAft>
+                <a:spcPts val="200"/>
+              </a:spcAft>
+              <a:buNone/>
+            </a:pPr>
+            <a:r>
+              <a:rPr lang="en-US" sz="950" b="1" dirty="0">
+                <a:solidFill>
+                  <a:srgbClr val="22333F"/>
+                </a:solidFill>
+                <a:latin typeface="Noto Sans" pitchFamily="34" charset="0"/>
+                <a:ea typeface="Noto Sans" pitchFamily="34" charset="-122"/>
+                <a:cs typeface="Noto Sans" pitchFamily="34" charset="-120"/>
+              </a:rPr>
+              <a:t>Chức năng: </a:t>
+            </a:r>
+            <a:r>
+              <a:rPr lang="en-US" sz="950" dirty="0">
+                <a:solidFill>
+                  <a:srgbClr val="22333F"/>
+                </a:solidFill>
+                <a:latin typeface="Noto Sans" pitchFamily="34" charset="0"/>
+                <a:ea typeface="Noto Sans" pitchFamily="34" charset="-122"/>
+                <a:cs typeface="Noto Sans" pitchFamily="34" charset="-120"/>
+              </a:rPr>
+              <a:t>Điểm cao, có chứng chỉ tiếng Anh theo lộ trình.</a:t>
+            </a:r>
+            <a:endParaRPr lang="en-US" sz="950" dirty="0"/>
+          </a:p>
+          <a:p>
+            <a:pPr indent="0" marL="0">
+              <a:lnSpc>
+                <a:spcPct val="102000"/>
+              </a:lnSpc>
+              <a:spcAft>
+                <a:spcPts val="200"/>
+              </a:spcAft>
+              <a:buNone/>
+            </a:pPr>
+            <a:r>
+              <a:rPr lang="en-US" sz="950" b="1" dirty="0">
+                <a:solidFill>
+                  <a:srgbClr val="22333F"/>
+                </a:solidFill>
+                <a:latin typeface="Noto Sans" pitchFamily="34" charset="0"/>
+                <a:ea typeface="Noto Sans" pitchFamily="34" charset="-122"/>
+                <a:cs typeface="Noto Sans" pitchFamily="34" charset="-120"/>
+              </a:rPr>
+              <a:t>Cảm xúc: </a:t>
+            </a:r>
+            <a:r>
+              <a:rPr lang="en-US" sz="950" dirty="0">
+                <a:solidFill>
+                  <a:srgbClr val="22333F"/>
+                </a:solidFill>
+                <a:latin typeface="Noto Sans" pitchFamily="34" charset="0"/>
+                <a:ea typeface="Noto Sans" pitchFamily="34" charset="-122"/>
+                <a:cs typeface="Noto Sans" pitchFamily="34" charset="-120"/>
+              </a:rPr>
+              <a:t>Giải tỏa lo “đầu tư mà không có kết quả” — mạnh với phụ huynh từng thất vọng ở sản phẩm khác.</a:t>
+            </a:r>
+            <a:endParaRPr lang="en-US" sz="950" dirty="0"/>
+          </a:p>
+          <a:p>
+            <a:pPr indent="0" marL="0">
+              <a:lnSpc>
+                <a:spcPct val="102000"/>
+              </a:lnSpc>
+              <a:spcAft>
+                <a:spcPts val="200"/>
+              </a:spcAft>
+              <a:buNone/>
+            </a:pPr>
+            <a:r>
+              <a:rPr lang="en-US" sz="950" b="1" dirty="0">
+                <a:solidFill>
+                  <a:srgbClr val="22333F"/>
+                </a:solidFill>
+                <a:latin typeface="Noto Sans" pitchFamily="34" charset="0"/>
+                <a:ea typeface="Noto Sans" pitchFamily="34" charset="-122"/>
+                <a:cs typeface="Noto Sans" pitchFamily="34" charset="-120"/>
+              </a:rPr>
+              <a:t>Xã hội: </a:t>
+            </a:r>
+            <a:r>
+              <a:rPr lang="en-US" sz="950" dirty="0">
+                <a:solidFill>
+                  <a:srgbClr val="22333F"/>
+                </a:solidFill>
+                <a:latin typeface="Noto Sans" pitchFamily="34" charset="0"/>
+                <a:ea typeface="Noto Sans" pitchFamily="34" charset="-122"/>
+                <a:cs typeface="Noto Sans" pitchFamily="34" charset="-120"/>
+              </a:rPr>
+              <a:t>Có “bằng chứng” để nói với chồng, ông bà, bạn bè rằng quyết định của mình là đúng.</a:t>
+            </a:r>
+            <a:endParaRPr lang="en-US" sz="950" dirty="0"/>
+          </a:p>
+        </p:txBody>
+      </p:sp>
+      <p:sp>
+        <p:nvSpPr>
+          <p:cNvPr id="11" name="Bar 11"/>
+          <p:cNvSpPr/>
+          <p:nvPr/>
+        </p:nvSpPr>
+        <p:spPr>
+          <a:xfrm>
+            <a:off x="502920" y="3250000"/>
+            <a:ext cx="73152" cy="1000000"/>
+          </a:xfrm>
+          <a:prstGeom prst="rect">
+            <a:avLst/>
+          </a:prstGeom>
+          <a:solidFill>
+            <a:srgbClr val="3B81B1"/>
+          </a:solidFill>
+          <a:ln/>
+        </p:spPr>
+      </p:sp>
+      <p:sp>
+        <p:nvSpPr>
+          <p:cNvPr id="12" name="Text 12"/>
+          <p:cNvSpPr/>
+          <p:nvPr/>
+        </p:nvSpPr>
+        <p:spPr>
+          <a:xfrm>
+            <a:off x="685800" y="3250000"/>
+            <a:ext cx="5283676" cy="1000000"/>
+          </a:xfrm>
+          <a:prstGeom prst="rect">
+            <a:avLst/>
+          </a:prstGeom>
+          <a:noFill/>
+          <a:ln/>
+        </p:spPr>
+        <p:txBody>
+          <a:bodyPr wrap="square" rtlCol="0" anchor="t">
+            <a:normAutofit/>
+          </a:bodyPr>
+          <a:lstStyle/>
+          <a:p>
+            <a:pPr indent="0" marL="0">
+              <a:lnSpc>
+                <a:spcPct val="102000"/>
+              </a:lnSpc>
+              <a:spcAft>
+                <a:spcPts val="200"/>
+              </a:spcAft>
+              <a:buNone/>
+            </a:pPr>
+            <a:r>
+              <a:rPr lang="en-US" sz="1150" b="1" dirty="0">
+                <a:solidFill>
+                  <a:srgbClr val="004671"/>
+                </a:solidFill>
+                <a:latin typeface="Noto Sans" pitchFamily="34" charset="0"/>
+                <a:ea typeface="Noto Sans" pitchFamily="34" charset="-122"/>
+                <a:cs typeface="Noto Sans" pitchFamily="34" charset="-120"/>
+              </a:rPr>
+              <a:t>JTBD 2 — Tự tin giao tiếp thực tế</a:t>
+            </a:r>
+            <a:endParaRPr lang="en-US" sz="1150" dirty="0"/>
+          </a:p>
+          <a:p>
+            <a:pPr indent="0" marL="0">
+              <a:lnSpc>
+                <a:spcPct val="102000"/>
+              </a:lnSpc>
+              <a:spcAft>
+                <a:spcPts val="200"/>
+              </a:spcAft>
+              <a:buNone/>
+            </a:pPr>
+            <a:r>
+              <a:rPr lang="en-US" sz="950" b="1" dirty="0">
+                <a:solidFill>
+                  <a:srgbClr val="22333F"/>
+                </a:solidFill>
+                <a:latin typeface="Noto Sans" pitchFamily="34" charset="0"/>
+                <a:ea typeface="Noto Sans" pitchFamily="34" charset="-122"/>
+                <a:cs typeface="Noto Sans" pitchFamily="34" charset="-120"/>
+              </a:rPr>
+              <a:t>Chức năng: </a:t>
+            </a:r>
+            <a:r>
+              <a:rPr lang="en-US" sz="950" dirty="0">
+                <a:solidFill>
+                  <a:srgbClr val="22333F"/>
+                </a:solidFill>
+                <a:latin typeface="Noto Sans" pitchFamily="34" charset="0"/>
+                <a:ea typeface="Noto Sans" pitchFamily="34" charset="-122"/>
+                <a:cs typeface="Noto Sans" pitchFamily="34" charset="-120"/>
+              </a:rPr>
+              <a:t>Nghe – nói được, phát âm chuẩn.</a:t>
+            </a:r>
+            <a:endParaRPr lang="en-US" sz="950" dirty="0"/>
+          </a:p>
+          <a:p>
+            <a:pPr indent="0" marL="0">
+              <a:lnSpc>
+                <a:spcPct val="102000"/>
+              </a:lnSpc>
+              <a:spcAft>
+                <a:spcPts val="200"/>
+              </a:spcAft>
+              <a:buNone/>
+            </a:pPr>
+            <a:r>
+              <a:rPr lang="en-US" sz="950" b="1" dirty="0">
+                <a:solidFill>
+                  <a:srgbClr val="22333F"/>
+                </a:solidFill>
+                <a:latin typeface="Noto Sans" pitchFamily="34" charset="0"/>
+                <a:ea typeface="Noto Sans" pitchFamily="34" charset="-122"/>
+                <a:cs typeface="Noto Sans" pitchFamily="34" charset="-120"/>
+              </a:rPr>
+              <a:t>Cảm xúc: </a:t>
+            </a:r>
+            <a:r>
+              <a:rPr lang="en-US" sz="950" dirty="0">
+                <a:solidFill>
+                  <a:srgbClr val="22333F"/>
+                </a:solidFill>
+                <a:latin typeface="Noto Sans" pitchFamily="34" charset="0"/>
+                <a:ea typeface="Noto Sans" pitchFamily="34" charset="-122"/>
+                <a:cs typeface="Noto Sans" pitchFamily="34" charset="-120"/>
+              </a:rPr>
+              <a:t>Nỗi sợ “học nhiều năm mà vẫn câm tiếng Anh” — giống chính phụ huynh từng trải qua.</a:t>
+            </a:r>
+            <a:endParaRPr lang="en-US" sz="950" dirty="0"/>
+          </a:p>
+          <a:p>
+            <a:pPr indent="0" marL="0">
+              <a:lnSpc>
+                <a:spcPct val="102000"/>
+              </a:lnSpc>
+              <a:spcAft>
+                <a:spcPts val="200"/>
+              </a:spcAft>
+              <a:buNone/>
+            </a:pPr>
+            <a:r>
+              <a:rPr lang="en-US" sz="950" b="1" dirty="0">
+                <a:solidFill>
+                  <a:srgbClr val="22333F"/>
+                </a:solidFill>
+                <a:latin typeface="Noto Sans" pitchFamily="34" charset="0"/>
+                <a:ea typeface="Noto Sans" pitchFamily="34" charset="-122"/>
+                <a:cs typeface="Noto Sans" pitchFamily="34" charset="-120"/>
+              </a:rPr>
+              <a:t>Xã hội: </a:t>
+            </a:r>
+            <a:r>
+              <a:rPr lang="en-US" sz="950" dirty="0">
+                <a:solidFill>
+                  <a:srgbClr val="22333F"/>
+                </a:solidFill>
+                <a:latin typeface="Noto Sans" pitchFamily="34" charset="0"/>
+                <a:ea typeface="Noto Sans" pitchFamily="34" charset="-122"/>
+                <a:cs typeface="Noto Sans" pitchFamily="34" charset="-120"/>
+              </a:rPr>
+              <a:t>Mong con có thứ mình không có được — gắn JTBD ẩn “đổi đời qua ngoại ngữ”.</a:t>
+            </a:r>
+            <a:endParaRPr lang="en-US" sz="950" dirty="0"/>
+          </a:p>
+        </p:txBody>
+      </p:sp>
+      <p:sp>
+        <p:nvSpPr>
+          <p:cNvPr id="13" name="Bar 13"/>
+          <p:cNvSpPr/>
+          <p:nvPr/>
+        </p:nvSpPr>
+        <p:spPr>
+          <a:xfrm>
+            <a:off x="502920" y="4290000"/>
+            <a:ext cx="73152" cy="1000000"/>
+          </a:xfrm>
+          <a:prstGeom prst="rect">
+            <a:avLst/>
+          </a:prstGeom>
+          <a:solidFill>
+            <a:srgbClr val="518E0D"/>
+          </a:solidFill>
+          <a:ln/>
+        </p:spPr>
+      </p:sp>
+      <p:sp>
+        <p:nvSpPr>
+          <p:cNvPr id="14" name="Text 14"/>
+          <p:cNvSpPr/>
+          <p:nvPr/>
+        </p:nvSpPr>
+        <p:spPr>
+          <a:xfrm>
+            <a:off x="685800" y="4290000"/>
+            <a:ext cx="5283676" cy="1000000"/>
+          </a:xfrm>
+          <a:prstGeom prst="rect">
+            <a:avLst/>
+          </a:prstGeom>
+          <a:noFill/>
+          <a:ln/>
+        </p:spPr>
+        <p:txBody>
+          <a:bodyPr wrap="square" rtlCol="0" anchor="t">
+            <a:normAutofit/>
+          </a:bodyPr>
+          <a:lstStyle/>
+          <a:p>
+            <a:pPr indent="0" marL="0">
+              <a:lnSpc>
+                <a:spcPct val="102000"/>
+              </a:lnSpc>
+              <a:spcAft>
+                <a:spcPts val="200"/>
+              </a:spcAft>
+              <a:buNone/>
+            </a:pPr>
+            <a:r>
+              <a:rPr lang="en-US" sz="1150" b="1" dirty="0">
+                <a:solidFill>
+                  <a:srgbClr val="004671"/>
+                </a:solidFill>
+                <a:latin typeface="Noto Sans" pitchFamily="34" charset="0"/>
+                <a:ea typeface="Noto Sans" pitchFamily="34" charset="-122"/>
+                <a:cs typeface="Noto Sans" pitchFamily="34" charset="-120"/>
+              </a:rPr>
+              <a:t>JTBD 3 — Yêu thích, tự giác học</a:t>
+            </a:r>
+            <a:endParaRPr lang="en-US" sz="1150" dirty="0"/>
+          </a:p>
+          <a:p>
+            <a:pPr indent="0" marL="0">
+              <a:lnSpc>
+                <a:spcPct val="102000"/>
+              </a:lnSpc>
+              <a:spcAft>
+                <a:spcPts val="200"/>
+              </a:spcAft>
+              <a:buNone/>
+            </a:pPr>
+            <a:r>
+              <a:rPr lang="en-US" sz="950" b="1" dirty="0">
+                <a:solidFill>
+                  <a:srgbClr val="22333F"/>
+                </a:solidFill>
+                <a:latin typeface="Noto Sans" pitchFamily="34" charset="0"/>
+                <a:ea typeface="Noto Sans" pitchFamily="34" charset="-122"/>
+                <a:cs typeface="Noto Sans" pitchFamily="34" charset="-120"/>
+              </a:rPr>
+              <a:t>Chức năng: </a:t>
+            </a:r>
+            <a:r>
+              <a:rPr lang="en-US" sz="950" dirty="0">
+                <a:solidFill>
+                  <a:srgbClr val="22333F"/>
+                </a:solidFill>
+                <a:latin typeface="Noto Sans" pitchFamily="34" charset="0"/>
+                <a:ea typeface="Noto Sans" pitchFamily="34" charset="-122"/>
+                <a:cs typeface="Noto Sans" pitchFamily="34" charset="-120"/>
+              </a:rPr>
+              <a:t>Chủ động học, không đối phó.</a:t>
+            </a:r>
+            <a:endParaRPr lang="en-US" sz="950" dirty="0"/>
+          </a:p>
+          <a:p>
+            <a:pPr indent="0" marL="0">
+              <a:lnSpc>
+                <a:spcPct val="102000"/>
+              </a:lnSpc>
+              <a:spcAft>
+                <a:spcPts val="200"/>
+              </a:spcAft>
+              <a:buNone/>
+            </a:pPr>
+            <a:r>
+              <a:rPr lang="en-US" sz="950" b="1" dirty="0">
+                <a:solidFill>
+                  <a:srgbClr val="22333F"/>
+                </a:solidFill>
+                <a:latin typeface="Noto Sans" pitchFamily="34" charset="0"/>
+                <a:ea typeface="Noto Sans" pitchFamily="34" charset="-122"/>
+                <a:cs typeface="Noto Sans" pitchFamily="34" charset="-120"/>
+              </a:rPr>
+              <a:t>Cảm xúc: </a:t>
+            </a:r>
+            <a:r>
+              <a:rPr lang="en-US" sz="950" dirty="0">
+                <a:solidFill>
+                  <a:srgbClr val="22333F"/>
+                </a:solidFill>
+                <a:latin typeface="Noto Sans" pitchFamily="34" charset="0"/>
+                <a:ea typeface="Noto Sans" pitchFamily="34" charset="-122"/>
+                <a:cs typeface="Noto Sans" pitchFamily="34" charset="-120"/>
+              </a:rPr>
+              <a:t>Mệt mỏi vì xung đột hằng ngày với con; cảm giác tội lỗi khi phải quát mắng.</a:t>
+            </a:r>
+            <a:endParaRPr lang="en-US" sz="950" dirty="0"/>
+          </a:p>
+          <a:p>
+            <a:pPr indent="0" marL="0">
+              <a:lnSpc>
+                <a:spcPct val="102000"/>
+              </a:lnSpc>
+              <a:spcAft>
+                <a:spcPts val="200"/>
+              </a:spcAft>
+              <a:buNone/>
+            </a:pPr>
+            <a:r>
+              <a:rPr lang="en-US" sz="950" b="1" dirty="0">
+                <a:solidFill>
+                  <a:srgbClr val="22333F"/>
+                </a:solidFill>
+                <a:latin typeface="Noto Sans" pitchFamily="34" charset="0"/>
+                <a:ea typeface="Noto Sans" pitchFamily="34" charset="-122"/>
+                <a:cs typeface="Noto Sans" pitchFamily="34" charset="-120"/>
+              </a:rPr>
+              <a:t>Xã hội: </a:t>
+            </a:r>
+            <a:r>
+              <a:rPr lang="en-US" sz="950" dirty="0">
+                <a:solidFill>
+                  <a:srgbClr val="22333F"/>
+                </a:solidFill>
+                <a:latin typeface="Noto Sans" pitchFamily="34" charset="0"/>
+                <a:ea typeface="Noto Sans" pitchFamily="34" charset="-122"/>
+                <a:cs typeface="Noto Sans" pitchFamily="34" charset="-120"/>
+              </a:rPr>
+              <a:t>Giữ hòa khí gia đình.</a:t>
+            </a:r>
+            <a:endParaRPr lang="en-US" sz="950" dirty="0"/>
+          </a:p>
+          <a:p>
+            <a:pPr indent="0" marL="0">
+              <a:lnSpc>
+                <a:spcPct val="102000"/>
+              </a:lnSpc>
+              <a:spcAft>
+                <a:spcPts val="200"/>
+              </a:spcAft>
+              <a:buNone/>
+            </a:pPr>
+            <a:r>
+              <a:rPr lang="en-US" sz="950" b="1" dirty="0">
+                <a:solidFill>
+                  <a:srgbClr val="B23B2E"/>
+                </a:solidFill>
+                <a:latin typeface="Noto Sans" pitchFamily="34" charset="0"/>
+                <a:ea typeface="Noto Sans" pitchFamily="34" charset="-122"/>
+                <a:cs typeface="Noto Sans" pitchFamily="34" charset="-120"/>
+              </a:rPr>
+              <a:t>⚠ </a:t>
+            </a:r>
+            <a:r>
+              <a:rPr lang="en-US" sz="950" dirty="0">
+                <a:solidFill>
+                  <a:srgbClr val="B23B2E"/>
+                </a:solidFill>
+                <a:latin typeface="Noto Sans" pitchFamily="34" charset="0"/>
+                <a:ea typeface="Noto Sans" pitchFamily="34" charset="-122"/>
+                <a:cs typeface="Noto Sans" pitchFamily="34" charset="-120"/>
+              </a:rPr>
+              <a:t>Dễ mâu thuẫn JTBD 1 nếu sản phẩm nặng điểm số/thi đua để “chứng minh”.</a:t>
+            </a:r>
+            <a:endParaRPr lang="en-US" sz="950" dirty="0"/>
+          </a:p>
+        </p:txBody>
+      </p:sp>
+      <p:sp>
+        <p:nvSpPr>
+          <p:cNvPr id="15" name="Bar 15"/>
+          <p:cNvSpPr/>
+          <p:nvPr/>
+        </p:nvSpPr>
+        <p:spPr>
+          <a:xfrm>
+            <a:off x="502920" y="5330000"/>
+            <a:ext cx="73152" cy="1000000"/>
+          </a:xfrm>
+          <a:prstGeom prst="rect">
+            <a:avLst/>
+          </a:prstGeom>
+          <a:solidFill>
+            <a:srgbClr val="A5BE00"/>
+          </a:solidFill>
+          <a:ln/>
+        </p:spPr>
+      </p:sp>
+      <p:sp>
+        <p:nvSpPr>
+          <p:cNvPr id="16" name="Text 16"/>
+          <p:cNvSpPr/>
+          <p:nvPr/>
+        </p:nvSpPr>
+        <p:spPr>
+          <a:xfrm>
+            <a:off x="685800" y="5330000"/>
+            <a:ext cx="5283676" cy="1000000"/>
+          </a:xfrm>
+          <a:prstGeom prst="rect">
+            <a:avLst/>
+          </a:prstGeom>
+          <a:noFill/>
+          <a:ln/>
+        </p:spPr>
+        <p:txBody>
+          <a:bodyPr wrap="square" rtlCol="0" anchor="t">
+            <a:normAutofit/>
+          </a:bodyPr>
+          <a:lstStyle/>
+          <a:p>
+            <a:pPr indent="0" marL="0">
+              <a:lnSpc>
+                <a:spcPct val="102000"/>
+              </a:lnSpc>
+              <a:spcAft>
+                <a:spcPts val="200"/>
+              </a:spcAft>
+              <a:buNone/>
+            </a:pPr>
+            <a:r>
+              <a:rPr lang="en-US" sz="1150" b="1" dirty="0">
+                <a:solidFill>
+                  <a:srgbClr val="004671"/>
+                </a:solidFill>
+                <a:latin typeface="Noto Sans" pitchFamily="34" charset="0"/>
+                <a:ea typeface="Noto Sans" pitchFamily="34" charset="-122"/>
+                <a:cs typeface="Noto Sans" pitchFamily="34" charset="-120"/>
+              </a:rPr>
+              <a:t>JTBD 4 — Giải phóng thời gian, áp lực kèm con</a:t>
+            </a:r>
+            <a:endParaRPr lang="en-US" sz="1150" dirty="0"/>
+          </a:p>
+          <a:p>
+            <a:pPr indent="0" marL="0">
+              <a:lnSpc>
+                <a:spcPct val="102000"/>
+              </a:lnSpc>
+              <a:spcAft>
+                <a:spcPts val="200"/>
+              </a:spcAft>
+              <a:buNone/>
+            </a:pPr>
+            <a:r>
+              <a:rPr lang="en-US" sz="950" b="1" dirty="0">
+                <a:solidFill>
+                  <a:srgbClr val="22333F"/>
+                </a:solidFill>
+                <a:latin typeface="Noto Sans" pitchFamily="34" charset="0"/>
+                <a:ea typeface="Noto Sans" pitchFamily="34" charset="-122"/>
+                <a:cs typeface="Noto Sans" pitchFamily="34" charset="-120"/>
+              </a:rPr>
+              <a:t>Chức năng: </a:t>
+            </a:r>
+            <a:r>
+              <a:rPr lang="en-US" sz="950" dirty="0">
+                <a:solidFill>
+                  <a:srgbClr val="22333F"/>
+                </a:solidFill>
+                <a:latin typeface="Noto Sans" pitchFamily="34" charset="0"/>
+                <a:ea typeface="Noto Sans" pitchFamily="34" charset="-122"/>
+                <a:cs typeface="Noto Sans" pitchFamily="34" charset="-120"/>
+              </a:rPr>
+              <a:t>Không cần giám sát/kèm cặp con hằng ngày.</a:t>
+            </a:r>
+            <a:endParaRPr lang="en-US" sz="950" dirty="0"/>
+          </a:p>
+          <a:p>
+            <a:pPr indent="0" marL="0">
+              <a:lnSpc>
+                <a:spcPct val="102000"/>
+              </a:lnSpc>
+              <a:spcAft>
+                <a:spcPts val="200"/>
+              </a:spcAft>
+              <a:buNone/>
+            </a:pPr>
+            <a:r>
+              <a:rPr lang="en-US" sz="950" b="1" dirty="0">
+                <a:solidFill>
+                  <a:srgbClr val="22333F"/>
+                </a:solidFill>
+                <a:latin typeface="Noto Sans" pitchFamily="34" charset="0"/>
+                <a:ea typeface="Noto Sans" pitchFamily="34" charset="-122"/>
+                <a:cs typeface="Noto Sans" pitchFamily="34" charset="-120"/>
+              </a:rPr>
+              <a:t>Cảm xúc: </a:t>
+            </a:r>
+            <a:r>
+              <a:rPr lang="en-US" sz="950" dirty="0">
+                <a:solidFill>
+                  <a:srgbClr val="22333F"/>
+                </a:solidFill>
+                <a:latin typeface="Noto Sans" pitchFamily="34" charset="0"/>
+                <a:ea typeface="Noto Sans" pitchFamily="34" charset="-122"/>
+                <a:cs typeface="Noto Sans" pitchFamily="34" charset="-120"/>
+              </a:rPr>
+              <a:t>Giải tỏa mặc cảm/tội lỗi vì không giỏi tiếng Anh, không có thời gian — phần thiếu nhất ở slide gốc.</a:t>
+            </a:r>
+            <a:endParaRPr lang="en-US" sz="950" dirty="0"/>
+          </a:p>
+          <a:p>
+            <a:pPr indent="0" marL="0">
+              <a:lnSpc>
+                <a:spcPct val="102000"/>
+              </a:lnSpc>
+              <a:spcAft>
+                <a:spcPts val="200"/>
+              </a:spcAft>
+              <a:buNone/>
+            </a:pPr>
+            <a:r>
+              <a:rPr lang="en-US" sz="950" b="1" dirty="0">
+                <a:solidFill>
+                  <a:srgbClr val="22333F"/>
+                </a:solidFill>
+                <a:latin typeface="Noto Sans" pitchFamily="34" charset="0"/>
+                <a:ea typeface="Noto Sans" pitchFamily="34" charset="-122"/>
+                <a:cs typeface="Noto Sans" pitchFamily="34" charset="-120"/>
+              </a:rPr>
+              <a:t>Xã hội: </a:t>
+            </a:r>
+            <a:r>
+              <a:rPr lang="en-US" sz="950" dirty="0">
+                <a:solidFill>
+                  <a:srgbClr val="22333F"/>
+                </a:solidFill>
+                <a:latin typeface="Noto Sans" pitchFamily="34" charset="0"/>
+                <a:ea typeface="Noto Sans" pitchFamily="34" charset="-122"/>
+                <a:cs typeface="Noto Sans" pitchFamily="34" charset="-120"/>
+              </a:rPr>
+              <a:t>Vẫn được nhìn nhận là “mẹ có trách nhiệm” dù bận.</a:t>
+            </a:r>
+            <a:endParaRPr lang="en-US" sz="950" dirty="0"/>
+          </a:p>
+        </p:txBody>
+      </p:sp>
+      <p:sp>
+        <p:nvSpPr>
+          <p:cNvPr id="17" name="Bar 17"/>
+          <p:cNvSpPr/>
+          <p:nvPr/>
+        </p:nvSpPr>
+        <p:spPr>
+          <a:xfrm>
+            <a:off x="6219476" y="2210000"/>
+            <a:ext cx="73152" cy="1000000"/>
+          </a:xfrm>
+          <a:prstGeom prst="rect">
+            <a:avLst/>
+          </a:prstGeom>
+          <a:solidFill>
+            <a:srgbClr val="004671"/>
+          </a:solidFill>
+          <a:ln/>
+        </p:spPr>
+      </p:sp>
+      <p:sp>
+        <p:nvSpPr>
+          <p:cNvPr id="18" name="Text 18"/>
+          <p:cNvSpPr/>
+          <p:nvPr/>
+        </p:nvSpPr>
+        <p:spPr>
+          <a:xfrm>
+            <a:off x="6402356" y="2210000"/>
+            <a:ext cx="5283676" cy="1000000"/>
+          </a:xfrm>
+          <a:prstGeom prst="rect">
+            <a:avLst/>
+          </a:prstGeom>
+          <a:noFill/>
+          <a:ln/>
+        </p:spPr>
+        <p:txBody>
+          <a:bodyPr wrap="square" rtlCol="0" anchor="t">
+            <a:normAutofit/>
+          </a:bodyPr>
+          <a:lstStyle/>
+          <a:p>
+            <a:pPr indent="0" marL="0">
+              <a:lnSpc>
+                <a:spcPct val="102000"/>
+              </a:lnSpc>
+              <a:spcAft>
+                <a:spcPts val="200"/>
+              </a:spcAft>
+              <a:buNone/>
+            </a:pPr>
+            <a:r>
+              <a:rPr lang="en-US" sz="1150" b="1" dirty="0">
+                <a:solidFill>
+                  <a:srgbClr val="004671"/>
+                </a:solidFill>
+                <a:latin typeface="Noto Sans" pitchFamily="34" charset="0"/>
+                <a:ea typeface="Noto Sans" pitchFamily="34" charset="-122"/>
+                <a:cs typeface="Noto Sans" pitchFamily="34" charset="-120"/>
+              </a:rPr>
+              <a:t>JTBD 5 — Không hổng môn khi áp lực chuyển cấp tới gần</a:t>
+            </a:r>
+            <a:endParaRPr lang="en-US" sz="1150" dirty="0"/>
+          </a:p>
+          <a:p>
+            <a:pPr indent="0" marL="0">
+              <a:lnSpc>
+                <a:spcPct val="102000"/>
+              </a:lnSpc>
+              <a:spcAft>
+                <a:spcPts val="200"/>
+              </a:spcAft>
+              <a:buNone/>
+            </a:pPr>
+            <a:r>
+              <a:rPr lang="en-US" sz="950" b="1" dirty="0">
+                <a:solidFill>
+                  <a:srgbClr val="22333F"/>
+                </a:solidFill>
+                <a:latin typeface="Noto Sans" pitchFamily="34" charset="0"/>
+                <a:ea typeface="Noto Sans" pitchFamily="34" charset="-122"/>
+                <a:cs typeface="Noto Sans" pitchFamily="34" charset="-120"/>
+              </a:rPr>
+              <a:t>Chức năng: </a:t>
+            </a:r>
+            <a:r>
+              <a:rPr lang="en-US" sz="950" dirty="0">
+                <a:solidFill>
+                  <a:srgbClr val="22333F"/>
+                </a:solidFill>
+                <a:latin typeface="Noto Sans" pitchFamily="34" charset="0"/>
+                <a:ea typeface="Noto Sans" pitchFamily="34" charset="-122"/>
+                <a:cs typeface="Noto Sans" pitchFamily="34" charset="-120"/>
+              </a:rPr>
+              <a:t>Điểm đồng đều, đủ năng lực thi (lớp 6, lớp 10).</a:t>
+            </a:r>
+            <a:endParaRPr lang="en-US" sz="950" dirty="0"/>
+          </a:p>
+          <a:p>
+            <a:pPr indent="0" marL="0">
+              <a:lnSpc>
+                <a:spcPct val="102000"/>
+              </a:lnSpc>
+              <a:spcAft>
+                <a:spcPts val="200"/>
+              </a:spcAft>
+              <a:buNone/>
+            </a:pPr>
+            <a:r>
+              <a:rPr lang="en-US" sz="950" b="1" dirty="0">
+                <a:solidFill>
+                  <a:srgbClr val="22333F"/>
+                </a:solidFill>
+                <a:latin typeface="Noto Sans" pitchFamily="34" charset="0"/>
+                <a:ea typeface="Noto Sans" pitchFamily="34" charset="-122"/>
+                <a:cs typeface="Noto Sans" pitchFamily="34" charset="-120"/>
+              </a:rPr>
+              <a:t>Cảm xúc: </a:t>
+            </a:r>
+            <a:r>
+              <a:rPr lang="en-US" sz="950" dirty="0">
+                <a:solidFill>
+                  <a:srgbClr val="22333F"/>
+                </a:solidFill>
+                <a:latin typeface="Noto Sans" pitchFamily="34" charset="0"/>
+                <a:ea typeface="Noto Sans" pitchFamily="34" charset="-122"/>
+                <a:cs typeface="Noto Sans" pitchFamily="34" charset="-120"/>
+              </a:rPr>
+              <a:t>Lo âu so sánh xã hội — sợ “ai cũng học mà mình không cho con học”.</a:t>
+            </a:r>
+            <a:endParaRPr lang="en-US" sz="950" dirty="0"/>
+          </a:p>
+          <a:p>
+            <a:pPr indent="0" marL="0">
+              <a:lnSpc>
+                <a:spcPct val="102000"/>
+              </a:lnSpc>
+              <a:spcAft>
+                <a:spcPts val="200"/>
+              </a:spcAft>
+              <a:buNone/>
+            </a:pPr>
+            <a:r>
+              <a:rPr lang="en-US" sz="950" b="1" dirty="0">
+                <a:solidFill>
+                  <a:srgbClr val="22333F"/>
+                </a:solidFill>
+                <a:latin typeface="Noto Sans" pitchFamily="34" charset="0"/>
+                <a:ea typeface="Noto Sans" pitchFamily="34" charset="-122"/>
+                <a:cs typeface="Noto Sans" pitchFamily="34" charset="-120"/>
+              </a:rPr>
+              <a:t>Xã hội: </a:t>
+            </a:r>
+            <a:r>
+              <a:rPr lang="en-US" sz="950" dirty="0">
+                <a:solidFill>
+                  <a:srgbClr val="22333F"/>
+                </a:solidFill>
+                <a:latin typeface="Noto Sans" pitchFamily="34" charset="0"/>
+                <a:ea typeface="Noto Sans" pitchFamily="34" charset="-122"/>
+                <a:cs typeface="Noto Sans" pitchFamily="34" charset="-120"/>
+              </a:rPr>
+              <a:t>Áp lực đồng thuận của cộng đồng phụ huynh quanh kỳ thi chuyển cấp.</a:t>
+            </a:r>
+            <a:endParaRPr lang="en-US" sz="950" dirty="0"/>
+          </a:p>
+        </p:txBody>
+      </p:sp>
+      <p:sp>
+        <p:nvSpPr>
+          <p:cNvPr id="19" name="Bar 19"/>
+          <p:cNvSpPr/>
+          <p:nvPr/>
+        </p:nvSpPr>
+        <p:spPr>
+          <a:xfrm>
+            <a:off x="6219476" y="3250000"/>
+            <a:ext cx="73152" cy="1000000"/>
+          </a:xfrm>
+          <a:prstGeom prst="rect">
+            <a:avLst/>
+          </a:prstGeom>
+          <a:solidFill>
+            <a:srgbClr val="3B81B1"/>
+          </a:solidFill>
+          <a:ln/>
+        </p:spPr>
+      </p:sp>
+      <p:sp>
+        <p:nvSpPr>
+          <p:cNvPr id="20" name="Text 20"/>
+          <p:cNvSpPr/>
+          <p:nvPr/>
+        </p:nvSpPr>
+        <p:spPr>
+          <a:xfrm>
+            <a:off x="6402356" y="3250000"/>
+            <a:ext cx="5283676" cy="1000000"/>
+          </a:xfrm>
+          <a:prstGeom prst="rect">
+            <a:avLst/>
+          </a:prstGeom>
+          <a:noFill/>
+          <a:ln/>
+        </p:spPr>
+        <p:txBody>
+          <a:bodyPr wrap="square" rtlCol="0" anchor="t">
+            <a:normAutofit/>
+          </a:bodyPr>
+          <a:lstStyle/>
+          <a:p>
+            <a:pPr indent="0" marL="0">
+              <a:lnSpc>
+                <a:spcPct val="102000"/>
+              </a:lnSpc>
+              <a:spcAft>
+                <a:spcPts val="200"/>
+              </a:spcAft>
+              <a:buNone/>
+            </a:pPr>
+            <a:r>
+              <a:rPr lang="en-US" sz="1150" b="1" dirty="0">
+                <a:solidFill>
+                  <a:srgbClr val="004671"/>
+                </a:solidFill>
+                <a:latin typeface="Noto Sans" pitchFamily="34" charset="0"/>
+                <a:ea typeface="Noto Sans" pitchFamily="34" charset="-122"/>
+                <a:cs typeface="Noto Sans" pitchFamily="34" charset="-120"/>
+              </a:rPr>
+              <a:t>JTBD 6 — Không phải quản lý nhiều nơi cùng lúc</a:t>
+            </a:r>
+            <a:endParaRPr lang="en-US" sz="1150" dirty="0"/>
+          </a:p>
+          <a:p>
+            <a:pPr indent="0" marL="0">
+              <a:lnSpc>
+                <a:spcPct val="102000"/>
+              </a:lnSpc>
+              <a:spcAft>
+                <a:spcPts val="200"/>
+              </a:spcAft>
+              <a:buNone/>
+            </a:pPr>
+            <a:r>
+              <a:rPr lang="en-US" sz="950" b="1" dirty="0">
+                <a:solidFill>
+                  <a:srgbClr val="22333F"/>
+                </a:solidFill>
+                <a:latin typeface="Noto Sans" pitchFamily="34" charset="0"/>
+                <a:ea typeface="Noto Sans" pitchFamily="34" charset="-122"/>
+                <a:cs typeface="Noto Sans" pitchFamily="34" charset="-120"/>
+              </a:rPr>
+              <a:t>Chức năng: </a:t>
+            </a:r>
+            <a:r>
+              <a:rPr lang="en-US" sz="950" dirty="0">
+                <a:solidFill>
+                  <a:srgbClr val="22333F"/>
+                </a:solidFill>
+                <a:latin typeface="Noto Sans" pitchFamily="34" charset="0"/>
+                <a:ea typeface="Noto Sans" pitchFamily="34" charset="-122"/>
+                <a:cs typeface="Noto Sans" pitchFamily="34" charset="-120"/>
+              </a:rPr>
+              <a:t>Đóng gói đa môn về một chỗ.</a:t>
+            </a:r>
+            <a:endParaRPr lang="en-US" sz="950" dirty="0"/>
+          </a:p>
+          <a:p>
+            <a:pPr indent="0" marL="0">
+              <a:lnSpc>
+                <a:spcPct val="102000"/>
+              </a:lnSpc>
+              <a:spcAft>
+                <a:spcPts val="200"/>
+              </a:spcAft>
+              <a:buNone/>
+            </a:pPr>
+            <a:r>
+              <a:rPr lang="en-US" sz="950" b="1" dirty="0">
+                <a:solidFill>
+                  <a:srgbClr val="22333F"/>
+                </a:solidFill>
+                <a:latin typeface="Noto Sans" pitchFamily="34" charset="0"/>
+                <a:ea typeface="Noto Sans" pitchFamily="34" charset="-122"/>
+                <a:cs typeface="Noto Sans" pitchFamily="34" charset="-120"/>
+              </a:rPr>
+              <a:t>Cảm xúc: </a:t>
+            </a:r>
+            <a:r>
+              <a:rPr lang="en-US" sz="950" dirty="0">
+                <a:solidFill>
+                  <a:srgbClr val="22333F"/>
+                </a:solidFill>
+                <a:latin typeface="Noto Sans" pitchFamily="34" charset="0"/>
+                <a:ea typeface="Noto Sans" pitchFamily="34" charset="-122"/>
+                <a:cs typeface="Noto Sans" pitchFamily="34" charset="-120"/>
+              </a:rPr>
+              <a:t>Mệt mỏi vì quản lý phân mảnh; muốn bớt đưa đón, bớt nhớ nhiều lịch và khoản chi.</a:t>
+            </a:r>
+            <a:endParaRPr lang="en-US" sz="950" dirty="0"/>
+          </a:p>
+        </p:txBody>
+      </p:sp>
+      <p:sp>
+        <p:nvSpPr>
+          <p:cNvPr id="21" name="Text 6"/>
+          <p:cNvSpPr/>
+          <p:nvPr/>
+        </p:nvSpPr>
+        <p:spPr>
+          <a:xfrm>
+            <a:off x="6219476" y="4300000"/>
+            <a:ext cx="5466556" cy="260000"/>
+          </a:xfrm>
+          <a:prstGeom prst="rect">
+            <a:avLst/>
+          </a:prstGeom>
+          <a:noFill/>
+          <a:ln/>
+        </p:spPr>
+        <p:txBody>
+          <a:bodyPr wrap="square" rtlCol="0" anchor="ctr"/>
+          <a:lstStyle/>
+          <a:p>
+            <a:pPr indent="0" marL="0">
+              <a:lnSpc>
+                <a:spcPct val="102000"/>
+              </a:lnSpc>
+              <a:spcAft>
+                <a:spcPts val="0"/>
+              </a:spcAft>
+              <a:buNone/>
+            </a:pPr>
+            <a:r>
+              <a:rPr lang="en-US" sz="900" b="1" dirty="0">
+                <a:solidFill>
+                  <a:srgbClr val="5B6472"/>
+                </a:solidFill>
+                <a:latin typeface="Noto Sans" pitchFamily="34" charset="0"/>
+                <a:ea typeface="Noto Sans" pitchFamily="34" charset="-122"/>
+                <a:cs typeface="Noto Sans" pitchFamily="34" charset="-120"/>
+              </a:rPr>
+              <a:t>JTBD ẨN — có bằng chứng mạnh, chưa đưa vào Slide 5–6 (chưa bóc tách 3 tầng)</a:t>
+            </a:r>
+            <a:endParaRPr lang="en-US" sz="900" dirty="0"/>
+          </a:p>
+        </p:txBody>
+      </p:sp>
+      <p:sp>
+        <p:nvSpPr>
+          <p:cNvPr id="22" name="Bar 22"/>
+          <p:cNvSpPr/>
+          <p:nvPr/>
+        </p:nvSpPr>
+        <p:spPr>
+          <a:xfrm>
+            <a:off x="6219476" y="4610000"/>
+            <a:ext cx="73152" cy="830000"/>
+          </a:xfrm>
+          <a:prstGeom prst="rect">
+            <a:avLst/>
+          </a:prstGeom>
+          <a:solidFill>
+            <a:srgbClr val="8A94A6"/>
+          </a:solidFill>
+          <a:ln/>
+        </p:spPr>
+      </p:sp>
+      <p:sp>
+        <p:nvSpPr>
+          <p:cNvPr id="23" name="Text 23"/>
+          <p:cNvSpPr/>
+          <p:nvPr/>
+        </p:nvSpPr>
+        <p:spPr>
+          <a:xfrm>
+            <a:off x="6402356" y="4610000"/>
+            <a:ext cx="5283676" cy="830000"/>
+          </a:xfrm>
+          <a:prstGeom prst="rect">
+            <a:avLst/>
+          </a:prstGeom>
+          <a:noFill/>
+          <a:ln/>
+        </p:spPr>
+        <p:txBody>
+          <a:bodyPr wrap="square" rtlCol="0" anchor="t">
+            <a:normAutofit/>
+          </a:bodyPr>
+          <a:lstStyle/>
+          <a:p>
+            <a:pPr indent="0" marL="0">
+              <a:lnSpc>
+                <a:spcPct val="102000"/>
+              </a:lnSpc>
+              <a:spcAft>
+                <a:spcPts val="200"/>
+              </a:spcAft>
+              <a:buNone/>
+            </a:pPr>
+            <a:r>
+              <a:rPr lang="en-US" sz="1100" b="1" dirty="0">
+                <a:solidFill>
+                  <a:srgbClr val="004671"/>
+                </a:solidFill>
+                <a:latin typeface="Noto Sans" pitchFamily="34" charset="0"/>
+                <a:ea typeface="Noto Sans" pitchFamily="34" charset="-122"/>
+                <a:cs typeface="Noto Sans" pitchFamily="34" charset="-120"/>
+              </a:rPr>
+              <a:t>JTBD 7 — Trấn an sau thất bại trước đó</a:t>
+            </a:r>
+            <a:endParaRPr lang="en-US" sz="1100" dirty="0"/>
+          </a:p>
+          <a:p>
+            <a:pPr indent="0" marL="0">
+              <a:lnSpc>
+                <a:spcPct val="102000"/>
+              </a:lnSpc>
+              <a:spcAft>
+                <a:spcPts val="100"/>
+              </a:spcAft>
+              <a:buNone/>
+            </a:pPr>
+            <a:r>
+              <a:rPr lang="en-US" sz="950" dirty="0">
+                <a:solidFill>
+                  <a:srgbClr val="5B6472"/>
+                </a:solidFill>
+                <a:latin typeface="Noto Sans" pitchFamily="34" charset="0"/>
+                <a:ea typeface="Noto Sans" pitchFamily="34" charset="-122"/>
+                <a:cs typeface="Noto Sans" pitchFamily="34" charset="-120"/>
+              </a:rPr>
+              <a:t>Đã từng bỏ tiền cho giải pháp không hiệu quả → muốn bằng chứng/cam kết rõ ràng trước khi bỏ tiền lần nữa, để tin “lần này sẽ khác”.</a:t>
+            </a:r>
+            <a:endParaRPr lang="en-US" sz="950" dirty="0"/>
+          </a:p>
+        </p:txBody>
+      </p:sp>
+      <p:sp>
+        <p:nvSpPr>
+          <p:cNvPr id="24" name="Bar 24"/>
+          <p:cNvSpPr/>
+          <p:nvPr/>
+        </p:nvSpPr>
+        <p:spPr>
+          <a:xfrm>
+            <a:off x="6219476" y="5470000"/>
+            <a:ext cx="73152" cy="830000"/>
+          </a:xfrm>
+          <a:prstGeom prst="rect">
+            <a:avLst/>
+          </a:prstGeom>
+          <a:solidFill>
+            <a:srgbClr val="8A94A6"/>
+          </a:solidFill>
+          <a:ln/>
+        </p:spPr>
+      </p:sp>
+      <p:sp>
+        <p:nvSpPr>
+          <p:cNvPr id="25" name="Text 25"/>
+          <p:cNvSpPr/>
+          <p:nvPr/>
+        </p:nvSpPr>
+        <p:spPr>
+          <a:xfrm>
+            <a:off x="6402356" y="5470000"/>
+            <a:ext cx="5283676" cy="830000"/>
+          </a:xfrm>
+          <a:prstGeom prst="rect">
+            <a:avLst/>
+          </a:prstGeom>
+          <a:noFill/>
+          <a:ln/>
+        </p:spPr>
+        <p:txBody>
+          <a:bodyPr wrap="square" rtlCol="0" anchor="t">
+            <a:normAutofit/>
+          </a:bodyPr>
+          <a:lstStyle/>
+          <a:p>
+            <a:pPr indent="0" marL="0">
+              <a:lnSpc>
+                <a:spcPct val="102000"/>
+              </a:lnSpc>
+              <a:spcAft>
+                <a:spcPts val="200"/>
+              </a:spcAft>
+              <a:buNone/>
+            </a:pPr>
+            <a:r>
+              <a:rPr lang="en-US" sz="1100" b="1" dirty="0">
+                <a:solidFill>
+                  <a:srgbClr val="004671"/>
+                </a:solidFill>
+                <a:latin typeface="Noto Sans" pitchFamily="34" charset="0"/>
+                <a:ea typeface="Noto Sans" pitchFamily="34" charset="-122"/>
+                <a:cs typeface="Noto Sans" pitchFamily="34" charset="-120"/>
+              </a:rPr>
+              <a:t>JTBD 8 — Không thua kém “con nhà người ta”</a:t>
+            </a:r>
+            <a:endParaRPr lang="en-US" sz="1100" dirty="0"/>
+          </a:p>
+          <a:p>
+            <a:pPr indent="0" marL="0">
+              <a:lnSpc>
+                <a:spcPct val="102000"/>
+              </a:lnSpc>
+              <a:spcAft>
+                <a:spcPts val="100"/>
+              </a:spcAft>
+              <a:buNone/>
+            </a:pPr>
+            <a:r>
+              <a:rPr lang="en-US" sz="950" dirty="0">
+                <a:solidFill>
+                  <a:srgbClr val="5B6472"/>
+                </a:solidFill>
+                <a:latin typeface="Noto Sans" pitchFamily="34" charset="0"/>
+                <a:ea typeface="Noto Sans" pitchFamily="34" charset="-122"/>
+                <a:cs typeface="Noto Sans" pitchFamily="34" charset="-120"/>
+              </a:rPr>
+              <a:t>Nghe hàng xóm/bạn bè khoe con đạt chứng chỉ hay đỗ trường tốt → muốn con mình có thành tích tương đương hoặc hơn để tự tin khi so sánh.</a:t>
+            </a:r>
+            <a:endParaRPr lang="en-US" sz="950" dirty="0"/>
+          </a:p>
+        </p:txBody>
+      </p:sp>
+      <p:pic>
+        <p:nvPicPr>
+          <p:cNvPr id="26" name="Image 1"/>
+          <p:cNvPicPr>
+            <a:picLocks noChangeAspect="1"/>
+          </p:cNvPicPr>
+          <p:nvPr/>
+        </p:nvPicPr>
+        <p:blipFill>
+          <a:blip r:embed="rId2"/>
+          <a:stretch>
+            <a:fillRect/>
+          </a:stretch>
+        </p:blipFill>
+        <p:spPr>
+          <a:xfrm>
+            <a:off x="502920" y="6473952"/>
+            <a:ext cx="237744" cy="237744"/>
+          </a:xfrm>
+          <a:prstGeom prst="rect">
+            <a:avLst/>
+          </a:prstGeom>
+        </p:spPr>
+      </p:pic>
+      <p:sp>
+        <p:nvSpPr>
+          <p:cNvPr id="27" name="Text 12"/>
+          <p:cNvSpPr/>
+          <p:nvPr/>
+        </p:nvSpPr>
+        <p:spPr>
+          <a:xfrm>
+            <a:off x="795528" y="6473952"/>
+            <a:ext cx="3657600" cy="256032"/>
+          </a:xfrm>
+          <a:prstGeom prst="rect">
+            <a:avLst/>
+          </a:prstGeom>
+          <a:noFill/>
+          <a:ln/>
+        </p:spPr>
+        <p:txBody>
+          <a:bodyPr wrap="square" rtlCol="0" anchor="ctr"/>
+          <a:lstStyle/>
+          <a:p>
+            <a:pPr indent="0" marL="0">
+              <a:lnSpc>
+                <a:spcPct val="102000"/>
+              </a:lnSpc>
+              <a:spcAft>
+                <a:spcPts val="0"/>
+              </a:spcAft>
+              <a:buNone/>
+            </a:pPr>
+            <a:r>
+              <a:rPr lang="en-US" sz="800" dirty="0">
+                <a:solidFill>
+                  <a:srgbClr val="5B6472"/>
+                </a:solidFill>
+                <a:latin typeface="Noto Sans" pitchFamily="34" charset="0"/>
+                <a:ea typeface="Noto Sans" pitchFamily="34" charset="-122"/>
+                <a:cs typeface="Noto Sans" pitchFamily="34" charset="-120"/>
+              </a:rPr>
+              <a:t>EDUPIA  AI CLASS NEW</a:t>
+            </a:r>
+            <a:endParaRPr lang="en-US" sz="800" dirty="0"/>
+          </a:p>
+        </p:txBody>
+      </p:sp>
+      <p:sp>
+        <p:nvSpPr>
+          <p:cNvPr id="28" name="Text 13"/>
+          <p:cNvSpPr/>
+          <p:nvPr/>
+        </p:nvSpPr>
+        <p:spPr>
+          <a:xfrm>
+            <a:off x="10789920" y="6473952"/>
+            <a:ext cx="914400" cy="256032"/>
+          </a:xfrm>
+          <a:prstGeom prst="rect">
+            <a:avLst/>
+          </a:prstGeom>
+          <a:noFill/>
+          <a:ln/>
+        </p:spPr>
+        <p:txBody>
+          <a:bodyPr wrap="square" rtlCol="0" anchor="ctr"/>
+          <a:lstStyle/>
+          <a:p>
+            <a:pPr algn="r" indent="0" marL="0">
+              <a:buNone/>
+            </a:pPr>
+            <a:r>
+              <a:rPr lang="en-US" sz="850" dirty="0">
+                <a:solidFill>
+                  <a:srgbClr val="5B6472"/>
+                </a:solidFill>
+                <a:latin typeface="Noto Sans" pitchFamily="34" charset="0"/>
+                <a:ea typeface="Noto Sans" pitchFamily="34" charset="-122"/>
+                <a:cs typeface="Noto Sans" pitchFamily="34" charset="-120"/>
+              </a:rPr>
+              <a:t>PHỤ LỤC</a:t>
+            </a:r>
+            <a:endParaRPr lang="en-US" sz="850" dirty="0"/>
+          </a:p>
+        </p:txBody>
+      </p:sp>
+    </p:spTree>
+  </p:cSld>
+  <p:clrMapOvr>
+    <a:masterClrMapping/>
+  </p:clrMapOvr>
+</p:sld>
+</file>
+
 <file path=ppt/slides/slide2.xml><?xml version="1.0" encoding="utf-8"?>
 <p:sld xmlns:a="http://schemas.openxmlformats.org/drawingml/2006/main" xmlns:r="http://schemas.openxmlformats.org/officeDocument/2006/relationships" xmlns:p="http://schemas.openxmlformats.org/presentationml/2006/main">
   <p:cSld name="Slide 2">

</xml_diff>